<commit_message>
fig: redesign Figure 1 overview — four self-titled C1-C4 cards (arc)
Replace the pipeline-badge overlay (cryptic "C4" tag that covered the PaddleOCR
label and conveyed nothing) with the paper's actual narrative arc:
PROBLEM (C1) → DIAGNOSE (C2) → SELECT (C3) → IMPROVE (C4). Each contribution is
now a self-titled card (verb + name + one-line description + headline stat), so
every Cn reads on its own. The RAG pipeline + model logos drop to a thin grey
context ribbon on top ("the document-RAG pipeline we study"). No badges, no
bottom band. Calibri. Regenerated by scripts/figures/make_overview_pptx.py.
</commit_message>
<xml_diff>
--- a/paper/figures/fig1_overview.pptx
+++ b/paper/figures/fig1_overview.pptx
@@ -7,7 +7,7 @@
   <p:sldIdLst>
     <p:sldId id="256" r:id="rId7"/>
   </p:sldIdLst>
-  <p:sldSz cx="10332720" cy="3931920" type="screen4x3"/>
+  <p:sldSz cx="10332720" cy="3310128" type="screen4x3"/>
   <p:notesSz cx="6858000" cy="9144000"/>
   <p:defaultTextStyle>
     <a:defPPr>
@@ -3096,19 +3096,21 @@
         </p:nvSpPr>
         <p:spPr>
           <a:xfrm>
-            <a:off x="182880" y="146304"/>
-            <a:ext cx="1691640" cy="310896"/>
+            <a:off x="182880" y="128016"/>
+            <a:ext cx="1773936" cy="676656"/>
           </a:xfrm>
           <a:prstGeom prst="roundRect">
             <a:avLst>
-              <a:gd name="adj" fmla="val 18000"/>
+              <a:gd name="adj" fmla="val 10000"/>
             </a:avLst>
           </a:prstGeom>
           <a:solidFill>
-            <a:srgbClr val="37474F"/>
+            <a:srgbClr val="F4F6F7"/>
           </a:solidFill>
-          <a:ln>
-            <a:noFill/>
+          <a:ln w="11430">
+            <a:solidFill>
+              <a:srgbClr val="CFD8DC"/>
+            </a:solidFill>
           </a:ln>
           <a:effectLst/>
         </p:spPr>
@@ -3127,7 +3129,31 @@
           </a:fontRef>
         </p:style>
         <p:txBody>
-          <a:bodyPr rtlCol="0" anchor="ctr" wrap="square" lIns="18288" rIns="18288" tIns="18288" bIns="18288">
+          <a:bodyPr rtlCol="0" anchor="ctr"/>
+          <a:lstStyle/>
+          <a:p>
+            <a:pPr algn="ctr"/>
+          </a:p>
+        </p:txBody>
+      </p:sp>
+      <p:sp>
+        <p:nvSpPr>
+          <p:cNvPr id="3" name="TextBox 2"/>
+          <p:cNvSpPr txBox="1"/>
+          <p:nvPr/>
+        </p:nvSpPr>
+        <p:spPr>
+          <a:xfrm>
+            <a:off x="182880" y="164592"/>
+            <a:ext cx="1773936" cy="164592"/>
+          </a:xfrm>
+          <a:prstGeom prst="rect">
+            <a:avLst/>
+          </a:prstGeom>
+          <a:noFill/>
+        </p:spPr>
+        <p:txBody>
+          <a:bodyPr wrap="square" anchor="ctr" lIns="18288" rIns="18288" tIns="18288" bIns="18288">
             <a:noAutofit/>
           </a:bodyPr>
           <a:lstStyle/>
@@ -3141,9 +3167,9 @@
               </a:spcAft>
             </a:pPr>
             <a:r>
-              <a:rPr sz="1250" b="1">
+              <a:rPr sz="900" b="1">
                 <a:solidFill>
-                  <a:srgbClr val="FFFFFF"/>
+                  <a:srgbClr val="546E7A"/>
                 </a:solidFill>
                 <a:latin typeface="Calibri"/>
               </a:rPr>
@@ -3154,25 +3180,27 @@
       </p:sp>
       <p:sp>
         <p:nvSpPr>
-          <p:cNvPr id="3" name="Rounded Rectangle 2"/>
+          <p:cNvPr id="4" name="Rounded Rectangle 3"/>
           <p:cNvSpPr/>
           <p:nvPr/>
         </p:nvSpPr>
         <p:spPr>
           <a:xfrm>
-            <a:off x="2240280" y="146304"/>
-            <a:ext cx="1691640" cy="310896"/>
+            <a:off x="2231136" y="128016"/>
+            <a:ext cx="1773936" cy="676656"/>
           </a:xfrm>
           <a:prstGeom prst="roundRect">
             <a:avLst>
-              <a:gd name="adj" fmla="val 18000"/>
+              <a:gd name="adj" fmla="val 10000"/>
             </a:avLst>
           </a:prstGeom>
           <a:solidFill>
-            <a:srgbClr val="37474F"/>
+            <a:srgbClr val="F4F6F7"/>
           </a:solidFill>
-          <a:ln>
-            <a:noFill/>
+          <a:ln w="11430">
+            <a:solidFill>
+              <a:srgbClr val="CFD8DC"/>
+            </a:solidFill>
           </a:ln>
           <a:effectLst/>
         </p:spPr>
@@ -3191,7 +3219,31 @@
           </a:fontRef>
         </p:style>
         <p:txBody>
-          <a:bodyPr rtlCol="0" anchor="ctr" wrap="square" lIns="18288" rIns="18288" tIns="18288" bIns="18288">
+          <a:bodyPr rtlCol="0" anchor="ctr"/>
+          <a:lstStyle/>
+          <a:p>
+            <a:pPr algn="ctr"/>
+          </a:p>
+        </p:txBody>
+      </p:sp>
+      <p:sp>
+        <p:nvSpPr>
+          <p:cNvPr id="5" name="TextBox 4"/>
+          <p:cNvSpPr txBox="1"/>
+          <p:nvPr/>
+        </p:nvSpPr>
+        <p:spPr>
+          <a:xfrm>
+            <a:off x="2231136" y="164592"/>
+            <a:ext cx="1773936" cy="164592"/>
+          </a:xfrm>
+          <a:prstGeom prst="rect">
+            <a:avLst/>
+          </a:prstGeom>
+          <a:noFill/>
+        </p:spPr>
+        <p:txBody>
+          <a:bodyPr wrap="square" anchor="ctr" lIns="18288" rIns="18288" tIns="18288" bIns="18288">
             <a:noAutofit/>
           </a:bodyPr>
           <a:lstStyle/>
@@ -3205,9 +3257,9 @@
               </a:spcAft>
             </a:pPr>
             <a:r>
-              <a:rPr sz="1250" b="1">
+              <a:rPr sz="900" b="1">
                 <a:solidFill>
-                  <a:srgbClr val="FFFFFF"/>
+                  <a:srgbClr val="546E7A"/>
                 </a:solidFill>
                 <a:latin typeface="Calibri"/>
               </a:rPr>
@@ -3218,25 +3270,27 @@
       </p:sp>
       <p:sp>
         <p:nvSpPr>
-          <p:cNvPr id="4" name="Rounded Rectangle 3"/>
+          <p:cNvPr id="6" name="Rounded Rectangle 5"/>
           <p:cNvSpPr/>
           <p:nvPr/>
         </p:nvSpPr>
         <p:spPr>
           <a:xfrm>
-            <a:off x="4297680" y="146304"/>
-            <a:ext cx="1691640" cy="310896"/>
+            <a:off x="4279392" y="128016"/>
+            <a:ext cx="1773936" cy="676656"/>
           </a:xfrm>
           <a:prstGeom prst="roundRect">
             <a:avLst>
-              <a:gd name="adj" fmla="val 18000"/>
+              <a:gd name="adj" fmla="val 10000"/>
             </a:avLst>
           </a:prstGeom>
           <a:solidFill>
-            <a:srgbClr val="37474F"/>
+            <a:srgbClr val="F4F6F7"/>
           </a:solidFill>
-          <a:ln>
-            <a:noFill/>
+          <a:ln w="11430">
+            <a:solidFill>
+              <a:srgbClr val="CFD8DC"/>
+            </a:solidFill>
           </a:ln>
           <a:effectLst/>
         </p:spPr>
@@ -3255,7 +3309,31 @@
           </a:fontRef>
         </p:style>
         <p:txBody>
-          <a:bodyPr rtlCol="0" anchor="ctr" wrap="square" lIns="18288" rIns="18288" tIns="18288" bIns="18288">
+          <a:bodyPr rtlCol="0" anchor="ctr"/>
+          <a:lstStyle/>
+          <a:p>
+            <a:pPr algn="ctr"/>
+          </a:p>
+        </p:txBody>
+      </p:sp>
+      <p:sp>
+        <p:nvSpPr>
+          <p:cNvPr id="7" name="TextBox 6"/>
+          <p:cNvSpPr txBox="1"/>
+          <p:nvPr/>
+        </p:nvSpPr>
+        <p:spPr>
+          <a:xfrm>
+            <a:off x="4279392" y="164592"/>
+            <a:ext cx="1773936" cy="164592"/>
+          </a:xfrm>
+          <a:prstGeom prst="rect">
+            <a:avLst/>
+          </a:prstGeom>
+          <a:noFill/>
+        </p:spPr>
+        <p:txBody>
+          <a:bodyPr wrap="square" anchor="ctr" lIns="18288" rIns="18288" tIns="18288" bIns="18288">
             <a:noAutofit/>
           </a:bodyPr>
           <a:lstStyle/>
@@ -3269,9 +3347,9 @@
               </a:spcAft>
             </a:pPr>
             <a:r>
-              <a:rPr sz="1250" b="1">
+              <a:rPr sz="900" b="1">
                 <a:solidFill>
-                  <a:srgbClr val="FFFFFF"/>
+                  <a:srgbClr val="546E7A"/>
                 </a:solidFill>
                 <a:latin typeface="Calibri"/>
               </a:rPr>
@@ -3282,25 +3360,27 @@
       </p:sp>
       <p:sp>
         <p:nvSpPr>
-          <p:cNvPr id="5" name="Rounded Rectangle 4"/>
+          <p:cNvPr id="8" name="Rounded Rectangle 7"/>
           <p:cNvSpPr/>
           <p:nvPr/>
         </p:nvSpPr>
         <p:spPr>
           <a:xfrm>
-            <a:off x="6355080" y="146304"/>
-            <a:ext cx="1691640" cy="310896"/>
+            <a:off x="6327648" y="128016"/>
+            <a:ext cx="1773936" cy="676656"/>
           </a:xfrm>
           <a:prstGeom prst="roundRect">
             <a:avLst>
-              <a:gd name="adj" fmla="val 18000"/>
+              <a:gd name="adj" fmla="val 10000"/>
             </a:avLst>
           </a:prstGeom>
           <a:solidFill>
-            <a:srgbClr val="37474F"/>
+            <a:srgbClr val="F4F6F7"/>
           </a:solidFill>
-          <a:ln>
-            <a:noFill/>
+          <a:ln w="11430">
+            <a:solidFill>
+              <a:srgbClr val="CFD8DC"/>
+            </a:solidFill>
           </a:ln>
           <a:effectLst/>
         </p:spPr>
@@ -3319,7 +3399,31 @@
           </a:fontRef>
         </p:style>
         <p:txBody>
-          <a:bodyPr rtlCol="0" anchor="ctr" wrap="square" lIns="18288" rIns="18288" tIns="18288" bIns="18288">
+          <a:bodyPr rtlCol="0" anchor="ctr"/>
+          <a:lstStyle/>
+          <a:p>
+            <a:pPr algn="ctr"/>
+          </a:p>
+        </p:txBody>
+      </p:sp>
+      <p:sp>
+        <p:nvSpPr>
+          <p:cNvPr id="9" name="TextBox 8"/>
+          <p:cNvSpPr txBox="1"/>
+          <p:nvPr/>
+        </p:nvSpPr>
+        <p:spPr>
+          <a:xfrm>
+            <a:off x="6327648" y="164592"/>
+            <a:ext cx="1773936" cy="164592"/>
+          </a:xfrm>
+          <a:prstGeom prst="rect">
+            <a:avLst/>
+          </a:prstGeom>
+          <a:noFill/>
+        </p:spPr>
+        <p:txBody>
+          <a:bodyPr wrap="square" anchor="ctr" lIns="18288" rIns="18288" tIns="18288" bIns="18288">
             <a:noAutofit/>
           </a:bodyPr>
           <a:lstStyle/>
@@ -3333,9 +3437,9 @@
               </a:spcAft>
             </a:pPr>
             <a:r>
-              <a:rPr sz="1250" b="1">
+              <a:rPr sz="900" b="1">
                 <a:solidFill>
-                  <a:srgbClr val="FFFFFF"/>
+                  <a:srgbClr val="546E7A"/>
                 </a:solidFill>
                 <a:latin typeface="Calibri"/>
               </a:rPr>
@@ -3346,25 +3450,27 @@
       </p:sp>
       <p:sp>
         <p:nvSpPr>
-          <p:cNvPr id="6" name="Rounded Rectangle 5"/>
+          <p:cNvPr id="10" name="Rounded Rectangle 9"/>
           <p:cNvSpPr/>
           <p:nvPr/>
         </p:nvSpPr>
         <p:spPr>
           <a:xfrm>
-            <a:off x="8412480" y="146304"/>
-            <a:ext cx="1691640" cy="310896"/>
+            <a:off x="8375904" y="128016"/>
+            <a:ext cx="1773936" cy="676656"/>
           </a:xfrm>
           <a:prstGeom prst="roundRect">
             <a:avLst>
-              <a:gd name="adj" fmla="val 18000"/>
+              <a:gd name="adj" fmla="val 10000"/>
             </a:avLst>
           </a:prstGeom>
           <a:solidFill>
-            <a:srgbClr val="37474F"/>
+            <a:srgbClr val="F4F6F7"/>
           </a:solidFill>
-          <a:ln>
-            <a:noFill/>
+          <a:ln w="11430">
+            <a:solidFill>
+              <a:srgbClr val="CFD8DC"/>
+            </a:solidFill>
           </a:ln>
           <a:effectLst/>
         </p:spPr>
@@ -3383,7 +3489,31 @@
           </a:fontRef>
         </p:style>
         <p:txBody>
-          <a:bodyPr rtlCol="0" anchor="ctr" wrap="square" lIns="18288" rIns="18288" tIns="18288" bIns="18288">
+          <a:bodyPr rtlCol="0" anchor="ctr"/>
+          <a:lstStyle/>
+          <a:p>
+            <a:pPr algn="ctr"/>
+          </a:p>
+        </p:txBody>
+      </p:sp>
+      <p:sp>
+        <p:nvSpPr>
+          <p:cNvPr id="11" name="TextBox 10"/>
+          <p:cNvSpPr txBox="1"/>
+          <p:nvPr/>
+        </p:nvSpPr>
+        <p:spPr>
+          <a:xfrm>
+            <a:off x="8375904" y="164592"/>
+            <a:ext cx="1773936" cy="164592"/>
+          </a:xfrm>
+          <a:prstGeom prst="rect">
+            <a:avLst/>
+          </a:prstGeom>
+          <a:noFill/>
+        </p:spPr>
+        <p:txBody>
+          <a:bodyPr wrap="square" anchor="ctr" lIns="18288" rIns="18288" tIns="18288" bIns="18288">
             <a:noAutofit/>
           </a:bodyPr>
           <a:lstStyle/>
@@ -3397,9 +3527,9 @@
               </a:spcAft>
             </a:pPr>
             <a:r>
-              <a:rPr sz="1250" b="1">
+              <a:rPr sz="900" b="1">
                 <a:solidFill>
-                  <a:srgbClr val="FFFFFF"/>
+                  <a:srgbClr val="546E7A"/>
                 </a:solidFill>
                 <a:latin typeface="Calibri"/>
               </a:rPr>
@@ -3408,57 +3538,9 @@
           </a:p>
         </p:txBody>
       </p:sp>
-      <p:sp>
-        <p:nvSpPr>
-          <p:cNvPr id="7" name="Rounded Rectangle 6"/>
-          <p:cNvSpPr/>
-          <p:nvPr/>
-        </p:nvSpPr>
-        <p:spPr>
-          <a:xfrm>
-            <a:off x="182880" y="548640"/>
-            <a:ext cx="1691640" cy="1335024"/>
-          </a:xfrm>
-          <a:prstGeom prst="roundRect">
-            <a:avLst>
-              <a:gd name="adj" fmla="val 6000"/>
-            </a:avLst>
-          </a:prstGeom>
-          <a:solidFill>
-            <a:srgbClr val="FFFFFF"/>
-          </a:solidFill>
-          <a:ln w="13970">
-            <a:solidFill>
-              <a:srgbClr val="B0BEC5"/>
-            </a:solidFill>
-          </a:ln>
-          <a:effectLst/>
-        </p:spPr>
-        <p:style>
-          <a:lnRef idx="1">
-            <a:schemeClr val="accent1"/>
-          </a:lnRef>
-          <a:fillRef idx="3">
-            <a:schemeClr val="accent1"/>
-          </a:fillRef>
-          <a:effectRef idx="2">
-            <a:schemeClr val="accent1"/>
-          </a:effectRef>
-          <a:fontRef idx="minor">
-            <a:schemeClr val="lt1"/>
-          </a:fontRef>
-        </p:style>
-        <p:txBody>
-          <a:bodyPr rtlCol="0" anchor="ctr"/>
-          <a:lstStyle/>
-          <a:p>
-            <a:pPr algn="ctr"/>
-          </a:p>
-        </p:txBody>
-      </p:sp>
       <p:pic>
         <p:nvPicPr>
-          <p:cNvPr id="8" name="Picture 7" descr="document.png"/>
+          <p:cNvPr id="12" name="Picture 11" descr="document.png"/>
           <p:cNvPicPr>
             <a:picLocks noChangeAspect="1"/>
           </p:cNvPicPr>
@@ -3472,126 +3554,17 @@
         </p:blipFill>
         <p:spPr>
           <a:xfrm>
-            <a:off x="772668" y="694944"/>
-            <a:ext cx="512064" cy="512064"/>
+            <a:off x="923544" y="365760"/>
+            <a:ext cx="292608" cy="292608"/>
           </a:xfrm>
           <a:prstGeom prst="rect">
             <a:avLst/>
           </a:prstGeom>
         </p:spPr>
       </p:pic>
-      <p:sp>
-        <p:nvSpPr>
-          <p:cNvPr id="9" name="TextBox 8"/>
-          <p:cNvSpPr txBox="1"/>
-          <p:nvPr/>
-        </p:nvSpPr>
-        <p:spPr>
-          <a:xfrm>
-            <a:off x="182880" y="1426464"/>
-            <a:ext cx="1691640" cy="420624"/>
-          </a:xfrm>
-          <a:prstGeom prst="rect">
-            <a:avLst/>
-          </a:prstGeom>
-          <a:noFill/>
-        </p:spPr>
-        <p:txBody>
-          <a:bodyPr wrap="square" anchor="t" lIns="45720" rIns="45720" tIns="36576" bIns="36576">
-            <a:noAutofit/>
-          </a:bodyPr>
-          <a:lstStyle/>
-          <a:p>
-            <a:pPr algn="ctr">
-              <a:spcBef>
-                <a:spcPts val="0"/>
-              </a:spcBef>
-              <a:spcAft>
-                <a:spcPts val="100"/>
-              </a:spcAft>
-            </a:pPr>
-            <a:r>
-              <a:rPr sz="1100" b="1">
-                <a:solidFill>
-                  <a:srgbClr val="1F3247"/>
-                </a:solidFill>
-                <a:latin typeface="Calibri"/>
-              </a:rPr>
-              <a:t>Korean gov doc</a:t>
-            </a:r>
-          </a:p>
-          <a:p>
-            <a:pPr algn="ctr">
-              <a:spcBef>
-                <a:spcPts val="0"/>
-              </a:spcBef>
-              <a:spcAft>
-                <a:spcPts val="400"/>
-              </a:spcAft>
-            </a:pPr>
-            <a:r>
-              <a:rPr sz="850" b="0">
-                <a:solidFill>
-                  <a:srgbClr val="546E7A"/>
-                </a:solidFill>
-                <a:latin typeface="Calibri"/>
-              </a:rPr>
-              <a:t>PDF / scanned page</a:t>
-            </a:r>
-          </a:p>
-        </p:txBody>
-      </p:sp>
-      <p:sp>
-        <p:nvSpPr>
-          <p:cNvPr id="10" name="Rounded Rectangle 9"/>
-          <p:cNvSpPr/>
-          <p:nvPr/>
-        </p:nvSpPr>
-        <p:spPr>
-          <a:xfrm>
-            <a:off x="4297680" y="548640"/>
-            <a:ext cx="1691640" cy="1335024"/>
-          </a:xfrm>
-          <a:prstGeom prst="roundRect">
-            <a:avLst>
-              <a:gd name="adj" fmla="val 6000"/>
-            </a:avLst>
-          </a:prstGeom>
-          <a:solidFill>
-            <a:srgbClr val="FFFFFF"/>
-          </a:solidFill>
-          <a:ln w="13970">
-            <a:solidFill>
-              <a:srgbClr val="B0BEC5"/>
-            </a:solidFill>
-          </a:ln>
-          <a:effectLst/>
-        </p:spPr>
-        <p:style>
-          <a:lnRef idx="1">
-            <a:schemeClr val="accent1"/>
-          </a:lnRef>
-          <a:fillRef idx="3">
-            <a:schemeClr val="accent1"/>
-          </a:fillRef>
-          <a:effectRef idx="2">
-            <a:schemeClr val="accent1"/>
-          </a:effectRef>
-          <a:fontRef idx="minor">
-            <a:schemeClr val="lt1"/>
-          </a:fontRef>
-        </p:style>
-        <p:txBody>
-          <a:bodyPr rtlCol="0" anchor="ctr"/>
-          <a:lstStyle/>
-          <a:p>
-            <a:pPr algn="ctr"/>
-          </a:p>
-        </p:txBody>
-      </p:sp>
       <p:pic>
         <p:nvPicPr>
-          <p:cNvPr id="11" name="Picture 10" descr="chunk.png"/>
+          <p:cNvPr id="13" name="Picture 12" descr="qwen.png"/>
           <p:cNvPicPr>
             <a:picLocks noChangeAspect="1"/>
           </p:cNvPicPr>
@@ -3605,126 +3578,17 @@
         </p:blipFill>
         <p:spPr>
           <a:xfrm>
-            <a:off x="4887468" y="694944"/>
-            <a:ext cx="512064" cy="512064"/>
+            <a:off x="2473452" y="420623"/>
+            <a:ext cx="274320" cy="274320"/>
           </a:xfrm>
           <a:prstGeom prst="rect">
             <a:avLst/>
           </a:prstGeom>
         </p:spPr>
       </p:pic>
-      <p:sp>
-        <p:nvSpPr>
-          <p:cNvPr id="12" name="TextBox 11"/>
-          <p:cNvSpPr txBox="1"/>
-          <p:nvPr/>
-        </p:nvSpPr>
-        <p:spPr>
-          <a:xfrm>
-            <a:off x="4297680" y="1426464"/>
-            <a:ext cx="1691640" cy="420624"/>
-          </a:xfrm>
-          <a:prstGeom prst="rect">
-            <a:avLst/>
-          </a:prstGeom>
-          <a:noFill/>
-        </p:spPr>
-        <p:txBody>
-          <a:bodyPr wrap="square" anchor="t" lIns="45720" rIns="45720" tIns="36576" bIns="36576">
-            <a:noAutofit/>
-          </a:bodyPr>
-          <a:lstStyle/>
-          <a:p>
-            <a:pPr algn="ctr">
-              <a:spcBef>
-                <a:spcPts val="0"/>
-              </a:spcBef>
-              <a:spcAft>
-                <a:spcPts val="100"/>
-              </a:spcAft>
-            </a:pPr>
-            <a:r>
-              <a:rPr sz="1100" b="1">
-                <a:solidFill>
-                  <a:srgbClr val="1F3247"/>
-                </a:solidFill>
-                <a:latin typeface="Calibri"/>
-              </a:rPr>
-              <a:t>Chunker</a:t>
-            </a:r>
-          </a:p>
-          <a:p>
-            <a:pPr algn="ctr">
-              <a:spcBef>
-                <a:spcPts val="0"/>
-              </a:spcBef>
-              <a:spcAft>
-                <a:spcPts val="400"/>
-              </a:spcAft>
-            </a:pPr>
-            <a:r>
-              <a:rPr sz="850" b="0">
-                <a:solidFill>
-                  <a:srgbClr val="546E7A"/>
-                </a:solidFill>
-                <a:latin typeface="Calibri"/>
-              </a:rPr>
-              <a:t>md-header · native · fixed</a:t>
-            </a:r>
-          </a:p>
-        </p:txBody>
-      </p:sp>
-      <p:sp>
-        <p:nvSpPr>
-          <p:cNvPr id="13" name="Rounded Rectangle 12"/>
-          <p:cNvSpPr/>
-          <p:nvPr/>
-        </p:nvSpPr>
-        <p:spPr>
-          <a:xfrm>
-            <a:off x="8412480" y="548640"/>
-            <a:ext cx="1691640" cy="1335024"/>
-          </a:xfrm>
-          <a:prstGeom prst="roundRect">
-            <a:avLst>
-              <a:gd name="adj" fmla="val 6000"/>
-            </a:avLst>
-          </a:prstGeom>
-          <a:solidFill>
-            <a:srgbClr val="FFFFFF"/>
-          </a:solidFill>
-          <a:ln w="13970">
-            <a:solidFill>
-              <a:srgbClr val="B0BEC5"/>
-            </a:solidFill>
-          </a:ln>
-          <a:effectLst/>
-        </p:spPr>
-        <p:style>
-          <a:lnRef idx="1">
-            <a:schemeClr val="accent1"/>
-          </a:lnRef>
-          <a:fillRef idx="3">
-            <a:schemeClr val="accent1"/>
-          </a:fillRef>
-          <a:effectRef idx="2">
-            <a:schemeClr val="accent1"/>
-          </a:effectRef>
-          <a:fontRef idx="minor">
-            <a:schemeClr val="lt1"/>
-          </a:fontRef>
-        </p:style>
-        <p:txBody>
-          <a:bodyPr rtlCol="0" anchor="ctr"/>
-          <a:lstStyle/>
-          <a:p>
-            <a:pPr algn="ctr"/>
-          </a:p>
-        </p:txBody>
-      </p:sp>
       <p:pic>
         <p:nvPicPr>
-          <p:cNvPr id="14" name="Picture 13" descr="answer.png"/>
+          <p:cNvPr id="14" name="Picture 13" descr="mineru.png"/>
           <p:cNvPicPr>
             <a:picLocks noChangeAspect="1"/>
           </p:cNvPicPr>
@@ -3738,168 +3602,17 @@
         </p:blipFill>
         <p:spPr>
           <a:xfrm>
-            <a:off x="9002268" y="694944"/>
-            <a:ext cx="512064" cy="512064"/>
+            <a:off x="2811780" y="420623"/>
+            <a:ext cx="274320" cy="274320"/>
           </a:xfrm>
           <a:prstGeom prst="rect">
             <a:avLst/>
           </a:prstGeom>
         </p:spPr>
       </p:pic>
-      <p:sp>
-        <p:nvSpPr>
-          <p:cNvPr id="15" name="TextBox 14"/>
-          <p:cNvSpPr txBox="1"/>
-          <p:nvPr/>
-        </p:nvSpPr>
-        <p:spPr>
-          <a:xfrm>
-            <a:off x="8412480" y="1426464"/>
-            <a:ext cx="1691640" cy="420624"/>
-          </a:xfrm>
-          <a:prstGeom prst="rect">
-            <a:avLst/>
-          </a:prstGeom>
-          <a:noFill/>
-        </p:spPr>
-        <p:txBody>
-          <a:bodyPr wrap="square" anchor="t" lIns="45720" rIns="45720" tIns="36576" bIns="36576">
-            <a:noAutofit/>
-          </a:bodyPr>
-          <a:lstStyle/>
-          <a:p>
-            <a:pPr algn="ctr">
-              <a:spcBef>
-                <a:spcPts val="0"/>
-              </a:spcBef>
-              <a:spcAft>
-                <a:spcPts val="100"/>
-              </a:spcAft>
-            </a:pPr>
-            <a:r>
-              <a:rPr sz="1100" b="1">
-                <a:solidFill>
-                  <a:srgbClr val="1F3247"/>
-                </a:solidFill>
-                <a:latin typeface="Calibri"/>
-              </a:rPr>
-              <a:t>RAG answer</a:t>
-            </a:r>
-          </a:p>
-          <a:p>
-            <a:pPr algn="ctr">
-              <a:spcBef>
-                <a:spcPts val="0"/>
-              </a:spcBef>
-              <a:spcAft>
-                <a:spcPts val="400"/>
-              </a:spcAft>
-            </a:pPr>
-            <a:r>
-              <a:rPr sz="850" b="0">
-                <a:solidFill>
-                  <a:srgbClr val="546E7A"/>
-                </a:solidFill>
-                <a:latin typeface="Calibri"/>
-              </a:rPr>
-              <a:t>grounded generation</a:t>
-            </a:r>
-          </a:p>
-        </p:txBody>
-      </p:sp>
-      <p:sp>
-        <p:nvSpPr>
-          <p:cNvPr id="16" name="Rounded Rectangle 15"/>
-          <p:cNvSpPr/>
-          <p:nvPr/>
-        </p:nvSpPr>
-        <p:spPr>
-          <a:xfrm>
-            <a:off x="2240280" y="548640"/>
-            <a:ext cx="1691640" cy="1335024"/>
-          </a:xfrm>
-          <a:prstGeom prst="roundRect">
-            <a:avLst>
-              <a:gd name="adj" fmla="val 6000"/>
-            </a:avLst>
-          </a:prstGeom>
-          <a:solidFill>
-            <a:srgbClr val="FFFFFF"/>
-          </a:solidFill>
-          <a:ln w="13970">
-            <a:solidFill>
-              <a:srgbClr val="B0BEC5"/>
-            </a:solidFill>
-          </a:ln>
-          <a:effectLst/>
-        </p:spPr>
-        <p:style>
-          <a:lnRef idx="1">
-            <a:schemeClr val="accent1"/>
-          </a:lnRef>
-          <a:fillRef idx="3">
-            <a:schemeClr val="accent1"/>
-          </a:fillRef>
-          <a:effectRef idx="2">
-            <a:schemeClr val="accent1"/>
-          </a:effectRef>
-          <a:fontRef idx="minor">
-            <a:schemeClr val="lt1"/>
-          </a:fontRef>
-        </p:style>
-        <p:txBody>
-          <a:bodyPr rtlCol="0" anchor="ctr"/>
-          <a:lstStyle/>
-          <a:p>
-            <a:pPr algn="ctr"/>
-          </a:p>
-        </p:txBody>
-      </p:sp>
-      <p:sp>
-        <p:nvSpPr>
-          <p:cNvPr id="17" name="TextBox 16"/>
-          <p:cNvSpPr txBox="1"/>
-          <p:nvPr/>
-        </p:nvSpPr>
-        <p:spPr>
-          <a:xfrm>
-            <a:off x="2240280" y="594360"/>
-            <a:ext cx="1691640" cy="201168"/>
-          </a:xfrm>
-          <a:prstGeom prst="rect">
-            <a:avLst/>
-          </a:prstGeom>
-          <a:noFill/>
-        </p:spPr>
-        <p:txBody>
-          <a:bodyPr wrap="square" anchor="ctr" lIns="18288" rIns="18288" tIns="18288" bIns="18288">
-            <a:noAutofit/>
-          </a:bodyPr>
-          <a:lstStyle/>
-          <a:p>
-            <a:pPr algn="ctr">
-              <a:spcBef>
-                <a:spcPts val="0"/>
-              </a:spcBef>
-              <a:spcAft>
-                <a:spcPts val="400"/>
-              </a:spcAft>
-            </a:pPr>
-            <a:r>
-              <a:rPr sz="1000" b="1">
-                <a:solidFill>
-                  <a:srgbClr val="1F3247"/>
-                </a:solidFill>
-                <a:latin typeface="Calibri"/>
-              </a:rPr>
-              <a:t>Parsers</a:t>
-            </a:r>
-          </a:p>
-        </p:txBody>
-      </p:sp>
       <p:pic>
         <p:nvPicPr>
-          <p:cNvPr id="18" name="Picture 17" descr="qwen.png"/>
+          <p:cNvPr id="15" name="Picture 14" descr="paddle.png"/>
           <p:cNvPicPr>
             <a:picLocks noChangeAspect="1"/>
           </p:cNvPicPr>
@@ -3913,59 +3626,17 @@
         </p:blipFill>
         <p:spPr>
           <a:xfrm>
-            <a:off x="2551816" y="822959"/>
-            <a:ext cx="277611" cy="277611"/>
+            <a:off x="3150108" y="420623"/>
+            <a:ext cx="274320" cy="274320"/>
           </a:xfrm>
           <a:prstGeom prst="rect">
             <a:avLst/>
           </a:prstGeom>
         </p:spPr>
       </p:pic>
-      <p:sp>
-        <p:nvSpPr>
-          <p:cNvPr id="19" name="TextBox 18"/>
-          <p:cNvSpPr txBox="1"/>
-          <p:nvPr/>
-        </p:nvSpPr>
-        <p:spPr>
-          <a:xfrm>
-            <a:off x="2295144" y="1109715"/>
-            <a:ext cx="790956" cy="133868"/>
-          </a:xfrm>
-          <a:prstGeom prst="rect">
-            <a:avLst/>
-          </a:prstGeom>
-          <a:noFill/>
-        </p:spPr>
-        <p:txBody>
-          <a:bodyPr wrap="square" anchor="t" lIns="0" rIns="0" tIns="0" bIns="0">
-            <a:noAutofit/>
-          </a:bodyPr>
-          <a:lstStyle/>
-          <a:p>
-            <a:pPr algn="ctr">
-              <a:spcBef>
-                <a:spcPts val="0"/>
-              </a:spcBef>
-              <a:spcAft>
-                <a:spcPts val="400"/>
-              </a:spcAft>
-            </a:pPr>
-            <a:r>
-              <a:rPr sz="650" b="0">
-                <a:solidFill>
-                  <a:srgbClr val="546E7A"/>
-                </a:solidFill>
-                <a:latin typeface="Calibri"/>
-              </a:rPr>
-              <a:t>Qwen-VL</a:t>
-            </a:r>
-          </a:p>
-        </p:txBody>
-      </p:sp>
       <p:pic>
         <p:nvPicPr>
-          <p:cNvPr id="20" name="Picture 19" descr="mineru.png"/>
+          <p:cNvPr id="16" name="Picture 15" descr="marker.png"/>
           <p:cNvPicPr>
             <a:picLocks noChangeAspect="1"/>
           </p:cNvPicPr>
@@ -3979,59 +3650,17 @@
         </p:blipFill>
         <p:spPr>
           <a:xfrm>
-            <a:off x="3342772" y="822959"/>
-            <a:ext cx="277611" cy="277611"/>
+            <a:off x="3488436" y="420623"/>
+            <a:ext cx="274320" cy="274320"/>
           </a:xfrm>
           <a:prstGeom prst="rect">
             <a:avLst/>
           </a:prstGeom>
         </p:spPr>
       </p:pic>
-      <p:sp>
-        <p:nvSpPr>
-          <p:cNvPr id="21" name="TextBox 20"/>
-          <p:cNvSpPr txBox="1"/>
-          <p:nvPr/>
-        </p:nvSpPr>
-        <p:spPr>
-          <a:xfrm>
-            <a:off x="3086100" y="1109715"/>
-            <a:ext cx="790956" cy="133868"/>
-          </a:xfrm>
-          <a:prstGeom prst="rect">
-            <a:avLst/>
-          </a:prstGeom>
-          <a:noFill/>
-        </p:spPr>
-        <p:txBody>
-          <a:bodyPr wrap="square" anchor="t" lIns="0" rIns="0" tIns="0" bIns="0">
-            <a:noAutofit/>
-          </a:bodyPr>
-          <a:lstStyle/>
-          <a:p>
-            <a:pPr algn="ctr">
-              <a:spcBef>
-                <a:spcPts val="0"/>
-              </a:spcBef>
-              <a:spcAft>
-                <a:spcPts val="400"/>
-              </a:spcAft>
-            </a:pPr>
-            <a:r>
-              <a:rPr sz="650" b="0">
-                <a:solidFill>
-                  <a:srgbClr val="546E7A"/>
-                </a:solidFill>
-                <a:latin typeface="Calibri"/>
-              </a:rPr>
-              <a:t>MinerU</a:t>
-            </a:r>
-          </a:p>
-        </p:txBody>
-      </p:sp>
       <p:pic>
         <p:nvPicPr>
-          <p:cNvPr id="22" name="Picture 21" descr="paddle.png"/>
+          <p:cNvPr id="17" name="Picture 16" descr="chunk.png"/>
           <p:cNvPicPr>
             <a:picLocks noChangeAspect="1"/>
           </p:cNvPicPr>
@@ -4045,59 +3674,17 @@
         </p:blipFill>
         <p:spPr>
           <a:xfrm>
-            <a:off x="2551816" y="1243584"/>
-            <a:ext cx="277611" cy="277611"/>
+            <a:off x="5020056" y="365760"/>
+            <a:ext cx="292608" cy="292608"/>
           </a:xfrm>
           <a:prstGeom prst="rect">
             <a:avLst/>
           </a:prstGeom>
         </p:spPr>
       </p:pic>
-      <p:sp>
-        <p:nvSpPr>
-          <p:cNvPr id="23" name="TextBox 22"/>
-          <p:cNvSpPr txBox="1"/>
-          <p:nvPr/>
-        </p:nvSpPr>
-        <p:spPr>
-          <a:xfrm>
-            <a:off x="2295144" y="1530339"/>
-            <a:ext cx="790956" cy="133868"/>
-          </a:xfrm>
-          <a:prstGeom prst="rect">
-            <a:avLst/>
-          </a:prstGeom>
-          <a:noFill/>
-        </p:spPr>
-        <p:txBody>
-          <a:bodyPr wrap="square" anchor="t" lIns="0" rIns="0" tIns="0" bIns="0">
-            <a:noAutofit/>
-          </a:bodyPr>
-          <a:lstStyle/>
-          <a:p>
-            <a:pPr algn="ctr">
-              <a:spcBef>
-                <a:spcPts val="0"/>
-              </a:spcBef>
-              <a:spcAft>
-                <a:spcPts val="400"/>
-              </a:spcAft>
-            </a:pPr>
-            <a:r>
-              <a:rPr sz="650" b="0">
-                <a:solidFill>
-                  <a:srgbClr val="546E7A"/>
-                </a:solidFill>
-                <a:latin typeface="Calibri"/>
-              </a:rPr>
-              <a:t>PaddleOCR</a:t>
-            </a:r>
-          </a:p>
-        </p:txBody>
-      </p:sp>
       <p:pic>
         <p:nvPicPr>
-          <p:cNvPr id="24" name="Picture 23" descr="marker.png"/>
+          <p:cNvPr id="18" name="Picture 17" descr="bge.png"/>
           <p:cNvPicPr>
             <a:picLocks noChangeAspect="1"/>
           </p:cNvPicPr>
@@ -4111,257 +3698,17 @@
         </p:blipFill>
         <p:spPr>
           <a:xfrm>
-            <a:off x="3342772" y="1243584"/>
-            <a:ext cx="277611" cy="277611"/>
+            <a:off x="6711696" y="411479"/>
+            <a:ext cx="292608" cy="292608"/>
           </a:xfrm>
           <a:prstGeom prst="rect">
             <a:avLst/>
           </a:prstGeom>
         </p:spPr>
       </p:pic>
-      <p:sp>
-        <p:nvSpPr>
-          <p:cNvPr id="25" name="TextBox 24"/>
-          <p:cNvSpPr txBox="1"/>
-          <p:nvPr/>
-        </p:nvSpPr>
-        <p:spPr>
-          <a:xfrm>
-            <a:off x="3086100" y="1530339"/>
-            <a:ext cx="790956" cy="133868"/>
-          </a:xfrm>
-          <a:prstGeom prst="rect">
-            <a:avLst/>
-          </a:prstGeom>
-          <a:noFill/>
-        </p:spPr>
-        <p:txBody>
-          <a:bodyPr wrap="square" anchor="t" lIns="0" rIns="0" tIns="0" bIns="0">
-            <a:noAutofit/>
-          </a:bodyPr>
-          <a:lstStyle/>
-          <a:p>
-            <a:pPr algn="ctr">
-              <a:spcBef>
-                <a:spcPts val="0"/>
-              </a:spcBef>
-              <a:spcAft>
-                <a:spcPts val="400"/>
-              </a:spcAft>
-            </a:pPr>
-            <a:r>
-              <a:rPr sz="650" b="0">
-                <a:solidFill>
-                  <a:srgbClr val="546E7A"/>
-                </a:solidFill>
-                <a:latin typeface="Calibri"/>
-              </a:rPr>
-              <a:t>Marker</a:t>
-            </a:r>
-          </a:p>
-        </p:txBody>
-      </p:sp>
-      <p:sp>
-        <p:nvSpPr>
-          <p:cNvPr id="26" name="Rounded Rectangle 25"/>
-          <p:cNvSpPr/>
-          <p:nvPr/>
-        </p:nvSpPr>
-        <p:spPr>
-          <a:xfrm>
-            <a:off x="2551176" y="1609344"/>
-            <a:ext cx="347472" cy="192024"/>
-          </a:xfrm>
-          <a:prstGeom prst="roundRect">
-            <a:avLst>
-              <a:gd name="adj" fmla="val 50000"/>
-            </a:avLst>
-          </a:prstGeom>
-          <a:solidFill>
-            <a:srgbClr val="C62828"/>
-          </a:solidFill>
-          <a:ln w="13970">
-            <a:solidFill>
-              <a:srgbClr val="FFFFFF"/>
-            </a:solidFill>
-          </a:ln>
-          <a:effectLst/>
-        </p:spPr>
-        <p:style>
-          <a:lnRef idx="1">
-            <a:schemeClr val="accent1"/>
-          </a:lnRef>
-          <a:fillRef idx="3">
-            <a:schemeClr val="accent1"/>
-          </a:fillRef>
-          <a:effectRef idx="2">
-            <a:schemeClr val="accent1"/>
-          </a:effectRef>
-          <a:fontRef idx="minor">
-            <a:schemeClr val="lt1"/>
-          </a:fontRef>
-        </p:style>
-        <p:txBody>
-          <a:bodyPr rtlCol="0" anchor="ctr" wrap="square" lIns="0" rIns="0" tIns="0" bIns="0">
-            <a:noAutofit/>
-          </a:bodyPr>
-          <a:lstStyle/>
-          <a:p>
-            <a:pPr algn="ctr">
-              <a:spcBef>
-                <a:spcPts val="0"/>
-              </a:spcBef>
-              <a:spcAft>
-                <a:spcPts val="300"/>
-              </a:spcAft>
-            </a:pPr>
-            <a:r>
-              <a:rPr sz="900" b="1">
-                <a:solidFill>
-                  <a:srgbClr val="FFFFFF"/>
-                </a:solidFill>
-                <a:latin typeface="Calibri"/>
-              </a:rPr>
-              <a:t>C4</a:t>
-            </a:r>
-          </a:p>
-        </p:txBody>
-      </p:sp>
-      <p:sp>
-        <p:nvSpPr>
-          <p:cNvPr id="27" name="TextBox 26"/>
-          <p:cNvSpPr txBox="1"/>
-          <p:nvPr/>
-        </p:nvSpPr>
-        <p:spPr>
-          <a:xfrm>
-            <a:off x="2916936" y="1600200"/>
-            <a:ext cx="960120" cy="219456"/>
-          </a:xfrm>
-          <a:prstGeom prst="rect">
-            <a:avLst/>
-          </a:prstGeom>
-          <a:noFill/>
-        </p:spPr>
-        <p:txBody>
-          <a:bodyPr wrap="square" anchor="ctr" lIns="0" rIns="0" tIns="0" bIns="0">
-            <a:noAutofit/>
-          </a:bodyPr>
-          <a:lstStyle/>
-          <a:p>
-            <a:pPr algn="l">
-              <a:spcBef>
-                <a:spcPts val="0"/>
-              </a:spcBef>
-              <a:spcAft>
-                <a:spcPts val="400"/>
-              </a:spcAft>
-            </a:pPr>
-            <a:r>
-              <a:rPr sz="950" b="1">
-                <a:solidFill>
-                  <a:srgbClr val="00695C"/>
-                </a:solidFill>
-                <a:latin typeface="Calibri"/>
-              </a:rPr>
-              <a:t>→ Prod (2B)</a:t>
-            </a:r>
-          </a:p>
-        </p:txBody>
-      </p:sp>
-      <p:sp>
-        <p:nvSpPr>
-          <p:cNvPr id="28" name="Rounded Rectangle 27"/>
-          <p:cNvSpPr/>
-          <p:nvPr/>
-        </p:nvSpPr>
-        <p:spPr>
-          <a:xfrm>
-            <a:off x="6355080" y="548640"/>
-            <a:ext cx="1691640" cy="1335024"/>
-          </a:xfrm>
-          <a:prstGeom prst="roundRect">
-            <a:avLst>
-              <a:gd name="adj" fmla="val 6000"/>
-            </a:avLst>
-          </a:prstGeom>
-          <a:solidFill>
-            <a:srgbClr val="FFFFFF"/>
-          </a:solidFill>
-          <a:ln w="13970">
-            <a:solidFill>
-              <a:srgbClr val="B0BEC5"/>
-            </a:solidFill>
-          </a:ln>
-          <a:effectLst/>
-        </p:spPr>
-        <p:style>
-          <a:lnRef idx="1">
-            <a:schemeClr val="accent1"/>
-          </a:lnRef>
-          <a:fillRef idx="3">
-            <a:schemeClr val="accent1"/>
-          </a:fillRef>
-          <a:effectRef idx="2">
-            <a:schemeClr val="accent1"/>
-          </a:effectRef>
-          <a:fontRef idx="minor">
-            <a:schemeClr val="lt1"/>
-          </a:fontRef>
-        </p:style>
-        <p:txBody>
-          <a:bodyPr rtlCol="0" anchor="ctr"/>
-          <a:lstStyle/>
-          <a:p>
-            <a:pPr algn="ctr"/>
-          </a:p>
-        </p:txBody>
-      </p:sp>
-      <p:sp>
-        <p:nvSpPr>
-          <p:cNvPr id="29" name="TextBox 28"/>
-          <p:cNvSpPr txBox="1"/>
-          <p:nvPr/>
-        </p:nvSpPr>
-        <p:spPr>
-          <a:xfrm>
-            <a:off x="6355080" y="594360"/>
-            <a:ext cx="1691640" cy="201168"/>
-          </a:xfrm>
-          <a:prstGeom prst="rect">
-            <a:avLst/>
-          </a:prstGeom>
-          <a:noFill/>
-        </p:spPr>
-        <p:txBody>
-          <a:bodyPr wrap="square" anchor="ctr" lIns="18288" rIns="18288" tIns="18288" bIns="18288">
-            <a:noAutofit/>
-          </a:bodyPr>
-          <a:lstStyle/>
-          <a:p>
-            <a:pPr algn="ctr">
-              <a:spcBef>
-                <a:spcPts val="0"/>
-              </a:spcBef>
-              <a:spcAft>
-                <a:spcPts val="400"/>
-              </a:spcAft>
-            </a:pPr>
-            <a:r>
-              <a:rPr sz="1000" b="1">
-                <a:solidFill>
-                  <a:srgbClr val="1F3247"/>
-                </a:solidFill>
-                <a:latin typeface="Calibri"/>
-              </a:rPr>
-              <a:t>Retrievers ×3</a:t>
-            </a:r>
-          </a:p>
-        </p:txBody>
-      </p:sp>
       <p:pic>
         <p:nvPicPr>
-          <p:cNvPr id="30" name="Picture 29" descr="bge.png"/>
+          <p:cNvPr id="19" name="Picture 18" descr="me5.png"/>
           <p:cNvPicPr>
             <a:picLocks noChangeAspect="1"/>
           </p:cNvPicPr>
@@ -4375,59 +3722,41 @@
         </p:blipFill>
         <p:spPr>
           <a:xfrm>
-            <a:off x="6480413" y="859536"/>
-            <a:ext cx="374172" cy="374172"/>
+            <a:off x="7068312" y="411479"/>
+            <a:ext cx="292608" cy="292608"/>
           </a:xfrm>
           <a:prstGeom prst="rect">
             <a:avLst/>
           </a:prstGeom>
         </p:spPr>
       </p:pic>
-      <p:sp>
-        <p:nvSpPr>
-          <p:cNvPr id="31" name="TextBox 30"/>
-          <p:cNvSpPr txBox="1"/>
+      <p:pic>
+        <p:nvPicPr>
+          <p:cNvPr id="20" name="Picture 19" descr="qwen.png"/>
+          <p:cNvPicPr>
+            <a:picLocks noChangeAspect="1"/>
+          </p:cNvPicPr>
           <p:nvPr/>
-        </p:nvSpPr>
-        <p:spPr>
-          <a:xfrm>
-            <a:off x="6400800" y="1242852"/>
-            <a:ext cx="533400" cy="183611"/>
+        </p:nvPicPr>
+        <p:blipFill>
+          <a:blip r:embed="rId3"/>
+          <a:stretch>
+            <a:fillRect/>
+          </a:stretch>
+        </p:blipFill>
+        <p:spPr>
+          <a:xfrm>
+            <a:off x="7424928" y="411479"/>
+            <a:ext cx="292608" cy="292608"/>
           </a:xfrm>
           <a:prstGeom prst="rect">
             <a:avLst/>
           </a:prstGeom>
-          <a:noFill/>
-        </p:spPr>
-        <p:txBody>
-          <a:bodyPr wrap="square" anchor="t" lIns="0" rIns="0" tIns="0" bIns="0">
-            <a:noAutofit/>
-          </a:bodyPr>
-          <a:lstStyle/>
-          <a:p>
-            <a:pPr algn="ctr">
-              <a:spcBef>
-                <a:spcPts val="0"/>
-              </a:spcBef>
-              <a:spcAft>
-                <a:spcPts val="400"/>
-              </a:spcAft>
-            </a:pPr>
-            <a:r>
-              <a:rPr sz="650" b="0">
-                <a:solidFill>
-                  <a:srgbClr val="546E7A"/>
-                </a:solidFill>
-                <a:latin typeface="Calibri"/>
-              </a:rPr>
-              <a:t>BGE-M3</a:t>
-            </a:r>
-          </a:p>
-        </p:txBody>
-      </p:sp>
+        </p:spPr>
+      </p:pic>
       <p:pic>
         <p:nvPicPr>
-          <p:cNvPr id="32" name="Picture 31" descr="me5.png"/>
+          <p:cNvPr id="21" name="Picture 20" descr="answer.png"/>
           <p:cNvPicPr>
             <a:picLocks noChangeAspect="1"/>
           </p:cNvPicPr>
@@ -4441,181 +3770,31 @@
         </p:blipFill>
         <p:spPr>
           <a:xfrm>
-            <a:off x="7013813" y="859536"/>
-            <a:ext cx="374172" cy="374172"/>
+            <a:off x="9116568" y="365760"/>
+            <a:ext cx="292608" cy="292608"/>
           </a:xfrm>
           <a:prstGeom prst="rect">
             <a:avLst/>
           </a:prstGeom>
         </p:spPr>
       </p:pic>
-      <p:sp>
-        <p:nvSpPr>
-          <p:cNvPr id="33" name="TextBox 32"/>
-          <p:cNvSpPr txBox="1"/>
-          <p:nvPr/>
-        </p:nvSpPr>
-        <p:spPr>
-          <a:xfrm>
-            <a:off x="6934200" y="1242852"/>
-            <a:ext cx="533400" cy="183611"/>
-          </a:xfrm>
-          <a:prstGeom prst="rect">
-            <a:avLst/>
-          </a:prstGeom>
-          <a:noFill/>
-        </p:spPr>
-        <p:txBody>
-          <a:bodyPr wrap="square" anchor="t" lIns="0" rIns="0" tIns="0" bIns="0">
-            <a:noAutofit/>
-          </a:bodyPr>
-          <a:lstStyle/>
-          <a:p>
-            <a:pPr algn="ctr">
-              <a:spcBef>
-                <a:spcPts val="0"/>
-              </a:spcBef>
-              <a:spcAft>
-                <a:spcPts val="400"/>
-              </a:spcAft>
-            </a:pPr>
-            <a:r>
-              <a:rPr sz="650" b="0">
-                <a:solidFill>
-                  <a:srgbClr val="546E7A"/>
-                </a:solidFill>
-                <a:latin typeface="Calibri"/>
-              </a:rPr>
-              <a:t>mE5</a:t>
-            </a:r>
-          </a:p>
-        </p:txBody>
-      </p:sp>
-      <p:pic>
-        <p:nvPicPr>
-          <p:cNvPr id="34" name="Picture 33" descr="qwen.png"/>
-          <p:cNvPicPr>
-            <a:picLocks noChangeAspect="1"/>
-          </p:cNvPicPr>
-          <p:nvPr/>
-        </p:nvPicPr>
-        <p:blipFill>
-          <a:blip r:embed="rId5"/>
-          <a:stretch>
-            <a:fillRect/>
-          </a:stretch>
-        </p:blipFill>
-        <p:spPr>
-          <a:xfrm>
-            <a:off x="7547213" y="859536"/>
-            <a:ext cx="374172" cy="374172"/>
-          </a:xfrm>
-          <a:prstGeom prst="rect">
-            <a:avLst/>
-          </a:prstGeom>
-        </p:spPr>
-      </p:pic>
-      <p:sp>
-        <p:nvSpPr>
-          <p:cNvPr id="35" name="TextBox 34"/>
-          <p:cNvSpPr txBox="1"/>
-          <p:nvPr/>
-        </p:nvSpPr>
-        <p:spPr>
-          <a:xfrm>
-            <a:off x="7467599" y="1242852"/>
-            <a:ext cx="533400" cy="183611"/>
-          </a:xfrm>
-          <a:prstGeom prst="rect">
-            <a:avLst/>
-          </a:prstGeom>
-          <a:noFill/>
-        </p:spPr>
-        <p:txBody>
-          <a:bodyPr wrap="square" anchor="t" lIns="0" rIns="0" tIns="0" bIns="0">
-            <a:noAutofit/>
-          </a:bodyPr>
-          <a:lstStyle/>
-          <a:p>
-            <a:pPr algn="ctr">
-              <a:spcBef>
-                <a:spcPts val="0"/>
-              </a:spcBef>
-              <a:spcAft>
-                <a:spcPts val="400"/>
-              </a:spcAft>
-            </a:pPr>
-            <a:r>
-              <a:rPr sz="650" b="0">
-                <a:solidFill>
-                  <a:srgbClr val="546E7A"/>
-                </a:solidFill>
-                <a:latin typeface="Calibri"/>
-              </a:rPr>
-              <a:t>Qwen3-Emb</a:t>
-            </a:r>
-          </a:p>
-        </p:txBody>
-      </p:sp>
-      <p:sp>
-        <p:nvSpPr>
-          <p:cNvPr id="36" name="TextBox 35"/>
-          <p:cNvSpPr txBox="1"/>
-          <p:nvPr/>
-        </p:nvSpPr>
-        <p:spPr>
-          <a:xfrm>
-            <a:off x="6355080" y="1609344"/>
-            <a:ext cx="1691640" cy="237744"/>
-          </a:xfrm>
-          <a:prstGeom prst="rect">
-            <a:avLst/>
-          </a:prstGeom>
-          <a:noFill/>
-        </p:spPr>
-        <p:txBody>
-          <a:bodyPr wrap="square" anchor="ctr" lIns="18288" rIns="18288" tIns="18288" bIns="18288">
-            <a:noAutofit/>
-          </a:bodyPr>
-          <a:lstStyle/>
-          <a:p>
-            <a:pPr algn="ctr">
-              <a:spcBef>
-                <a:spcPts val="0"/>
-              </a:spcBef>
-              <a:spcAft>
-                <a:spcPts val="400"/>
-              </a:spcAft>
-            </a:pPr>
-            <a:r>
-              <a:rPr sz="850" b="0">
-                <a:solidFill>
-                  <a:srgbClr val="546E7A"/>
-                </a:solidFill>
-                <a:latin typeface="Calibri"/>
-              </a:rPr>
-              <a:t>k ∈ {1, 5, 10}</a:t>
-            </a:r>
-          </a:p>
-        </p:txBody>
-      </p:sp>
       <p:cxnSp>
         <p:nvCxnSpPr>
-          <p:cNvPr id="37" name="Connector 36"/>
+          <p:cNvPr id="22" name="Connector 21"/>
           <p:cNvCxnSpPr/>
           <p:nvPr/>
         </p:nvCxnSpPr>
         <p:spPr>
           <a:xfrm>
-            <a:off x="1892808" y="1216152"/>
-            <a:ext cx="329184" cy="0"/>
+            <a:off x="1975104" y="466344"/>
+            <a:ext cx="237744" cy="0"/>
           </a:xfrm>
           <a:prstGeom prst="line">
             <a:avLst/>
           </a:prstGeom>
-          <a:ln w="20320">
+          <a:ln w="17780">
             <a:solidFill>
-              <a:srgbClr val="78909C"/>
+              <a:srgbClr val="B0BEC5"/>
             </a:solidFill>
             <a:tailEnd type="triangle" w="med" len="med"/>
           </a:ln>
@@ -4637,21 +3816,21 @@
       </p:cxnSp>
       <p:cxnSp>
         <p:nvCxnSpPr>
-          <p:cNvPr id="38" name="Connector 37"/>
+          <p:cNvPr id="23" name="Connector 22"/>
           <p:cNvCxnSpPr/>
           <p:nvPr/>
         </p:nvCxnSpPr>
         <p:spPr>
           <a:xfrm>
-            <a:off x="3950208" y="1216152"/>
-            <a:ext cx="329184" cy="0"/>
+            <a:off x="4023360" y="466344"/>
+            <a:ext cx="237744" cy="0"/>
           </a:xfrm>
           <a:prstGeom prst="line">
             <a:avLst/>
           </a:prstGeom>
-          <a:ln w="20320">
+          <a:ln w="17780">
             <a:solidFill>
-              <a:srgbClr val="78909C"/>
+              <a:srgbClr val="B0BEC5"/>
             </a:solidFill>
             <a:tailEnd type="triangle" w="med" len="med"/>
           </a:ln>
@@ -4673,21 +3852,21 @@
       </p:cxnSp>
       <p:cxnSp>
         <p:nvCxnSpPr>
-          <p:cNvPr id="39" name="Connector 38"/>
+          <p:cNvPr id="24" name="Connector 23"/>
           <p:cNvCxnSpPr/>
           <p:nvPr/>
         </p:nvCxnSpPr>
         <p:spPr>
           <a:xfrm>
-            <a:off x="6007608" y="1216152"/>
-            <a:ext cx="329184" cy="0"/>
+            <a:off x="6071616" y="466344"/>
+            <a:ext cx="237744" cy="0"/>
           </a:xfrm>
           <a:prstGeom prst="line">
             <a:avLst/>
           </a:prstGeom>
-          <a:ln w="20320">
+          <a:ln w="17780">
             <a:solidFill>
-              <a:srgbClr val="78909C"/>
+              <a:srgbClr val="B0BEC5"/>
             </a:solidFill>
             <a:tailEnd type="triangle" w="med" len="med"/>
           </a:ln>
@@ -4709,21 +3888,21 @@
       </p:cxnSp>
       <p:cxnSp>
         <p:nvCxnSpPr>
-          <p:cNvPr id="40" name="Connector 39"/>
+          <p:cNvPr id="25" name="Connector 24"/>
           <p:cNvCxnSpPr/>
           <p:nvPr/>
         </p:nvCxnSpPr>
         <p:spPr>
           <a:xfrm>
-            <a:off x="8065008" y="1216152"/>
-            <a:ext cx="329184" cy="0"/>
+            <a:off x="8119872" y="466344"/>
+            <a:ext cx="237744" cy="0"/>
           </a:xfrm>
           <a:prstGeom prst="line">
             <a:avLst/>
           </a:prstGeom>
-          <a:ln w="20320">
+          <a:ln w="17780">
             <a:solidFill>
-              <a:srgbClr val="78909C"/>
+              <a:srgbClr val="B0BEC5"/>
             </a:solidFill>
             <a:tailEnd type="triangle" w="med" len="med"/>
           </a:ln>
@@ -4745,27 +3924,115 @@
       </p:cxnSp>
       <p:sp>
         <p:nvSpPr>
-          <p:cNvPr id="41" name="Rounded Rectangle 40"/>
+          <p:cNvPr id="26" name="TextBox 25"/>
+          <p:cNvSpPr txBox="1"/>
+          <p:nvPr/>
+        </p:nvSpPr>
+        <p:spPr>
+          <a:xfrm>
+            <a:off x="182880" y="809244"/>
+            <a:ext cx="1773936" cy="146304"/>
+          </a:xfrm>
+          <a:prstGeom prst="rect">
+            <a:avLst/>
+          </a:prstGeom>
+          <a:noFill/>
+        </p:spPr>
+        <p:txBody>
+          <a:bodyPr wrap="square" anchor="t" lIns="18288" rIns="18288" tIns="18288" bIns="18288">
+            <a:noAutofit/>
+          </a:bodyPr>
+          <a:lstStyle/>
+          <a:p>
+            <a:pPr algn="l">
+              <a:spcBef>
+                <a:spcPts val="0"/>
+              </a:spcBef>
+              <a:spcAft>
+                <a:spcPts val="300"/>
+              </a:spcAft>
+            </a:pPr>
+            <a:r>
+              <a:rPr sz="750" b="0">
+                <a:solidFill>
+                  <a:srgbClr val="90A4AE"/>
+                </a:solidFill>
+                <a:latin typeface="Calibri"/>
+              </a:rPr>
+              <a:t>the document-RAG pipeline we study</a:t>
+            </a:r>
+          </a:p>
+        </p:txBody>
+      </p:sp>
+      <p:sp>
+        <p:nvSpPr>
+          <p:cNvPr id="27" name="Rounded Rectangle 26"/>
           <p:cNvSpPr/>
           <p:nvPr/>
         </p:nvSpPr>
         <p:spPr>
           <a:xfrm>
-            <a:off x="2203704" y="457200"/>
-            <a:ext cx="347472" cy="192024"/>
+            <a:off x="182880" y="1078992"/>
+            <a:ext cx="2249424" cy="2103120"/>
           </a:xfrm>
           <a:prstGeom prst="roundRect">
             <a:avLst>
-              <a:gd name="adj" fmla="val 50000"/>
+              <a:gd name="adj" fmla="val 5000"/>
+            </a:avLst>
+          </a:prstGeom>
+          <a:solidFill>
+            <a:srgbClr val="FFFFFF"/>
+          </a:solidFill>
+          <a:ln w="16510">
+            <a:solidFill>
+              <a:srgbClr val="C62828"/>
+            </a:solidFill>
+          </a:ln>
+          <a:effectLst/>
+        </p:spPr>
+        <p:style>
+          <a:lnRef idx="1">
+            <a:schemeClr val="accent1"/>
+          </a:lnRef>
+          <a:fillRef idx="3">
+            <a:schemeClr val="accent1"/>
+          </a:fillRef>
+          <a:effectRef idx="2">
+            <a:schemeClr val="accent1"/>
+          </a:effectRef>
+          <a:fontRef idx="minor">
+            <a:schemeClr val="lt1"/>
+          </a:fontRef>
+        </p:style>
+        <p:txBody>
+          <a:bodyPr rtlCol="0" anchor="ctr"/>
+          <a:lstStyle/>
+          <a:p>
+            <a:pPr algn="ctr"/>
+          </a:p>
+        </p:txBody>
+      </p:sp>
+      <p:sp>
+        <p:nvSpPr>
+          <p:cNvPr id="28" name="Rounded Rectangle 27"/>
+          <p:cNvSpPr/>
+          <p:nvPr/>
+        </p:nvSpPr>
+        <p:spPr>
+          <a:xfrm>
+            <a:off x="182880" y="1078992"/>
+            <a:ext cx="2249424" cy="512064"/>
+          </a:xfrm>
+          <a:prstGeom prst="roundRect">
+            <a:avLst>
+              <a:gd name="adj" fmla="val 9000"/>
             </a:avLst>
           </a:prstGeom>
           <a:solidFill>
             <a:srgbClr val="C62828"/>
           </a:solidFill>
-          <a:ln w="13970">
-            <a:solidFill>
-              <a:srgbClr val="FFFFFF"/>
-            </a:solidFill>
+          <a:ln>
+            <a:noFill/>
           </a:ln>
           <a:effectLst/>
         </p:spPr>
@@ -4784,10 +4051,29 @@
           </a:fontRef>
         </p:style>
         <p:txBody>
-          <a:bodyPr rtlCol="0" anchor="ctr" wrap="square" lIns="0" rIns="0" tIns="0" bIns="0">
+          <a:bodyPr rtlCol="0" anchor="ctr" wrap="square" lIns="36576" rIns="36576" tIns="36576" bIns="36576">
             <a:noAutofit/>
           </a:bodyPr>
           <a:lstStyle/>
+          <a:p>
+            <a:pPr algn="ctr">
+              <a:spcBef>
+                <a:spcPts val="0"/>
+              </a:spcBef>
+              <a:spcAft>
+                <a:spcPts val="100"/>
+              </a:spcAft>
+            </a:pPr>
+            <a:r>
+              <a:rPr sz="800" b="1">
+                <a:solidFill>
+                  <a:srgbClr val="FFFFFF"/>
+                </a:solidFill>
+                <a:latin typeface="Calibri"/>
+              </a:rPr>
+              <a:t>PROBLEM</a:t>
+            </a:r>
+          </a:p>
           <a:p>
             <a:pPr algn="ctr">
               <a:spcBef>
@@ -4798,40 +4084,83 @@
               </a:spcAft>
             </a:pPr>
             <a:r>
-              <a:rPr sz="900" b="1">
+              <a:rPr sz="1200" b="1">
                 <a:solidFill>
                   <a:srgbClr val="FFFFFF"/>
                 </a:solidFill>
                 <a:latin typeface="Calibri"/>
               </a:rPr>
-              <a:t>C1</a:t>
-            </a:r>
-          </a:p>
-        </p:txBody>
-      </p:sp>
-      <p:sp>
-        <p:nvSpPr>
-          <p:cNvPr id="42" name="Rounded Rectangle 41"/>
+              <a:t>C1 · The disconnect</a:t>
+            </a:r>
+          </a:p>
+        </p:txBody>
+      </p:sp>
+      <p:sp>
+        <p:nvSpPr>
+          <p:cNvPr id="29" name="TextBox 28"/>
+          <p:cNvSpPr txBox="1"/>
+          <p:nvPr/>
+        </p:nvSpPr>
+        <p:spPr>
+          <a:xfrm>
+            <a:off x="274320" y="1655064"/>
+            <a:ext cx="2066543" cy="1088135"/>
+          </a:xfrm>
+          <a:prstGeom prst="rect">
+            <a:avLst/>
+          </a:prstGeom>
+          <a:noFill/>
+        </p:spPr>
+        <p:txBody>
+          <a:bodyPr wrap="square" anchor="t" lIns="27432" rIns="27432" tIns="27432" bIns="27432">
+            <a:noAutofit/>
+          </a:bodyPr>
+          <a:lstStyle/>
+          <a:p>
+            <a:pPr algn="l">
+              <a:lnSpc>
+                <a:spcPct val="104000"/>
+              </a:lnSpc>
+              <a:spcBef>
+                <a:spcPts val="0"/>
+              </a:spcBef>
+              <a:spcAft>
+                <a:spcPts val="300"/>
+              </a:spcAft>
+            </a:pPr>
+            <a:r>
+              <a:rPr sz="950" b="0">
+                <a:solidFill>
+                  <a:srgbClr val="1F3247"/>
+                </a:solidFill>
+                <a:latin typeface="Calibri"/>
+              </a:rPr>
+              <a:t>Parsers that look clean don’t retrieve. Boundary Clarity anti-correlates with retrieval (r = −0.81).</a:t>
+            </a:r>
+          </a:p>
+        </p:txBody>
+      </p:sp>
+      <p:sp>
+        <p:nvSpPr>
+          <p:cNvPr id="30" name="Rounded Rectangle 29"/>
           <p:cNvSpPr/>
           <p:nvPr/>
         </p:nvSpPr>
         <p:spPr>
           <a:xfrm>
-            <a:off x="4261104" y="457200"/>
-            <a:ext cx="347472" cy="192024"/>
+            <a:off x="274320" y="2761487"/>
+            <a:ext cx="2066543" cy="329184"/>
           </a:xfrm>
           <a:prstGeom prst="roundRect">
             <a:avLst>
-              <a:gd name="adj" fmla="val 50000"/>
+              <a:gd name="adj" fmla="val 12000"/>
             </a:avLst>
           </a:prstGeom>
           <a:solidFill>
-            <a:srgbClr val="C62828"/>
+            <a:srgbClr val="FDEBEC"/>
           </a:solidFill>
-          <a:ln w="13970">
-            <a:solidFill>
-              <a:srgbClr val="FFFFFF"/>
-            </a:solidFill>
+          <a:ln>
+            <a:noFill/>
           </a:ln>
           <a:effectLst/>
         </p:spPr>
@@ -4850,7 +4179,7 @@
           </a:fontRef>
         </p:style>
         <p:txBody>
-          <a:bodyPr rtlCol="0" anchor="ctr" wrap="square" lIns="0" rIns="0" tIns="0" bIns="0">
+          <a:bodyPr rtlCol="0" anchor="ctr" wrap="square" lIns="27432" rIns="27432" tIns="27432" bIns="27432">
             <a:noAutofit/>
           </a:bodyPr>
           <a:lstStyle/>
@@ -4864,93 +4193,27 @@
               </a:spcAft>
             </a:pPr>
             <a:r>
-              <a:rPr sz="900" b="1">
+              <a:rPr sz="950" b="1">
                 <a:solidFill>
-                  <a:srgbClr val="FFFFFF"/>
+                  <a:srgbClr val="C62828"/>
                 </a:solidFill>
                 <a:latin typeface="Calibri"/>
               </a:rPr>
-              <a:t>C2</a:t>
-            </a:r>
-          </a:p>
-        </p:txBody>
-      </p:sp>
-      <p:sp>
-        <p:nvSpPr>
-          <p:cNvPr id="43" name="Rounded Rectangle 42"/>
+              <a:t>Parser choice → Hit@1 2.8×  (0.197 → 0.549)</a:t>
+            </a:r>
+          </a:p>
+        </p:txBody>
+      </p:sp>
+      <p:sp>
+        <p:nvSpPr>
+          <p:cNvPr id="31" name="Rounded Rectangle 30"/>
           <p:cNvSpPr/>
           <p:nvPr/>
         </p:nvSpPr>
         <p:spPr>
           <a:xfrm>
-            <a:off x="6318504" y="457200"/>
-            <a:ext cx="347472" cy="192024"/>
-          </a:xfrm>
-          <a:prstGeom prst="roundRect">
-            <a:avLst>
-              <a:gd name="adj" fmla="val 50000"/>
-            </a:avLst>
-          </a:prstGeom>
-          <a:solidFill>
-            <a:srgbClr val="C62828"/>
-          </a:solidFill>
-          <a:ln w="13970">
-            <a:solidFill>
-              <a:srgbClr val="FFFFFF"/>
-            </a:solidFill>
-          </a:ln>
-          <a:effectLst/>
-        </p:spPr>
-        <p:style>
-          <a:lnRef idx="1">
-            <a:schemeClr val="accent1"/>
-          </a:lnRef>
-          <a:fillRef idx="3">
-            <a:schemeClr val="accent1"/>
-          </a:fillRef>
-          <a:effectRef idx="2">
-            <a:schemeClr val="accent1"/>
-          </a:effectRef>
-          <a:fontRef idx="minor">
-            <a:schemeClr val="lt1"/>
-          </a:fontRef>
-        </p:style>
-        <p:txBody>
-          <a:bodyPr rtlCol="0" anchor="ctr" wrap="square" lIns="0" rIns="0" tIns="0" bIns="0">
-            <a:noAutofit/>
-          </a:bodyPr>
-          <a:lstStyle/>
-          <a:p>
-            <a:pPr algn="ctr">
-              <a:spcBef>
-                <a:spcPts val="0"/>
-              </a:spcBef>
-              <a:spcAft>
-                <a:spcPts val="300"/>
-              </a:spcAft>
-            </a:pPr>
-            <a:r>
-              <a:rPr sz="900" b="1">
-                <a:solidFill>
-                  <a:srgbClr val="FFFFFF"/>
-                </a:solidFill>
-                <a:latin typeface="Calibri"/>
-              </a:rPr>
-              <a:t>C3</a:t>
-            </a:r>
-          </a:p>
-        </p:txBody>
-      </p:sp>
-      <p:sp>
-        <p:nvSpPr>
-          <p:cNvPr id="44" name="Rounded Rectangle 43"/>
-          <p:cNvSpPr/>
-          <p:nvPr/>
-        </p:nvSpPr>
-        <p:spPr>
-          <a:xfrm>
-            <a:off x="182880" y="1993392"/>
-            <a:ext cx="4480560" cy="1792224"/>
+            <a:off x="2752344" y="1078992"/>
+            <a:ext cx="2249424" cy="2103120"/>
           </a:xfrm>
           <a:prstGeom prst="roundRect">
             <a:avLst>
@@ -4958,9 +4221,9 @@
             </a:avLst>
           </a:prstGeom>
           <a:solidFill>
-            <a:srgbClr val="E8F0FE"/>
+            <a:srgbClr val="FFFFFF"/>
           </a:solidFill>
-          <a:ln w="13970">
+          <a:ln w="16510">
             <a:solidFill>
               <a:srgbClr val="1565C0"/>
             </a:solidFill>
@@ -4991,18 +4254,18 @@
       </p:sp>
       <p:sp>
         <p:nvSpPr>
-          <p:cNvPr id="45" name="Rounded Rectangle 44"/>
+          <p:cNvPr id="32" name="Rounded Rectangle 31"/>
           <p:cNvSpPr/>
           <p:nvPr/>
         </p:nvSpPr>
         <p:spPr>
           <a:xfrm>
-            <a:off x="182880" y="1993392"/>
-            <a:ext cx="4480560" cy="310896"/>
+            <a:off x="2752344" y="1078992"/>
+            <a:ext cx="2249424" cy="512064"/>
           </a:xfrm>
           <a:prstGeom prst="roundRect">
             <a:avLst>
-              <a:gd name="adj" fmla="val 10000"/>
+              <a:gd name="adj" fmla="val 9000"/>
             </a:avLst>
           </a:prstGeom>
           <a:solidFill>
@@ -5028,10 +4291,29 @@
           </a:fontRef>
         </p:style>
         <p:txBody>
-          <a:bodyPr rtlCol="0" anchor="ctr" wrap="square" lIns="27432" rIns="27432" tIns="27432" bIns="27432">
+          <a:bodyPr rtlCol="0" anchor="ctr" wrap="square" lIns="36576" rIns="36576" tIns="36576" bIns="36576">
             <a:noAutofit/>
           </a:bodyPr>
           <a:lstStyle/>
+          <a:p>
+            <a:pPr algn="ctr">
+              <a:spcBef>
+                <a:spcPts val="0"/>
+              </a:spcBef>
+              <a:spcAft>
+                <a:spcPts val="100"/>
+              </a:spcAft>
+            </a:pPr>
+            <a:r>
+              <a:rPr sz="800" b="1">
+                <a:solidFill>
+                  <a:srgbClr val="FFFFFF"/>
+                </a:solidFill>
+                <a:latin typeface="Calibri"/>
+              </a:rPr>
+              <a:t>DIAGNOSE</a:t>
+            </a:r>
+          </a:p>
           <a:p>
             <a:pPr algn="ctr">
               <a:spcBef>
@@ -5042,27 +4324,27 @@
               </a:spcAft>
             </a:pPr>
             <a:r>
-              <a:rPr sz="1050" b="1">
+              <a:rPr sz="1200" b="1">
                 <a:solidFill>
                   <a:srgbClr val="FFFFFF"/>
                 </a:solidFill>
                 <a:latin typeface="Calibri"/>
               </a:rPr>
-              <a:t>DIAGNOSE  —  locate the real fault</a:t>
-            </a:r>
-          </a:p>
-        </p:txBody>
-      </p:sp>
-      <p:sp>
-        <p:nvSpPr>
-          <p:cNvPr id="46" name="TextBox 45"/>
+              <a:t>C2 · Coverage diagnostic</a:t>
+            </a:r>
+          </a:p>
+        </p:txBody>
+      </p:sp>
+      <p:sp>
+        <p:nvSpPr>
+          <p:cNvPr id="33" name="TextBox 32"/>
           <p:cNvSpPr txBox="1"/>
           <p:nvPr/>
         </p:nvSpPr>
         <p:spPr>
           <a:xfrm>
-            <a:off x="256032" y="2350008"/>
-            <a:ext cx="4334256" cy="1371600"/>
+            <a:off x="2843784" y="1655064"/>
+            <a:ext cx="2066543" cy="1088135"/>
           </a:xfrm>
           <a:prstGeom prst="rect">
             <a:avLst/>
@@ -5070,17 +4352,84 @@
           <a:noFill/>
         </p:spPr>
         <p:txBody>
-          <a:bodyPr wrap="square" anchor="t" lIns="36576" rIns="36576" tIns="36576" bIns="36576">
+          <a:bodyPr wrap="square" anchor="t" lIns="27432" rIns="27432" tIns="27432" bIns="27432">
             <a:noAutofit/>
           </a:bodyPr>
           <a:lstStyle/>
           <a:p>
             <a:pPr algn="l">
+              <a:lnSpc>
+                <a:spcPct val="104000"/>
+              </a:lnSpc>
               <a:spcBef>
                 <a:spcPts val="0"/>
               </a:spcBef>
               <a:spcAft>
-                <a:spcPts val="500"/>
+                <a:spcPts val="300"/>
+              </a:spcAft>
+            </a:pPr>
+            <a:r>
+              <a:rPr sz="950" b="0">
+                <a:solidFill>
+                  <a:srgbClr val="1F3247"/>
+                </a:solidFill>
+                <a:latin typeface="Calibri"/>
+              </a:rPr>
+              <a:t>A retriever-free check labels every answer covered / split / absent. Absent means a parser fault.</a:t>
+            </a:r>
+          </a:p>
+        </p:txBody>
+      </p:sp>
+      <p:sp>
+        <p:nvSpPr>
+          <p:cNvPr id="34" name="Rounded Rectangle 33"/>
+          <p:cNvSpPr/>
+          <p:nvPr/>
+        </p:nvSpPr>
+        <p:spPr>
+          <a:xfrm>
+            <a:off x="2843784" y="2761487"/>
+            <a:ext cx="2066543" cy="329184"/>
+          </a:xfrm>
+          <a:prstGeom prst="roundRect">
+            <a:avLst>
+              <a:gd name="adj" fmla="val 12000"/>
+            </a:avLst>
+          </a:prstGeom>
+          <a:solidFill>
+            <a:srgbClr val="E8F0FE"/>
+          </a:solidFill>
+          <a:ln>
+            <a:noFill/>
+          </a:ln>
+          <a:effectLst/>
+        </p:spPr>
+        <p:style>
+          <a:lnRef idx="1">
+            <a:schemeClr val="accent1"/>
+          </a:lnRef>
+          <a:fillRef idx="3">
+            <a:schemeClr val="accent1"/>
+          </a:fillRef>
+          <a:effectRef idx="2">
+            <a:schemeClr val="accent1"/>
+          </a:effectRef>
+          <a:fontRef idx="minor">
+            <a:schemeClr val="lt1"/>
+          </a:fontRef>
+        </p:style>
+        <p:txBody>
+          <a:bodyPr rtlCol="0" anchor="ctr" wrap="square" lIns="27432" rIns="27432" tIns="27432" bIns="27432">
+            <a:noAutofit/>
+          </a:bodyPr>
+          <a:lstStyle/>
+          <a:p>
+            <a:pPr algn="ctr">
+              <a:spcBef>
+                <a:spcPts val="0"/>
+              </a:spcBef>
+              <a:spcAft>
+                <a:spcPts val="300"/>
               </a:spcAft>
             </a:pPr>
             <a:r>
@@ -5090,58 +4439,21 @@
                 </a:solidFill>
                 <a:latin typeface="Calibri"/>
               </a:rPr>
-              <a:t>C1  </a:t>
-            </a:r>
-            <a:r>
-              <a:rPr sz="950" b="0">
-                <a:solidFill>
-                  <a:srgbClr val="1F3247"/>
-                </a:solidFill>
-                <a:latin typeface="Calibri"/>
-              </a:rPr>
-              <a:t>Disconnect — parsers that look clean don’t retrieve. Boundary Clarity anti-correlates with retrieval (r = −0.81); parser choice alone swings Hit@1 2.8× (0.197 → 0.549).</a:t>
-            </a:r>
-          </a:p>
-          <a:p>
-            <a:pPr algn="l">
-              <a:spcBef>
-                <a:spcPts val="0"/>
-              </a:spcBef>
-              <a:spcAft>
-                <a:spcPts val="500"/>
-              </a:spcAft>
-            </a:pPr>
-            <a:r>
-              <a:rPr sz="950" b="1">
-                <a:solidFill>
-                  <a:srgbClr val="1565C0"/>
-                </a:solidFill>
-                <a:latin typeface="Calibri"/>
-              </a:rPr>
-              <a:t>C2  </a:t>
-            </a:r>
-            <a:r>
-              <a:rPr sz="950" b="0">
-                <a:solidFill>
-                  <a:srgbClr val="1F3247"/>
-                </a:solidFill>
-                <a:latin typeface="Calibri"/>
-              </a:rPr>
-              <a:t>Coverage (no retriever) — 20.2% of answers are absent from the parser output, constant across 8 chunkers → fix the parser before the retriever.</a:t>
-            </a:r>
-          </a:p>
-        </p:txBody>
-      </p:sp>
-      <p:sp>
-        <p:nvSpPr>
-          <p:cNvPr id="47" name="Rounded Rectangle 46"/>
+              <a:t>20.2% absent — constant across 8 chunkers</a:t>
+            </a:r>
+          </a:p>
+        </p:txBody>
+      </p:sp>
+      <p:sp>
+        <p:nvSpPr>
+          <p:cNvPr id="35" name="Rounded Rectangle 34"/>
           <p:cNvSpPr/>
           <p:nvPr/>
         </p:nvSpPr>
         <p:spPr>
           <a:xfrm>
-            <a:off x="4800600" y="1993392"/>
-            <a:ext cx="2651760" cy="1792224"/>
+            <a:off x="5321808" y="1078992"/>
+            <a:ext cx="2249424" cy="2103120"/>
           </a:xfrm>
           <a:prstGeom prst="roundRect">
             <a:avLst>
@@ -5149,9 +4461,9 @@
             </a:avLst>
           </a:prstGeom>
           <a:solidFill>
-            <a:srgbClr val="E7F5EA"/>
+            <a:srgbClr val="FFFFFF"/>
           </a:solidFill>
-          <a:ln w="13970">
+          <a:ln w="16510">
             <a:solidFill>
               <a:srgbClr val="2E7D32"/>
             </a:solidFill>
@@ -5182,18 +4494,18 @@
       </p:sp>
       <p:sp>
         <p:nvSpPr>
-          <p:cNvPr id="48" name="Rounded Rectangle 47"/>
+          <p:cNvPr id="36" name="Rounded Rectangle 35"/>
           <p:cNvSpPr/>
           <p:nvPr/>
         </p:nvSpPr>
         <p:spPr>
           <a:xfrm>
-            <a:off x="4800600" y="1993392"/>
-            <a:ext cx="2651760" cy="310896"/>
+            <a:off x="5321808" y="1078992"/>
+            <a:ext cx="2249424" cy="512064"/>
           </a:xfrm>
           <a:prstGeom prst="roundRect">
             <a:avLst>
-              <a:gd name="adj" fmla="val 10000"/>
+              <a:gd name="adj" fmla="val 9000"/>
             </a:avLst>
           </a:prstGeom>
           <a:solidFill>
@@ -5219,10 +4531,29 @@
           </a:fontRef>
         </p:style>
         <p:txBody>
-          <a:bodyPr rtlCol="0" anchor="ctr" wrap="square" lIns="27432" rIns="27432" tIns="27432" bIns="27432">
+          <a:bodyPr rtlCol="0" anchor="ctr" wrap="square" lIns="36576" rIns="36576" tIns="36576" bIns="36576">
             <a:noAutofit/>
           </a:bodyPr>
           <a:lstStyle/>
+          <a:p>
+            <a:pPr algn="ctr">
+              <a:spcBef>
+                <a:spcPts val="0"/>
+              </a:spcBef>
+              <a:spcAft>
+                <a:spcPts val="100"/>
+              </a:spcAft>
+            </a:pPr>
+            <a:r>
+              <a:rPr sz="800" b="1">
+                <a:solidFill>
+                  <a:srgbClr val="FFFFFF"/>
+                </a:solidFill>
+                <a:latin typeface="Calibri"/>
+              </a:rPr>
+              <a:t>SELECT</a:t>
+            </a:r>
+          </a:p>
           <a:p>
             <a:pPr algn="ctr">
               <a:spcBef>
@@ -5233,27 +4564,27 @@
               </a:spcAft>
             </a:pPr>
             <a:r>
-              <a:rPr sz="1050" b="1">
+              <a:rPr sz="1200" b="1">
                 <a:solidFill>
                   <a:srgbClr val="FFFFFF"/>
                 </a:solidFill>
                 <a:latin typeface="Calibri"/>
               </a:rPr>
-              <a:t>SELECT</a:t>
-            </a:r>
-          </a:p>
-        </p:txBody>
-      </p:sp>
-      <p:sp>
-        <p:nvSpPr>
-          <p:cNvPr id="49" name="TextBox 48"/>
+              <a:t>C3 · RCPS protocol</a:t>
+            </a:r>
+          </a:p>
+        </p:txBody>
+      </p:sp>
+      <p:sp>
+        <p:nvSpPr>
+          <p:cNvPr id="37" name="TextBox 36"/>
           <p:cNvSpPr txBox="1"/>
           <p:nvPr/>
         </p:nvSpPr>
         <p:spPr>
           <a:xfrm>
-            <a:off x="4873752" y="2350008"/>
-            <a:ext cx="2505456" cy="1371600"/>
+            <a:off x="5413248" y="1655064"/>
+            <a:ext cx="2066543" cy="1088135"/>
           </a:xfrm>
           <a:prstGeom prst="rect">
             <a:avLst/>
@@ -5261,17 +4592,84 @@
           <a:noFill/>
         </p:spPr>
         <p:txBody>
-          <a:bodyPr wrap="square" anchor="t" lIns="36576" rIns="36576" tIns="36576" bIns="36576">
+          <a:bodyPr wrap="square" anchor="t" lIns="27432" rIns="27432" tIns="27432" bIns="27432">
             <a:noAutofit/>
           </a:bodyPr>
           <a:lstStyle/>
           <a:p>
             <a:pPr algn="l">
+              <a:lnSpc>
+                <a:spcPct val="104000"/>
+              </a:lnSpc>
               <a:spcBef>
                 <a:spcPts val="0"/>
               </a:spcBef>
               <a:spcAft>
-                <a:spcPts val="500"/>
+                <a:spcPts val="300"/>
+              </a:spcAft>
+            </a:pPr>
+            <a:r>
+              <a:rPr sz="950" b="0">
+                <a:solidFill>
+                  <a:srgbClr val="1F3247"/>
+                </a:solidFill>
+                <a:latin typeface="Calibri"/>
+              </a:rPr>
+              <a:t>Rank parsers &amp; chunkers by what retrieval does, on a held-out Q–A probe. Retriever-averaged &amp; format-invariant. No training.</a:t>
+            </a:r>
+          </a:p>
+        </p:txBody>
+      </p:sp>
+      <p:sp>
+        <p:nvSpPr>
+          <p:cNvPr id="38" name="Rounded Rectangle 37"/>
+          <p:cNvSpPr/>
+          <p:nvPr/>
+        </p:nvSpPr>
+        <p:spPr>
+          <a:xfrm>
+            <a:off x="5413248" y="2761487"/>
+            <a:ext cx="2066543" cy="329184"/>
+          </a:xfrm>
+          <a:prstGeom prst="roundRect">
+            <a:avLst>
+              <a:gd name="adj" fmla="val 12000"/>
+            </a:avLst>
+          </a:prstGeom>
+          <a:solidFill>
+            <a:srgbClr val="E7F5EA"/>
+          </a:solidFill>
+          <a:ln>
+            <a:noFill/>
+          </a:ln>
+          <a:effectLst/>
+        </p:spPr>
+        <p:style>
+          <a:lnRef idx="1">
+            <a:schemeClr val="accent1"/>
+          </a:lnRef>
+          <a:fillRef idx="3">
+            <a:schemeClr val="accent1"/>
+          </a:fillRef>
+          <a:effectRef idx="2">
+            <a:schemeClr val="accent1"/>
+          </a:effectRef>
+          <a:fontRef idx="minor">
+            <a:schemeClr val="lt1"/>
+          </a:fontRef>
+        </p:style>
+        <p:txBody>
+          <a:bodyPr rtlCol="0" anchor="ctr" wrap="square" lIns="27432" rIns="27432" tIns="27432" bIns="27432">
+            <a:noAutofit/>
+          </a:bodyPr>
+          <a:lstStyle/>
+          <a:p>
+            <a:pPr algn="ctr">
+              <a:spcBef>
+                <a:spcPts val="0"/>
+              </a:spcBef>
+              <a:spcAft>
+                <a:spcPts val="300"/>
               </a:spcAft>
             </a:pPr>
             <a:r>
@@ -5281,30 +4679,21 @@
                 </a:solidFill>
                 <a:latin typeface="Calibri"/>
               </a:rPr>
-              <a:t>C3  </a:t>
-            </a:r>
-            <a:r>
-              <a:rPr sz="950" b="0">
-                <a:solidFill>
-                  <a:srgbClr val="1F3247"/>
-                </a:solidFill>
-                <a:latin typeface="Calibri"/>
-              </a:rPr>
-              <a:t>RCPS — rank parsers &amp; chunkers by what retrieval does, on a held-out Q–A probe. Retriever-averaged &amp; format-invariant. No training.</a:t>
-            </a:r>
-          </a:p>
-        </p:txBody>
-      </p:sp>
-      <p:sp>
-        <p:nvSpPr>
-          <p:cNvPr id="50" name="Rounded Rectangle 49"/>
+              <a:t>Picks what BC / edit-distance rank wrong</a:t>
+            </a:r>
+          </a:p>
+        </p:txBody>
+      </p:sp>
+      <p:sp>
+        <p:nvSpPr>
+          <p:cNvPr id="39" name="Rounded Rectangle 38"/>
           <p:cNvSpPr/>
           <p:nvPr/>
         </p:nvSpPr>
         <p:spPr>
           <a:xfrm>
-            <a:off x="7589520" y="1993392"/>
-            <a:ext cx="2514600" cy="1792224"/>
+            <a:off x="7891271" y="1078992"/>
+            <a:ext cx="2249424" cy="2103120"/>
           </a:xfrm>
           <a:prstGeom prst="roundRect">
             <a:avLst>
@@ -5312,9 +4701,9 @@
             </a:avLst>
           </a:prstGeom>
           <a:solidFill>
-            <a:srgbClr val="FFF3E0"/>
+            <a:srgbClr val="FFFFFF"/>
           </a:solidFill>
-          <a:ln w="13970">
+          <a:ln w="16510">
             <a:solidFill>
               <a:srgbClr val="E65100"/>
             </a:solidFill>
@@ -5345,18 +4734,18 @@
       </p:sp>
       <p:sp>
         <p:nvSpPr>
-          <p:cNvPr id="51" name="Rounded Rectangle 50"/>
+          <p:cNvPr id="40" name="Rounded Rectangle 39"/>
           <p:cNvSpPr/>
           <p:nvPr/>
         </p:nvSpPr>
         <p:spPr>
           <a:xfrm>
-            <a:off x="7589520" y="1993392"/>
-            <a:ext cx="2514600" cy="310896"/>
+            <a:off x="7891271" y="1078992"/>
+            <a:ext cx="2249424" cy="512064"/>
           </a:xfrm>
           <a:prstGeom prst="roundRect">
             <a:avLst>
-              <a:gd name="adj" fmla="val 10000"/>
+              <a:gd name="adj" fmla="val 9000"/>
             </a:avLst>
           </a:prstGeom>
           <a:solidFill>
@@ -5382,10 +4771,29 @@
           </a:fontRef>
         </p:style>
         <p:txBody>
-          <a:bodyPr rtlCol="0" anchor="ctr" wrap="square" lIns="27432" rIns="27432" tIns="27432" bIns="27432">
+          <a:bodyPr rtlCol="0" anchor="ctr" wrap="square" lIns="36576" rIns="36576" tIns="36576" bIns="36576">
             <a:noAutofit/>
           </a:bodyPr>
           <a:lstStyle/>
+          <a:p>
+            <a:pPr algn="ctr">
+              <a:spcBef>
+                <a:spcPts val="0"/>
+              </a:spcBef>
+              <a:spcAft>
+                <a:spcPts val="100"/>
+              </a:spcAft>
+            </a:pPr>
+            <a:r>
+              <a:rPr sz="800" b="1">
+                <a:solidFill>
+                  <a:srgbClr val="FFFFFF"/>
+                </a:solidFill>
+                <a:latin typeface="Calibri"/>
+              </a:rPr>
+              <a:t>IMPROVE</a:t>
+            </a:r>
+          </a:p>
           <a:p>
             <a:pPr algn="ctr">
               <a:spcBef>
@@ -5396,27 +4804,27 @@
               </a:spcAft>
             </a:pPr>
             <a:r>
-              <a:rPr sz="1050" b="1">
+              <a:rPr sz="1200" b="1">
                 <a:solidFill>
                   <a:srgbClr val="FFFFFF"/>
                 </a:solidFill>
                 <a:latin typeface="Calibri"/>
               </a:rPr>
-              <a:t>IMPROVE  (bounded)</a:t>
-            </a:r>
-          </a:p>
-        </p:txBody>
-      </p:sp>
-      <p:sp>
-        <p:nvSpPr>
-          <p:cNvPr id="52" name="TextBox 51"/>
+              <a:t>C4 · Bounded training</a:t>
+            </a:r>
+          </a:p>
+        </p:txBody>
+      </p:sp>
+      <p:sp>
+        <p:nvSpPr>
+          <p:cNvPr id="41" name="TextBox 40"/>
           <p:cNvSpPr txBox="1"/>
           <p:nvPr/>
         </p:nvSpPr>
         <p:spPr>
           <a:xfrm>
-            <a:off x="7662672" y="2350008"/>
-            <a:ext cx="2368296" cy="1371600"/>
+            <a:off x="7982711" y="1655064"/>
+            <a:ext cx="2066543" cy="1088135"/>
           </a:xfrm>
           <a:prstGeom prst="rect">
             <a:avLst/>
@@ -5424,17 +4832,84 @@
           <a:noFill/>
         </p:spPr>
         <p:txBody>
-          <a:bodyPr wrap="square" anchor="t" lIns="36576" rIns="36576" tIns="36576" bIns="36576">
+          <a:bodyPr wrap="square" anchor="t" lIns="27432" rIns="27432" tIns="27432" bIns="27432">
             <a:noAutofit/>
           </a:bodyPr>
           <a:lstStyle/>
           <a:p>
             <a:pPr algn="l">
+              <a:lnSpc>
+                <a:spcPct val="104000"/>
+              </a:lnSpc>
               <a:spcBef>
                 <a:spcPts val="0"/>
               </a:spcBef>
               <a:spcAft>
-                <a:spcPts val="500"/>
+                <a:spcPts val="300"/>
+              </a:spcAft>
+            </a:pPr>
+            <a:r>
+              <a:rPr sz="950" b="0">
+                <a:solidFill>
+                  <a:srgbClr val="1F3247"/>
+                </a:solidFill>
+                <a:latin typeface="Calibri"/>
+              </a:rPr>
+              <a:t>Best-of-K fidelity distillation improves the parser; a matched control shows the retrieval reward is unnecessary.</a:t>
+            </a:r>
+          </a:p>
+        </p:txBody>
+      </p:sp>
+      <p:sp>
+        <p:nvSpPr>
+          <p:cNvPr id="42" name="Rounded Rectangle 41"/>
+          <p:cNvSpPr/>
+          <p:nvPr/>
+        </p:nvSpPr>
+        <p:spPr>
+          <a:xfrm>
+            <a:off x="7982711" y="2761487"/>
+            <a:ext cx="2066543" cy="329184"/>
+          </a:xfrm>
+          <a:prstGeom prst="roundRect">
+            <a:avLst>
+              <a:gd name="adj" fmla="val 12000"/>
+            </a:avLst>
+          </a:prstGeom>
+          <a:solidFill>
+            <a:srgbClr val="FFF3E0"/>
+          </a:solidFill>
+          <a:ln>
+            <a:noFill/>
+          </a:ln>
+          <a:effectLst/>
+        </p:spPr>
+        <p:style>
+          <a:lnRef idx="1">
+            <a:schemeClr val="accent1"/>
+          </a:lnRef>
+          <a:fillRef idx="3">
+            <a:schemeClr val="accent1"/>
+          </a:fillRef>
+          <a:effectRef idx="2">
+            <a:schemeClr val="accent1"/>
+          </a:effectRef>
+          <a:fontRef idx="minor">
+            <a:schemeClr val="lt1"/>
+          </a:fontRef>
+        </p:style>
+        <p:txBody>
+          <a:bodyPr rtlCol="0" anchor="ctr" wrap="square" lIns="27432" rIns="27432" tIns="27432" bIns="27432">
+            <a:noAutofit/>
+          </a:bodyPr>
+          <a:lstStyle/>
+          <a:p>
+            <a:pPr algn="ctr">
+              <a:spcBef>
+                <a:spcPts val="0"/>
+              </a:spcBef>
+              <a:spcAft>
+                <a:spcPts val="300"/>
               </a:spcAft>
             </a:pPr>
             <a:r>
@@ -5444,20 +4919,119 @@
                 </a:solidFill>
                 <a:latin typeface="Calibri"/>
               </a:rPr>
-              <a:t>C4  </a:t>
-            </a:r>
-            <a:r>
-              <a:rPr sz="950" b="0">
-                <a:solidFill>
-                  <a:srgbClr val="1F3247"/>
-                </a:solidFill>
-                <a:latin typeface="Calibri"/>
-              </a:rPr>
-              <a:t>Best-of-K fidelity distillation: +1.22 pp Hit@5 (OHR-Bench). A matched control shows the retrieval reward is unnecessary.</a:t>
-            </a:r>
-          </a:p>
-        </p:txBody>
-      </p:sp>
+              <a:t>+1.22 pp Hit@5  (OHR-Bench)</a:t>
+            </a:r>
+          </a:p>
+        </p:txBody>
+      </p:sp>
+      <p:cxnSp>
+        <p:nvCxnSpPr>
+          <p:cNvPr id="43" name="Connector 42"/>
+          <p:cNvCxnSpPr/>
+          <p:nvPr/>
+        </p:nvCxnSpPr>
+        <p:spPr>
+          <a:xfrm>
+            <a:off x="2450592" y="2130552"/>
+            <a:ext cx="283464" cy="0"/>
+          </a:xfrm>
+          <a:prstGeom prst="line">
+            <a:avLst/>
+          </a:prstGeom>
+          <a:ln w="25400">
+            <a:solidFill>
+              <a:srgbClr val="90A4AE"/>
+            </a:solidFill>
+            <a:tailEnd type="triangle" w="med" len="med"/>
+          </a:ln>
+        </p:spPr>
+        <p:style>
+          <a:lnRef idx="2">
+            <a:schemeClr val="accent1"/>
+          </a:lnRef>
+          <a:fillRef idx="0">
+            <a:schemeClr val="accent1"/>
+          </a:fillRef>
+          <a:effectRef idx="1">
+            <a:schemeClr val="accent1"/>
+          </a:effectRef>
+          <a:fontRef idx="minor">
+            <a:schemeClr val="tx1"/>
+          </a:fontRef>
+        </p:style>
+      </p:cxnSp>
+      <p:cxnSp>
+        <p:nvCxnSpPr>
+          <p:cNvPr id="44" name="Connector 43"/>
+          <p:cNvCxnSpPr/>
+          <p:nvPr/>
+        </p:nvCxnSpPr>
+        <p:spPr>
+          <a:xfrm>
+            <a:off x="5020056" y="2130552"/>
+            <a:ext cx="283464" cy="0"/>
+          </a:xfrm>
+          <a:prstGeom prst="line">
+            <a:avLst/>
+          </a:prstGeom>
+          <a:ln w="25400">
+            <a:solidFill>
+              <a:srgbClr val="90A4AE"/>
+            </a:solidFill>
+            <a:tailEnd type="triangle" w="med" len="med"/>
+          </a:ln>
+        </p:spPr>
+        <p:style>
+          <a:lnRef idx="2">
+            <a:schemeClr val="accent1"/>
+          </a:lnRef>
+          <a:fillRef idx="0">
+            <a:schemeClr val="accent1"/>
+          </a:fillRef>
+          <a:effectRef idx="1">
+            <a:schemeClr val="accent1"/>
+          </a:effectRef>
+          <a:fontRef idx="minor">
+            <a:schemeClr val="tx1"/>
+          </a:fontRef>
+        </p:style>
+      </p:cxnSp>
+      <p:cxnSp>
+        <p:nvCxnSpPr>
+          <p:cNvPr id="45" name="Connector 44"/>
+          <p:cNvCxnSpPr/>
+          <p:nvPr/>
+        </p:nvCxnSpPr>
+        <p:spPr>
+          <a:xfrm>
+            <a:off x="7589520" y="2130552"/>
+            <a:ext cx="283463" cy="0"/>
+          </a:xfrm>
+          <a:prstGeom prst="line">
+            <a:avLst/>
+          </a:prstGeom>
+          <a:ln w="25400">
+            <a:solidFill>
+              <a:srgbClr val="90A4AE"/>
+            </a:solidFill>
+            <a:tailEnd type="triangle" w="med" len="med"/>
+          </a:ln>
+        </p:spPr>
+        <p:style>
+          <a:lnRef idx="2">
+            <a:schemeClr val="accent1"/>
+          </a:lnRef>
+          <a:fillRef idx="0">
+            <a:schemeClr val="accent1"/>
+          </a:fillRef>
+          <a:effectRef idx="1">
+            <a:schemeClr val="accent1"/>
+          </a:effectRef>
+          <a:fontRef idx="minor">
+            <a:schemeClr val="tx1"/>
+          </a:fontRef>
+        </p:style>
+      </p:cxnSp>
     </p:spTree>
   </p:cSld>
   <p:clrMapOvr>

</xml_diff>

<commit_message>
fig: Figure 1 overview — back to pipeline + zones, drop the cryptic badges
Revert the four-card redesign to the more readable pipeline + three-zone layout,
and fix the C1-C4 part by removing the in-pipeline badges entirely: the bare
"C4" tag conveyed nothing and overlapped the PaddleOCR logo label. The
contributions now read solely in the three colour zones (Diagnose = C1+C2 /
Select = C3 / Improve = C4), each with a full one-line description, so nothing
is cryptic and nothing is covered. Parse box "fine-tune → Prod (2B)" recentred.
</commit_message>
<xml_diff>
--- a/paper/figures/fig1_overview.pptx
+++ b/paper/figures/fig1_overview.pptx
@@ -7,7 +7,7 @@
   <p:sldIdLst>
     <p:sldId id="256" r:id="rId7"/>
   </p:sldIdLst>
-  <p:sldSz cx="10332720" cy="3310128" type="screen4x3"/>
+  <p:sldSz cx="10332720" cy="3931920" type="screen4x3"/>
   <p:notesSz cx="6858000" cy="9144000"/>
   <p:defaultTextStyle>
     <a:defPPr>
@@ -3096,21 +3096,19 @@
         </p:nvSpPr>
         <p:spPr>
           <a:xfrm>
-            <a:off x="182880" y="128016"/>
-            <a:ext cx="1773936" cy="676656"/>
+            <a:off x="182880" y="146304"/>
+            <a:ext cx="1691640" cy="310896"/>
           </a:xfrm>
           <a:prstGeom prst="roundRect">
             <a:avLst>
-              <a:gd name="adj" fmla="val 10000"/>
+              <a:gd name="adj" fmla="val 18000"/>
             </a:avLst>
           </a:prstGeom>
           <a:solidFill>
-            <a:srgbClr val="F4F6F7"/>
+            <a:srgbClr val="37474F"/>
           </a:solidFill>
-          <a:ln w="11430">
-            <a:solidFill>
-              <a:srgbClr val="CFD8DC"/>
-            </a:solidFill>
+          <a:ln>
+            <a:noFill/>
           </a:ln>
           <a:effectLst/>
         </p:spPr>
@@ -3129,31 +3127,7 @@
           </a:fontRef>
         </p:style>
         <p:txBody>
-          <a:bodyPr rtlCol="0" anchor="ctr"/>
-          <a:lstStyle/>
-          <a:p>
-            <a:pPr algn="ctr"/>
-          </a:p>
-        </p:txBody>
-      </p:sp>
-      <p:sp>
-        <p:nvSpPr>
-          <p:cNvPr id="3" name="TextBox 2"/>
-          <p:cNvSpPr txBox="1"/>
-          <p:nvPr/>
-        </p:nvSpPr>
-        <p:spPr>
-          <a:xfrm>
-            <a:off x="182880" y="164592"/>
-            <a:ext cx="1773936" cy="164592"/>
-          </a:xfrm>
-          <a:prstGeom prst="rect">
-            <a:avLst/>
-          </a:prstGeom>
-          <a:noFill/>
-        </p:spPr>
-        <p:txBody>
-          <a:bodyPr wrap="square" anchor="ctr" lIns="18288" rIns="18288" tIns="18288" bIns="18288">
+          <a:bodyPr rtlCol="0" anchor="ctr" wrap="square" lIns="18288" rIns="18288" tIns="18288" bIns="18288">
             <a:noAutofit/>
           </a:bodyPr>
           <a:lstStyle/>
@@ -3167,9 +3141,9 @@
               </a:spcAft>
             </a:pPr>
             <a:r>
-              <a:rPr sz="900" b="1">
+              <a:rPr sz="1250" b="1">
                 <a:solidFill>
-                  <a:srgbClr val="546E7A"/>
+                  <a:srgbClr val="FFFFFF"/>
                 </a:solidFill>
                 <a:latin typeface="Calibri"/>
               </a:rPr>
@@ -3180,27 +3154,25 @@
       </p:sp>
       <p:sp>
         <p:nvSpPr>
-          <p:cNvPr id="4" name="Rounded Rectangle 3"/>
+          <p:cNvPr id="3" name="Rounded Rectangle 2"/>
           <p:cNvSpPr/>
           <p:nvPr/>
         </p:nvSpPr>
         <p:spPr>
           <a:xfrm>
-            <a:off x="2231136" y="128016"/>
-            <a:ext cx="1773936" cy="676656"/>
+            <a:off x="2240280" y="146304"/>
+            <a:ext cx="1691640" cy="310896"/>
           </a:xfrm>
           <a:prstGeom prst="roundRect">
             <a:avLst>
-              <a:gd name="adj" fmla="val 10000"/>
+              <a:gd name="adj" fmla="val 18000"/>
             </a:avLst>
           </a:prstGeom>
           <a:solidFill>
-            <a:srgbClr val="F4F6F7"/>
+            <a:srgbClr val="37474F"/>
           </a:solidFill>
-          <a:ln w="11430">
-            <a:solidFill>
-              <a:srgbClr val="CFD8DC"/>
-            </a:solidFill>
+          <a:ln>
+            <a:noFill/>
           </a:ln>
           <a:effectLst/>
         </p:spPr>
@@ -3219,31 +3191,7 @@
           </a:fontRef>
         </p:style>
         <p:txBody>
-          <a:bodyPr rtlCol="0" anchor="ctr"/>
-          <a:lstStyle/>
-          <a:p>
-            <a:pPr algn="ctr"/>
-          </a:p>
-        </p:txBody>
-      </p:sp>
-      <p:sp>
-        <p:nvSpPr>
-          <p:cNvPr id="5" name="TextBox 4"/>
-          <p:cNvSpPr txBox="1"/>
-          <p:nvPr/>
-        </p:nvSpPr>
-        <p:spPr>
-          <a:xfrm>
-            <a:off x="2231136" y="164592"/>
-            <a:ext cx="1773936" cy="164592"/>
-          </a:xfrm>
-          <a:prstGeom prst="rect">
-            <a:avLst/>
-          </a:prstGeom>
-          <a:noFill/>
-        </p:spPr>
-        <p:txBody>
-          <a:bodyPr wrap="square" anchor="ctr" lIns="18288" rIns="18288" tIns="18288" bIns="18288">
+          <a:bodyPr rtlCol="0" anchor="ctr" wrap="square" lIns="18288" rIns="18288" tIns="18288" bIns="18288">
             <a:noAutofit/>
           </a:bodyPr>
           <a:lstStyle/>
@@ -3257,9 +3205,9 @@
               </a:spcAft>
             </a:pPr>
             <a:r>
-              <a:rPr sz="900" b="1">
+              <a:rPr sz="1250" b="1">
                 <a:solidFill>
-                  <a:srgbClr val="546E7A"/>
+                  <a:srgbClr val="FFFFFF"/>
                 </a:solidFill>
                 <a:latin typeface="Calibri"/>
               </a:rPr>
@@ -3270,27 +3218,25 @@
       </p:sp>
       <p:sp>
         <p:nvSpPr>
-          <p:cNvPr id="6" name="Rounded Rectangle 5"/>
+          <p:cNvPr id="4" name="Rounded Rectangle 3"/>
           <p:cNvSpPr/>
           <p:nvPr/>
         </p:nvSpPr>
         <p:spPr>
           <a:xfrm>
-            <a:off x="4279392" y="128016"/>
-            <a:ext cx="1773936" cy="676656"/>
+            <a:off x="4297680" y="146304"/>
+            <a:ext cx="1691640" cy="310896"/>
           </a:xfrm>
           <a:prstGeom prst="roundRect">
             <a:avLst>
-              <a:gd name="adj" fmla="val 10000"/>
+              <a:gd name="adj" fmla="val 18000"/>
             </a:avLst>
           </a:prstGeom>
           <a:solidFill>
-            <a:srgbClr val="F4F6F7"/>
+            <a:srgbClr val="37474F"/>
           </a:solidFill>
-          <a:ln w="11430">
-            <a:solidFill>
-              <a:srgbClr val="CFD8DC"/>
-            </a:solidFill>
+          <a:ln>
+            <a:noFill/>
           </a:ln>
           <a:effectLst/>
         </p:spPr>
@@ -3309,31 +3255,7 @@
           </a:fontRef>
         </p:style>
         <p:txBody>
-          <a:bodyPr rtlCol="0" anchor="ctr"/>
-          <a:lstStyle/>
-          <a:p>
-            <a:pPr algn="ctr"/>
-          </a:p>
-        </p:txBody>
-      </p:sp>
-      <p:sp>
-        <p:nvSpPr>
-          <p:cNvPr id="7" name="TextBox 6"/>
-          <p:cNvSpPr txBox="1"/>
-          <p:nvPr/>
-        </p:nvSpPr>
-        <p:spPr>
-          <a:xfrm>
-            <a:off x="4279392" y="164592"/>
-            <a:ext cx="1773936" cy="164592"/>
-          </a:xfrm>
-          <a:prstGeom prst="rect">
-            <a:avLst/>
-          </a:prstGeom>
-          <a:noFill/>
-        </p:spPr>
-        <p:txBody>
-          <a:bodyPr wrap="square" anchor="ctr" lIns="18288" rIns="18288" tIns="18288" bIns="18288">
+          <a:bodyPr rtlCol="0" anchor="ctr" wrap="square" lIns="18288" rIns="18288" tIns="18288" bIns="18288">
             <a:noAutofit/>
           </a:bodyPr>
           <a:lstStyle/>
@@ -3347,9 +3269,9 @@
               </a:spcAft>
             </a:pPr>
             <a:r>
-              <a:rPr sz="900" b="1">
+              <a:rPr sz="1250" b="1">
                 <a:solidFill>
-                  <a:srgbClr val="546E7A"/>
+                  <a:srgbClr val="FFFFFF"/>
                 </a:solidFill>
                 <a:latin typeface="Calibri"/>
               </a:rPr>
@@ -3360,27 +3282,25 @@
       </p:sp>
       <p:sp>
         <p:nvSpPr>
-          <p:cNvPr id="8" name="Rounded Rectangle 7"/>
+          <p:cNvPr id="5" name="Rounded Rectangle 4"/>
           <p:cNvSpPr/>
           <p:nvPr/>
         </p:nvSpPr>
         <p:spPr>
           <a:xfrm>
-            <a:off x="6327648" y="128016"/>
-            <a:ext cx="1773936" cy="676656"/>
+            <a:off x="6355080" y="146304"/>
+            <a:ext cx="1691640" cy="310896"/>
           </a:xfrm>
           <a:prstGeom prst="roundRect">
             <a:avLst>
-              <a:gd name="adj" fmla="val 10000"/>
+              <a:gd name="adj" fmla="val 18000"/>
             </a:avLst>
           </a:prstGeom>
           <a:solidFill>
-            <a:srgbClr val="F4F6F7"/>
+            <a:srgbClr val="37474F"/>
           </a:solidFill>
-          <a:ln w="11430">
-            <a:solidFill>
-              <a:srgbClr val="CFD8DC"/>
-            </a:solidFill>
+          <a:ln>
+            <a:noFill/>
           </a:ln>
           <a:effectLst/>
         </p:spPr>
@@ -3399,31 +3319,7 @@
           </a:fontRef>
         </p:style>
         <p:txBody>
-          <a:bodyPr rtlCol="0" anchor="ctr"/>
-          <a:lstStyle/>
-          <a:p>
-            <a:pPr algn="ctr"/>
-          </a:p>
-        </p:txBody>
-      </p:sp>
-      <p:sp>
-        <p:nvSpPr>
-          <p:cNvPr id="9" name="TextBox 8"/>
-          <p:cNvSpPr txBox="1"/>
-          <p:nvPr/>
-        </p:nvSpPr>
-        <p:spPr>
-          <a:xfrm>
-            <a:off x="6327648" y="164592"/>
-            <a:ext cx="1773936" cy="164592"/>
-          </a:xfrm>
-          <a:prstGeom prst="rect">
-            <a:avLst/>
-          </a:prstGeom>
-          <a:noFill/>
-        </p:spPr>
-        <p:txBody>
-          <a:bodyPr wrap="square" anchor="ctr" lIns="18288" rIns="18288" tIns="18288" bIns="18288">
+          <a:bodyPr rtlCol="0" anchor="ctr" wrap="square" lIns="18288" rIns="18288" tIns="18288" bIns="18288">
             <a:noAutofit/>
           </a:bodyPr>
           <a:lstStyle/>
@@ -3437,9 +3333,9 @@
               </a:spcAft>
             </a:pPr>
             <a:r>
-              <a:rPr sz="900" b="1">
+              <a:rPr sz="1250" b="1">
                 <a:solidFill>
-                  <a:srgbClr val="546E7A"/>
+                  <a:srgbClr val="FFFFFF"/>
                 </a:solidFill>
                 <a:latin typeface="Calibri"/>
               </a:rPr>
@@ -3450,27 +3346,25 @@
       </p:sp>
       <p:sp>
         <p:nvSpPr>
-          <p:cNvPr id="10" name="Rounded Rectangle 9"/>
+          <p:cNvPr id="6" name="Rounded Rectangle 5"/>
           <p:cNvSpPr/>
           <p:nvPr/>
         </p:nvSpPr>
         <p:spPr>
           <a:xfrm>
-            <a:off x="8375904" y="128016"/>
-            <a:ext cx="1773936" cy="676656"/>
+            <a:off x="8412480" y="146304"/>
+            <a:ext cx="1691640" cy="310896"/>
           </a:xfrm>
           <a:prstGeom prst="roundRect">
             <a:avLst>
-              <a:gd name="adj" fmla="val 10000"/>
+              <a:gd name="adj" fmla="val 18000"/>
             </a:avLst>
           </a:prstGeom>
           <a:solidFill>
-            <a:srgbClr val="F4F6F7"/>
+            <a:srgbClr val="37474F"/>
           </a:solidFill>
-          <a:ln w="11430">
-            <a:solidFill>
-              <a:srgbClr val="CFD8DC"/>
-            </a:solidFill>
+          <a:ln>
+            <a:noFill/>
           </a:ln>
           <a:effectLst/>
         </p:spPr>
@@ -3489,31 +3383,7 @@
           </a:fontRef>
         </p:style>
         <p:txBody>
-          <a:bodyPr rtlCol="0" anchor="ctr"/>
-          <a:lstStyle/>
-          <a:p>
-            <a:pPr algn="ctr"/>
-          </a:p>
-        </p:txBody>
-      </p:sp>
-      <p:sp>
-        <p:nvSpPr>
-          <p:cNvPr id="11" name="TextBox 10"/>
-          <p:cNvSpPr txBox="1"/>
-          <p:nvPr/>
-        </p:nvSpPr>
-        <p:spPr>
-          <a:xfrm>
-            <a:off x="8375904" y="164592"/>
-            <a:ext cx="1773936" cy="164592"/>
-          </a:xfrm>
-          <a:prstGeom prst="rect">
-            <a:avLst/>
-          </a:prstGeom>
-          <a:noFill/>
-        </p:spPr>
-        <p:txBody>
-          <a:bodyPr wrap="square" anchor="ctr" lIns="18288" rIns="18288" tIns="18288" bIns="18288">
+          <a:bodyPr rtlCol="0" anchor="ctr" wrap="square" lIns="18288" rIns="18288" tIns="18288" bIns="18288">
             <a:noAutofit/>
           </a:bodyPr>
           <a:lstStyle/>
@@ -3527,9 +3397,9 @@
               </a:spcAft>
             </a:pPr>
             <a:r>
-              <a:rPr sz="900" b="1">
+              <a:rPr sz="1250" b="1">
                 <a:solidFill>
-                  <a:srgbClr val="546E7A"/>
+                  <a:srgbClr val="FFFFFF"/>
                 </a:solidFill>
                 <a:latin typeface="Calibri"/>
               </a:rPr>
@@ -3538,9 +3408,57 @@
           </a:p>
         </p:txBody>
       </p:sp>
+      <p:sp>
+        <p:nvSpPr>
+          <p:cNvPr id="7" name="Rounded Rectangle 6"/>
+          <p:cNvSpPr/>
+          <p:nvPr/>
+        </p:nvSpPr>
+        <p:spPr>
+          <a:xfrm>
+            <a:off x="182880" y="548640"/>
+            <a:ext cx="1691640" cy="1335024"/>
+          </a:xfrm>
+          <a:prstGeom prst="roundRect">
+            <a:avLst>
+              <a:gd name="adj" fmla="val 6000"/>
+            </a:avLst>
+          </a:prstGeom>
+          <a:solidFill>
+            <a:srgbClr val="FFFFFF"/>
+          </a:solidFill>
+          <a:ln w="13970">
+            <a:solidFill>
+              <a:srgbClr val="B0BEC5"/>
+            </a:solidFill>
+          </a:ln>
+          <a:effectLst/>
+        </p:spPr>
+        <p:style>
+          <a:lnRef idx="1">
+            <a:schemeClr val="accent1"/>
+          </a:lnRef>
+          <a:fillRef idx="3">
+            <a:schemeClr val="accent1"/>
+          </a:fillRef>
+          <a:effectRef idx="2">
+            <a:schemeClr val="accent1"/>
+          </a:effectRef>
+          <a:fontRef idx="minor">
+            <a:schemeClr val="lt1"/>
+          </a:fontRef>
+        </p:style>
+        <p:txBody>
+          <a:bodyPr rtlCol="0" anchor="ctr"/>
+          <a:lstStyle/>
+          <a:p>
+            <a:pPr algn="ctr"/>
+          </a:p>
+        </p:txBody>
+      </p:sp>
       <p:pic>
         <p:nvPicPr>
-          <p:cNvPr id="12" name="Picture 11" descr="document.png"/>
+          <p:cNvPr id="8" name="Picture 7" descr="document.png"/>
           <p:cNvPicPr>
             <a:picLocks noChangeAspect="1"/>
           </p:cNvPicPr>
@@ -3554,17 +3472,126 @@
         </p:blipFill>
         <p:spPr>
           <a:xfrm>
-            <a:off x="923544" y="365760"/>
-            <a:ext cx="292608" cy="292608"/>
+            <a:off x="772668" y="694944"/>
+            <a:ext cx="512064" cy="512064"/>
           </a:xfrm>
           <a:prstGeom prst="rect">
             <a:avLst/>
           </a:prstGeom>
         </p:spPr>
       </p:pic>
+      <p:sp>
+        <p:nvSpPr>
+          <p:cNvPr id="9" name="TextBox 8"/>
+          <p:cNvSpPr txBox="1"/>
+          <p:nvPr/>
+        </p:nvSpPr>
+        <p:spPr>
+          <a:xfrm>
+            <a:off x="182880" y="1426464"/>
+            <a:ext cx="1691640" cy="420624"/>
+          </a:xfrm>
+          <a:prstGeom prst="rect">
+            <a:avLst/>
+          </a:prstGeom>
+          <a:noFill/>
+        </p:spPr>
+        <p:txBody>
+          <a:bodyPr wrap="square" anchor="t" lIns="45720" rIns="45720" tIns="36576" bIns="36576">
+            <a:noAutofit/>
+          </a:bodyPr>
+          <a:lstStyle/>
+          <a:p>
+            <a:pPr algn="ctr">
+              <a:spcBef>
+                <a:spcPts val="0"/>
+              </a:spcBef>
+              <a:spcAft>
+                <a:spcPts val="100"/>
+              </a:spcAft>
+            </a:pPr>
+            <a:r>
+              <a:rPr sz="1100" b="1">
+                <a:solidFill>
+                  <a:srgbClr val="1F3247"/>
+                </a:solidFill>
+                <a:latin typeface="Calibri"/>
+              </a:rPr>
+              <a:t>Korean gov doc</a:t>
+            </a:r>
+          </a:p>
+          <a:p>
+            <a:pPr algn="ctr">
+              <a:spcBef>
+                <a:spcPts val="0"/>
+              </a:spcBef>
+              <a:spcAft>
+                <a:spcPts val="400"/>
+              </a:spcAft>
+            </a:pPr>
+            <a:r>
+              <a:rPr sz="850" b="0">
+                <a:solidFill>
+                  <a:srgbClr val="546E7A"/>
+                </a:solidFill>
+                <a:latin typeface="Calibri"/>
+              </a:rPr>
+              <a:t>PDF / scanned page</a:t>
+            </a:r>
+          </a:p>
+        </p:txBody>
+      </p:sp>
+      <p:sp>
+        <p:nvSpPr>
+          <p:cNvPr id="10" name="Rounded Rectangle 9"/>
+          <p:cNvSpPr/>
+          <p:nvPr/>
+        </p:nvSpPr>
+        <p:spPr>
+          <a:xfrm>
+            <a:off x="4297680" y="548640"/>
+            <a:ext cx="1691640" cy="1335024"/>
+          </a:xfrm>
+          <a:prstGeom prst="roundRect">
+            <a:avLst>
+              <a:gd name="adj" fmla="val 6000"/>
+            </a:avLst>
+          </a:prstGeom>
+          <a:solidFill>
+            <a:srgbClr val="FFFFFF"/>
+          </a:solidFill>
+          <a:ln w="13970">
+            <a:solidFill>
+              <a:srgbClr val="B0BEC5"/>
+            </a:solidFill>
+          </a:ln>
+          <a:effectLst/>
+        </p:spPr>
+        <p:style>
+          <a:lnRef idx="1">
+            <a:schemeClr val="accent1"/>
+          </a:lnRef>
+          <a:fillRef idx="3">
+            <a:schemeClr val="accent1"/>
+          </a:fillRef>
+          <a:effectRef idx="2">
+            <a:schemeClr val="accent1"/>
+          </a:effectRef>
+          <a:fontRef idx="minor">
+            <a:schemeClr val="lt1"/>
+          </a:fontRef>
+        </p:style>
+        <p:txBody>
+          <a:bodyPr rtlCol="0" anchor="ctr"/>
+          <a:lstStyle/>
+          <a:p>
+            <a:pPr algn="ctr"/>
+          </a:p>
+        </p:txBody>
+      </p:sp>
       <p:pic>
         <p:nvPicPr>
-          <p:cNvPr id="13" name="Picture 12" descr="qwen.png"/>
+          <p:cNvPr id="11" name="Picture 10" descr="chunk.png"/>
           <p:cNvPicPr>
             <a:picLocks noChangeAspect="1"/>
           </p:cNvPicPr>
@@ -3578,17 +3605,126 @@
         </p:blipFill>
         <p:spPr>
           <a:xfrm>
-            <a:off x="2473452" y="420623"/>
-            <a:ext cx="274320" cy="274320"/>
+            <a:off x="4887468" y="694944"/>
+            <a:ext cx="512064" cy="512064"/>
           </a:xfrm>
           <a:prstGeom prst="rect">
             <a:avLst/>
           </a:prstGeom>
         </p:spPr>
       </p:pic>
+      <p:sp>
+        <p:nvSpPr>
+          <p:cNvPr id="12" name="TextBox 11"/>
+          <p:cNvSpPr txBox="1"/>
+          <p:nvPr/>
+        </p:nvSpPr>
+        <p:spPr>
+          <a:xfrm>
+            <a:off x="4297680" y="1426464"/>
+            <a:ext cx="1691640" cy="420624"/>
+          </a:xfrm>
+          <a:prstGeom prst="rect">
+            <a:avLst/>
+          </a:prstGeom>
+          <a:noFill/>
+        </p:spPr>
+        <p:txBody>
+          <a:bodyPr wrap="square" anchor="t" lIns="45720" rIns="45720" tIns="36576" bIns="36576">
+            <a:noAutofit/>
+          </a:bodyPr>
+          <a:lstStyle/>
+          <a:p>
+            <a:pPr algn="ctr">
+              <a:spcBef>
+                <a:spcPts val="0"/>
+              </a:spcBef>
+              <a:spcAft>
+                <a:spcPts val="100"/>
+              </a:spcAft>
+            </a:pPr>
+            <a:r>
+              <a:rPr sz="1100" b="1">
+                <a:solidFill>
+                  <a:srgbClr val="1F3247"/>
+                </a:solidFill>
+                <a:latin typeface="Calibri"/>
+              </a:rPr>
+              <a:t>Chunker</a:t>
+            </a:r>
+          </a:p>
+          <a:p>
+            <a:pPr algn="ctr">
+              <a:spcBef>
+                <a:spcPts val="0"/>
+              </a:spcBef>
+              <a:spcAft>
+                <a:spcPts val="400"/>
+              </a:spcAft>
+            </a:pPr>
+            <a:r>
+              <a:rPr sz="850" b="0">
+                <a:solidFill>
+                  <a:srgbClr val="546E7A"/>
+                </a:solidFill>
+                <a:latin typeface="Calibri"/>
+              </a:rPr>
+              <a:t>md-header · native · fixed</a:t>
+            </a:r>
+          </a:p>
+        </p:txBody>
+      </p:sp>
+      <p:sp>
+        <p:nvSpPr>
+          <p:cNvPr id="13" name="Rounded Rectangle 12"/>
+          <p:cNvSpPr/>
+          <p:nvPr/>
+        </p:nvSpPr>
+        <p:spPr>
+          <a:xfrm>
+            <a:off x="8412480" y="548640"/>
+            <a:ext cx="1691640" cy="1335024"/>
+          </a:xfrm>
+          <a:prstGeom prst="roundRect">
+            <a:avLst>
+              <a:gd name="adj" fmla="val 6000"/>
+            </a:avLst>
+          </a:prstGeom>
+          <a:solidFill>
+            <a:srgbClr val="FFFFFF"/>
+          </a:solidFill>
+          <a:ln w="13970">
+            <a:solidFill>
+              <a:srgbClr val="B0BEC5"/>
+            </a:solidFill>
+          </a:ln>
+          <a:effectLst/>
+        </p:spPr>
+        <p:style>
+          <a:lnRef idx="1">
+            <a:schemeClr val="accent1"/>
+          </a:lnRef>
+          <a:fillRef idx="3">
+            <a:schemeClr val="accent1"/>
+          </a:fillRef>
+          <a:effectRef idx="2">
+            <a:schemeClr val="accent1"/>
+          </a:effectRef>
+          <a:fontRef idx="minor">
+            <a:schemeClr val="lt1"/>
+          </a:fontRef>
+        </p:style>
+        <p:txBody>
+          <a:bodyPr rtlCol="0" anchor="ctr"/>
+          <a:lstStyle/>
+          <a:p>
+            <a:pPr algn="ctr"/>
+          </a:p>
+        </p:txBody>
+      </p:sp>
       <p:pic>
         <p:nvPicPr>
-          <p:cNvPr id="14" name="Picture 13" descr="mineru.png"/>
+          <p:cNvPr id="14" name="Picture 13" descr="answer.png"/>
           <p:cNvPicPr>
             <a:picLocks noChangeAspect="1"/>
           </p:cNvPicPr>
@@ -3602,17 +3738,168 @@
         </p:blipFill>
         <p:spPr>
           <a:xfrm>
-            <a:off x="2811780" y="420623"/>
-            <a:ext cx="274320" cy="274320"/>
+            <a:off x="9002268" y="694944"/>
+            <a:ext cx="512064" cy="512064"/>
           </a:xfrm>
           <a:prstGeom prst="rect">
             <a:avLst/>
           </a:prstGeom>
         </p:spPr>
       </p:pic>
+      <p:sp>
+        <p:nvSpPr>
+          <p:cNvPr id="15" name="TextBox 14"/>
+          <p:cNvSpPr txBox="1"/>
+          <p:nvPr/>
+        </p:nvSpPr>
+        <p:spPr>
+          <a:xfrm>
+            <a:off x="8412480" y="1426464"/>
+            <a:ext cx="1691640" cy="420624"/>
+          </a:xfrm>
+          <a:prstGeom prst="rect">
+            <a:avLst/>
+          </a:prstGeom>
+          <a:noFill/>
+        </p:spPr>
+        <p:txBody>
+          <a:bodyPr wrap="square" anchor="t" lIns="45720" rIns="45720" tIns="36576" bIns="36576">
+            <a:noAutofit/>
+          </a:bodyPr>
+          <a:lstStyle/>
+          <a:p>
+            <a:pPr algn="ctr">
+              <a:spcBef>
+                <a:spcPts val="0"/>
+              </a:spcBef>
+              <a:spcAft>
+                <a:spcPts val="100"/>
+              </a:spcAft>
+            </a:pPr>
+            <a:r>
+              <a:rPr sz="1100" b="1">
+                <a:solidFill>
+                  <a:srgbClr val="1F3247"/>
+                </a:solidFill>
+                <a:latin typeface="Calibri"/>
+              </a:rPr>
+              <a:t>RAG answer</a:t>
+            </a:r>
+          </a:p>
+          <a:p>
+            <a:pPr algn="ctr">
+              <a:spcBef>
+                <a:spcPts val="0"/>
+              </a:spcBef>
+              <a:spcAft>
+                <a:spcPts val="400"/>
+              </a:spcAft>
+            </a:pPr>
+            <a:r>
+              <a:rPr sz="850" b="0">
+                <a:solidFill>
+                  <a:srgbClr val="546E7A"/>
+                </a:solidFill>
+                <a:latin typeface="Calibri"/>
+              </a:rPr>
+              <a:t>grounded generation</a:t>
+            </a:r>
+          </a:p>
+        </p:txBody>
+      </p:sp>
+      <p:sp>
+        <p:nvSpPr>
+          <p:cNvPr id="16" name="Rounded Rectangle 15"/>
+          <p:cNvSpPr/>
+          <p:nvPr/>
+        </p:nvSpPr>
+        <p:spPr>
+          <a:xfrm>
+            <a:off x="2240280" y="548640"/>
+            <a:ext cx="1691640" cy="1335024"/>
+          </a:xfrm>
+          <a:prstGeom prst="roundRect">
+            <a:avLst>
+              <a:gd name="adj" fmla="val 6000"/>
+            </a:avLst>
+          </a:prstGeom>
+          <a:solidFill>
+            <a:srgbClr val="FFFFFF"/>
+          </a:solidFill>
+          <a:ln w="13970">
+            <a:solidFill>
+              <a:srgbClr val="B0BEC5"/>
+            </a:solidFill>
+          </a:ln>
+          <a:effectLst/>
+        </p:spPr>
+        <p:style>
+          <a:lnRef idx="1">
+            <a:schemeClr val="accent1"/>
+          </a:lnRef>
+          <a:fillRef idx="3">
+            <a:schemeClr val="accent1"/>
+          </a:fillRef>
+          <a:effectRef idx="2">
+            <a:schemeClr val="accent1"/>
+          </a:effectRef>
+          <a:fontRef idx="minor">
+            <a:schemeClr val="lt1"/>
+          </a:fontRef>
+        </p:style>
+        <p:txBody>
+          <a:bodyPr rtlCol="0" anchor="ctr"/>
+          <a:lstStyle/>
+          <a:p>
+            <a:pPr algn="ctr"/>
+          </a:p>
+        </p:txBody>
+      </p:sp>
+      <p:sp>
+        <p:nvSpPr>
+          <p:cNvPr id="17" name="TextBox 16"/>
+          <p:cNvSpPr txBox="1"/>
+          <p:nvPr/>
+        </p:nvSpPr>
+        <p:spPr>
+          <a:xfrm>
+            <a:off x="2240280" y="594360"/>
+            <a:ext cx="1691640" cy="201168"/>
+          </a:xfrm>
+          <a:prstGeom prst="rect">
+            <a:avLst/>
+          </a:prstGeom>
+          <a:noFill/>
+        </p:spPr>
+        <p:txBody>
+          <a:bodyPr wrap="square" anchor="ctr" lIns="18288" rIns="18288" tIns="18288" bIns="18288">
+            <a:noAutofit/>
+          </a:bodyPr>
+          <a:lstStyle/>
+          <a:p>
+            <a:pPr algn="ctr">
+              <a:spcBef>
+                <a:spcPts val="0"/>
+              </a:spcBef>
+              <a:spcAft>
+                <a:spcPts val="400"/>
+              </a:spcAft>
+            </a:pPr>
+            <a:r>
+              <a:rPr sz="1000" b="1">
+                <a:solidFill>
+                  <a:srgbClr val="1F3247"/>
+                </a:solidFill>
+                <a:latin typeface="Calibri"/>
+              </a:rPr>
+              <a:t>Parsers</a:t>
+            </a:r>
+          </a:p>
+        </p:txBody>
+      </p:sp>
       <p:pic>
         <p:nvPicPr>
-          <p:cNvPr id="15" name="Picture 14" descr="paddle.png"/>
+          <p:cNvPr id="18" name="Picture 17" descr="qwen.png"/>
           <p:cNvPicPr>
             <a:picLocks noChangeAspect="1"/>
           </p:cNvPicPr>
@@ -3626,17 +3913,59 @@
         </p:blipFill>
         <p:spPr>
           <a:xfrm>
-            <a:off x="3150108" y="420623"/>
-            <a:ext cx="274320" cy="274320"/>
+            <a:off x="2551816" y="822959"/>
+            <a:ext cx="277611" cy="277611"/>
           </a:xfrm>
           <a:prstGeom prst="rect">
             <a:avLst/>
           </a:prstGeom>
         </p:spPr>
       </p:pic>
+      <p:sp>
+        <p:nvSpPr>
+          <p:cNvPr id="19" name="TextBox 18"/>
+          <p:cNvSpPr txBox="1"/>
+          <p:nvPr/>
+        </p:nvSpPr>
+        <p:spPr>
+          <a:xfrm>
+            <a:off x="2295144" y="1109715"/>
+            <a:ext cx="790956" cy="133868"/>
+          </a:xfrm>
+          <a:prstGeom prst="rect">
+            <a:avLst/>
+          </a:prstGeom>
+          <a:noFill/>
+        </p:spPr>
+        <p:txBody>
+          <a:bodyPr wrap="square" anchor="t" lIns="0" rIns="0" tIns="0" bIns="0">
+            <a:noAutofit/>
+          </a:bodyPr>
+          <a:lstStyle/>
+          <a:p>
+            <a:pPr algn="ctr">
+              <a:spcBef>
+                <a:spcPts val="0"/>
+              </a:spcBef>
+              <a:spcAft>
+                <a:spcPts val="400"/>
+              </a:spcAft>
+            </a:pPr>
+            <a:r>
+              <a:rPr sz="650" b="0">
+                <a:solidFill>
+                  <a:srgbClr val="546E7A"/>
+                </a:solidFill>
+                <a:latin typeface="Calibri"/>
+              </a:rPr>
+              <a:t>Qwen-VL</a:t>
+            </a:r>
+          </a:p>
+        </p:txBody>
+      </p:sp>
       <p:pic>
         <p:nvPicPr>
-          <p:cNvPr id="16" name="Picture 15" descr="marker.png"/>
+          <p:cNvPr id="20" name="Picture 19" descr="mineru.png"/>
           <p:cNvPicPr>
             <a:picLocks noChangeAspect="1"/>
           </p:cNvPicPr>
@@ -3650,17 +3979,59 @@
         </p:blipFill>
         <p:spPr>
           <a:xfrm>
-            <a:off x="3488436" y="420623"/>
-            <a:ext cx="274320" cy="274320"/>
+            <a:off x="3342772" y="822959"/>
+            <a:ext cx="277611" cy="277611"/>
           </a:xfrm>
           <a:prstGeom prst="rect">
             <a:avLst/>
           </a:prstGeom>
         </p:spPr>
       </p:pic>
+      <p:sp>
+        <p:nvSpPr>
+          <p:cNvPr id="21" name="TextBox 20"/>
+          <p:cNvSpPr txBox="1"/>
+          <p:nvPr/>
+        </p:nvSpPr>
+        <p:spPr>
+          <a:xfrm>
+            <a:off x="3086100" y="1109715"/>
+            <a:ext cx="790956" cy="133868"/>
+          </a:xfrm>
+          <a:prstGeom prst="rect">
+            <a:avLst/>
+          </a:prstGeom>
+          <a:noFill/>
+        </p:spPr>
+        <p:txBody>
+          <a:bodyPr wrap="square" anchor="t" lIns="0" rIns="0" tIns="0" bIns="0">
+            <a:noAutofit/>
+          </a:bodyPr>
+          <a:lstStyle/>
+          <a:p>
+            <a:pPr algn="ctr">
+              <a:spcBef>
+                <a:spcPts val="0"/>
+              </a:spcBef>
+              <a:spcAft>
+                <a:spcPts val="400"/>
+              </a:spcAft>
+            </a:pPr>
+            <a:r>
+              <a:rPr sz="650" b="0">
+                <a:solidFill>
+                  <a:srgbClr val="546E7A"/>
+                </a:solidFill>
+                <a:latin typeface="Calibri"/>
+              </a:rPr>
+              <a:t>MinerU</a:t>
+            </a:r>
+          </a:p>
+        </p:txBody>
+      </p:sp>
       <p:pic>
         <p:nvPicPr>
-          <p:cNvPr id="17" name="Picture 16" descr="chunk.png"/>
+          <p:cNvPr id="22" name="Picture 21" descr="paddle.png"/>
           <p:cNvPicPr>
             <a:picLocks noChangeAspect="1"/>
           </p:cNvPicPr>
@@ -3674,17 +4045,59 @@
         </p:blipFill>
         <p:spPr>
           <a:xfrm>
-            <a:off x="5020056" y="365760"/>
-            <a:ext cx="292608" cy="292608"/>
+            <a:off x="2551816" y="1243584"/>
+            <a:ext cx="277611" cy="277611"/>
           </a:xfrm>
           <a:prstGeom prst="rect">
             <a:avLst/>
           </a:prstGeom>
         </p:spPr>
       </p:pic>
+      <p:sp>
+        <p:nvSpPr>
+          <p:cNvPr id="23" name="TextBox 22"/>
+          <p:cNvSpPr txBox="1"/>
+          <p:nvPr/>
+        </p:nvSpPr>
+        <p:spPr>
+          <a:xfrm>
+            <a:off x="2295144" y="1530339"/>
+            <a:ext cx="790956" cy="133868"/>
+          </a:xfrm>
+          <a:prstGeom prst="rect">
+            <a:avLst/>
+          </a:prstGeom>
+          <a:noFill/>
+        </p:spPr>
+        <p:txBody>
+          <a:bodyPr wrap="square" anchor="t" lIns="0" rIns="0" tIns="0" bIns="0">
+            <a:noAutofit/>
+          </a:bodyPr>
+          <a:lstStyle/>
+          <a:p>
+            <a:pPr algn="ctr">
+              <a:spcBef>
+                <a:spcPts val="0"/>
+              </a:spcBef>
+              <a:spcAft>
+                <a:spcPts val="400"/>
+              </a:spcAft>
+            </a:pPr>
+            <a:r>
+              <a:rPr sz="650" b="0">
+                <a:solidFill>
+                  <a:srgbClr val="546E7A"/>
+                </a:solidFill>
+                <a:latin typeface="Calibri"/>
+              </a:rPr>
+              <a:t>PaddleOCR</a:t>
+            </a:r>
+          </a:p>
+        </p:txBody>
+      </p:sp>
       <p:pic>
         <p:nvPicPr>
-          <p:cNvPr id="18" name="Picture 17" descr="bge.png"/>
+          <p:cNvPr id="24" name="Picture 23" descr="marker.png"/>
           <p:cNvPicPr>
             <a:picLocks noChangeAspect="1"/>
           </p:cNvPicPr>
@@ -3698,17 +4111,191 @@
         </p:blipFill>
         <p:spPr>
           <a:xfrm>
-            <a:off x="6711696" y="411479"/>
-            <a:ext cx="292608" cy="292608"/>
+            <a:off x="3342772" y="1243584"/>
+            <a:ext cx="277611" cy="277611"/>
           </a:xfrm>
           <a:prstGeom prst="rect">
             <a:avLst/>
           </a:prstGeom>
         </p:spPr>
       </p:pic>
+      <p:sp>
+        <p:nvSpPr>
+          <p:cNvPr id="25" name="TextBox 24"/>
+          <p:cNvSpPr txBox="1"/>
+          <p:nvPr/>
+        </p:nvSpPr>
+        <p:spPr>
+          <a:xfrm>
+            <a:off x="3086100" y="1530339"/>
+            <a:ext cx="790956" cy="133868"/>
+          </a:xfrm>
+          <a:prstGeom prst="rect">
+            <a:avLst/>
+          </a:prstGeom>
+          <a:noFill/>
+        </p:spPr>
+        <p:txBody>
+          <a:bodyPr wrap="square" anchor="t" lIns="0" rIns="0" tIns="0" bIns="0">
+            <a:noAutofit/>
+          </a:bodyPr>
+          <a:lstStyle/>
+          <a:p>
+            <a:pPr algn="ctr">
+              <a:spcBef>
+                <a:spcPts val="0"/>
+              </a:spcBef>
+              <a:spcAft>
+                <a:spcPts val="400"/>
+              </a:spcAft>
+            </a:pPr>
+            <a:r>
+              <a:rPr sz="650" b="0">
+                <a:solidFill>
+                  <a:srgbClr val="546E7A"/>
+                </a:solidFill>
+                <a:latin typeface="Calibri"/>
+              </a:rPr>
+              <a:t>Marker</a:t>
+            </a:r>
+          </a:p>
+        </p:txBody>
+      </p:sp>
+      <p:sp>
+        <p:nvSpPr>
+          <p:cNvPr id="26" name="TextBox 25"/>
+          <p:cNvSpPr txBox="1"/>
+          <p:nvPr/>
+        </p:nvSpPr>
+        <p:spPr>
+          <a:xfrm>
+            <a:off x="2240280" y="1600200"/>
+            <a:ext cx="1691640" cy="219456"/>
+          </a:xfrm>
+          <a:prstGeom prst="rect">
+            <a:avLst/>
+          </a:prstGeom>
+          <a:noFill/>
+        </p:spPr>
+        <p:txBody>
+          <a:bodyPr wrap="square" anchor="ctr" lIns="18288" rIns="18288" tIns="18288" bIns="18288">
+            <a:noAutofit/>
+          </a:bodyPr>
+          <a:lstStyle/>
+          <a:p>
+            <a:pPr algn="ctr">
+              <a:spcBef>
+                <a:spcPts val="0"/>
+              </a:spcBef>
+              <a:spcAft>
+                <a:spcPts val="400"/>
+              </a:spcAft>
+            </a:pPr>
+            <a:r>
+              <a:rPr sz="900" b="1">
+                <a:solidFill>
+                  <a:srgbClr val="00695C"/>
+                </a:solidFill>
+                <a:latin typeface="Calibri"/>
+              </a:rPr>
+              <a:t>fine-tune → Prod (2B)</a:t>
+            </a:r>
+          </a:p>
+        </p:txBody>
+      </p:sp>
+      <p:sp>
+        <p:nvSpPr>
+          <p:cNvPr id="27" name="Rounded Rectangle 26"/>
+          <p:cNvSpPr/>
+          <p:nvPr/>
+        </p:nvSpPr>
+        <p:spPr>
+          <a:xfrm>
+            <a:off x="6355080" y="548640"/>
+            <a:ext cx="1691640" cy="1335024"/>
+          </a:xfrm>
+          <a:prstGeom prst="roundRect">
+            <a:avLst>
+              <a:gd name="adj" fmla="val 6000"/>
+            </a:avLst>
+          </a:prstGeom>
+          <a:solidFill>
+            <a:srgbClr val="FFFFFF"/>
+          </a:solidFill>
+          <a:ln w="13970">
+            <a:solidFill>
+              <a:srgbClr val="B0BEC5"/>
+            </a:solidFill>
+          </a:ln>
+          <a:effectLst/>
+        </p:spPr>
+        <p:style>
+          <a:lnRef idx="1">
+            <a:schemeClr val="accent1"/>
+          </a:lnRef>
+          <a:fillRef idx="3">
+            <a:schemeClr val="accent1"/>
+          </a:fillRef>
+          <a:effectRef idx="2">
+            <a:schemeClr val="accent1"/>
+          </a:effectRef>
+          <a:fontRef idx="minor">
+            <a:schemeClr val="lt1"/>
+          </a:fontRef>
+        </p:style>
+        <p:txBody>
+          <a:bodyPr rtlCol="0" anchor="ctr"/>
+          <a:lstStyle/>
+          <a:p>
+            <a:pPr algn="ctr"/>
+          </a:p>
+        </p:txBody>
+      </p:sp>
+      <p:sp>
+        <p:nvSpPr>
+          <p:cNvPr id="28" name="TextBox 27"/>
+          <p:cNvSpPr txBox="1"/>
+          <p:nvPr/>
+        </p:nvSpPr>
+        <p:spPr>
+          <a:xfrm>
+            <a:off x="6355080" y="594360"/>
+            <a:ext cx="1691640" cy="201168"/>
+          </a:xfrm>
+          <a:prstGeom prst="rect">
+            <a:avLst/>
+          </a:prstGeom>
+          <a:noFill/>
+        </p:spPr>
+        <p:txBody>
+          <a:bodyPr wrap="square" anchor="ctr" lIns="18288" rIns="18288" tIns="18288" bIns="18288">
+            <a:noAutofit/>
+          </a:bodyPr>
+          <a:lstStyle/>
+          <a:p>
+            <a:pPr algn="ctr">
+              <a:spcBef>
+                <a:spcPts val="0"/>
+              </a:spcBef>
+              <a:spcAft>
+                <a:spcPts val="400"/>
+              </a:spcAft>
+            </a:pPr>
+            <a:r>
+              <a:rPr sz="1000" b="1">
+                <a:solidFill>
+                  <a:srgbClr val="1F3247"/>
+                </a:solidFill>
+                <a:latin typeface="Calibri"/>
+              </a:rPr>
+              <a:t>Retrievers ×3</a:t>
+            </a:r>
+          </a:p>
+        </p:txBody>
+      </p:sp>
       <p:pic>
         <p:nvPicPr>
-          <p:cNvPr id="19" name="Picture 18" descr="me5.png"/>
+          <p:cNvPr id="29" name="Picture 28" descr="bge.png"/>
           <p:cNvPicPr>
             <a:picLocks noChangeAspect="1"/>
           </p:cNvPicPr>
@@ -3722,41 +4309,59 @@
         </p:blipFill>
         <p:spPr>
           <a:xfrm>
-            <a:off x="7068312" y="411479"/>
-            <a:ext cx="292608" cy="292608"/>
+            <a:off x="6480413" y="859536"/>
+            <a:ext cx="374172" cy="374172"/>
           </a:xfrm>
           <a:prstGeom prst="rect">
             <a:avLst/>
           </a:prstGeom>
         </p:spPr>
       </p:pic>
-      <p:pic>
-        <p:nvPicPr>
-          <p:cNvPr id="20" name="Picture 19" descr="qwen.png"/>
-          <p:cNvPicPr>
-            <a:picLocks noChangeAspect="1"/>
-          </p:cNvPicPr>
+      <p:sp>
+        <p:nvSpPr>
+          <p:cNvPr id="30" name="TextBox 29"/>
+          <p:cNvSpPr txBox="1"/>
           <p:nvPr/>
-        </p:nvPicPr>
-        <p:blipFill>
-          <a:blip r:embed="rId3"/>
-          <a:stretch>
-            <a:fillRect/>
-          </a:stretch>
-        </p:blipFill>
-        <p:spPr>
-          <a:xfrm>
-            <a:off x="7424928" y="411479"/>
-            <a:ext cx="292608" cy="292608"/>
+        </p:nvSpPr>
+        <p:spPr>
+          <a:xfrm>
+            <a:off x="6400800" y="1242852"/>
+            <a:ext cx="533400" cy="183611"/>
           </a:xfrm>
           <a:prstGeom prst="rect">
             <a:avLst/>
           </a:prstGeom>
-        </p:spPr>
-      </p:pic>
+          <a:noFill/>
+        </p:spPr>
+        <p:txBody>
+          <a:bodyPr wrap="square" anchor="t" lIns="0" rIns="0" tIns="0" bIns="0">
+            <a:noAutofit/>
+          </a:bodyPr>
+          <a:lstStyle/>
+          <a:p>
+            <a:pPr algn="ctr">
+              <a:spcBef>
+                <a:spcPts val="0"/>
+              </a:spcBef>
+              <a:spcAft>
+                <a:spcPts val="400"/>
+              </a:spcAft>
+            </a:pPr>
+            <a:r>
+              <a:rPr sz="650" b="0">
+                <a:solidFill>
+                  <a:srgbClr val="546E7A"/>
+                </a:solidFill>
+                <a:latin typeface="Calibri"/>
+              </a:rPr>
+              <a:t>BGE-M3</a:t>
+            </a:r>
+          </a:p>
+        </p:txBody>
+      </p:sp>
       <p:pic>
         <p:nvPicPr>
-          <p:cNvPr id="21" name="Picture 20" descr="answer.png"/>
+          <p:cNvPr id="31" name="Picture 30" descr="me5.png"/>
           <p:cNvPicPr>
             <a:picLocks noChangeAspect="1"/>
           </p:cNvPicPr>
@@ -3770,31 +4375,181 @@
         </p:blipFill>
         <p:spPr>
           <a:xfrm>
-            <a:off x="9116568" y="365760"/>
-            <a:ext cx="292608" cy="292608"/>
+            <a:off x="7013813" y="859536"/>
+            <a:ext cx="374172" cy="374172"/>
           </a:xfrm>
           <a:prstGeom prst="rect">
             <a:avLst/>
           </a:prstGeom>
         </p:spPr>
       </p:pic>
+      <p:sp>
+        <p:nvSpPr>
+          <p:cNvPr id="32" name="TextBox 31"/>
+          <p:cNvSpPr txBox="1"/>
+          <p:nvPr/>
+        </p:nvSpPr>
+        <p:spPr>
+          <a:xfrm>
+            <a:off x="6934200" y="1242852"/>
+            <a:ext cx="533400" cy="183611"/>
+          </a:xfrm>
+          <a:prstGeom prst="rect">
+            <a:avLst/>
+          </a:prstGeom>
+          <a:noFill/>
+        </p:spPr>
+        <p:txBody>
+          <a:bodyPr wrap="square" anchor="t" lIns="0" rIns="0" tIns="0" bIns="0">
+            <a:noAutofit/>
+          </a:bodyPr>
+          <a:lstStyle/>
+          <a:p>
+            <a:pPr algn="ctr">
+              <a:spcBef>
+                <a:spcPts val="0"/>
+              </a:spcBef>
+              <a:spcAft>
+                <a:spcPts val="400"/>
+              </a:spcAft>
+            </a:pPr>
+            <a:r>
+              <a:rPr sz="650" b="0">
+                <a:solidFill>
+                  <a:srgbClr val="546E7A"/>
+                </a:solidFill>
+                <a:latin typeface="Calibri"/>
+              </a:rPr>
+              <a:t>mE5</a:t>
+            </a:r>
+          </a:p>
+        </p:txBody>
+      </p:sp>
+      <p:pic>
+        <p:nvPicPr>
+          <p:cNvPr id="33" name="Picture 32" descr="qwen.png"/>
+          <p:cNvPicPr>
+            <a:picLocks noChangeAspect="1"/>
+          </p:cNvPicPr>
+          <p:nvPr/>
+        </p:nvPicPr>
+        <p:blipFill>
+          <a:blip r:embed="rId5"/>
+          <a:stretch>
+            <a:fillRect/>
+          </a:stretch>
+        </p:blipFill>
+        <p:spPr>
+          <a:xfrm>
+            <a:off x="7547213" y="859536"/>
+            <a:ext cx="374172" cy="374172"/>
+          </a:xfrm>
+          <a:prstGeom prst="rect">
+            <a:avLst/>
+          </a:prstGeom>
+        </p:spPr>
+      </p:pic>
+      <p:sp>
+        <p:nvSpPr>
+          <p:cNvPr id="34" name="TextBox 33"/>
+          <p:cNvSpPr txBox="1"/>
+          <p:nvPr/>
+        </p:nvSpPr>
+        <p:spPr>
+          <a:xfrm>
+            <a:off x="7467599" y="1242852"/>
+            <a:ext cx="533400" cy="183611"/>
+          </a:xfrm>
+          <a:prstGeom prst="rect">
+            <a:avLst/>
+          </a:prstGeom>
+          <a:noFill/>
+        </p:spPr>
+        <p:txBody>
+          <a:bodyPr wrap="square" anchor="t" lIns="0" rIns="0" tIns="0" bIns="0">
+            <a:noAutofit/>
+          </a:bodyPr>
+          <a:lstStyle/>
+          <a:p>
+            <a:pPr algn="ctr">
+              <a:spcBef>
+                <a:spcPts val="0"/>
+              </a:spcBef>
+              <a:spcAft>
+                <a:spcPts val="400"/>
+              </a:spcAft>
+            </a:pPr>
+            <a:r>
+              <a:rPr sz="650" b="0">
+                <a:solidFill>
+                  <a:srgbClr val="546E7A"/>
+                </a:solidFill>
+                <a:latin typeface="Calibri"/>
+              </a:rPr>
+              <a:t>Qwen3-Emb</a:t>
+            </a:r>
+          </a:p>
+        </p:txBody>
+      </p:sp>
+      <p:sp>
+        <p:nvSpPr>
+          <p:cNvPr id="35" name="TextBox 34"/>
+          <p:cNvSpPr txBox="1"/>
+          <p:nvPr/>
+        </p:nvSpPr>
+        <p:spPr>
+          <a:xfrm>
+            <a:off x="6355080" y="1609344"/>
+            <a:ext cx="1691640" cy="237744"/>
+          </a:xfrm>
+          <a:prstGeom prst="rect">
+            <a:avLst/>
+          </a:prstGeom>
+          <a:noFill/>
+        </p:spPr>
+        <p:txBody>
+          <a:bodyPr wrap="square" anchor="ctr" lIns="18288" rIns="18288" tIns="18288" bIns="18288">
+            <a:noAutofit/>
+          </a:bodyPr>
+          <a:lstStyle/>
+          <a:p>
+            <a:pPr algn="ctr">
+              <a:spcBef>
+                <a:spcPts val="0"/>
+              </a:spcBef>
+              <a:spcAft>
+                <a:spcPts val="400"/>
+              </a:spcAft>
+            </a:pPr>
+            <a:r>
+              <a:rPr sz="850" b="0">
+                <a:solidFill>
+                  <a:srgbClr val="546E7A"/>
+                </a:solidFill>
+                <a:latin typeface="Calibri"/>
+              </a:rPr>
+              <a:t>k ∈ {1, 5, 10}</a:t>
+            </a:r>
+          </a:p>
+        </p:txBody>
+      </p:sp>
       <p:cxnSp>
         <p:nvCxnSpPr>
-          <p:cNvPr id="22" name="Connector 21"/>
+          <p:cNvPr id="36" name="Connector 35"/>
           <p:cNvCxnSpPr/>
           <p:nvPr/>
         </p:nvCxnSpPr>
         <p:spPr>
           <a:xfrm>
-            <a:off x="1975104" y="466344"/>
-            <a:ext cx="237744" cy="0"/>
+            <a:off x="1892808" y="1216152"/>
+            <a:ext cx="329184" cy="0"/>
           </a:xfrm>
           <a:prstGeom prst="line">
             <a:avLst/>
           </a:prstGeom>
-          <a:ln w="17780">
+          <a:ln w="20320">
             <a:solidFill>
-              <a:srgbClr val="B0BEC5"/>
+              <a:srgbClr val="78909C"/>
             </a:solidFill>
             <a:tailEnd type="triangle" w="med" len="med"/>
           </a:ln>
@@ -3816,21 +4571,21 @@
       </p:cxnSp>
       <p:cxnSp>
         <p:nvCxnSpPr>
-          <p:cNvPr id="23" name="Connector 22"/>
+          <p:cNvPr id="37" name="Connector 36"/>
           <p:cNvCxnSpPr/>
           <p:nvPr/>
         </p:nvCxnSpPr>
         <p:spPr>
           <a:xfrm>
-            <a:off x="4023360" y="466344"/>
-            <a:ext cx="237744" cy="0"/>
+            <a:off x="3950208" y="1216152"/>
+            <a:ext cx="329184" cy="0"/>
           </a:xfrm>
           <a:prstGeom prst="line">
             <a:avLst/>
           </a:prstGeom>
-          <a:ln w="17780">
+          <a:ln w="20320">
             <a:solidFill>
-              <a:srgbClr val="B0BEC5"/>
+              <a:srgbClr val="78909C"/>
             </a:solidFill>
             <a:tailEnd type="triangle" w="med" len="med"/>
           </a:ln>
@@ -3852,21 +4607,21 @@
       </p:cxnSp>
       <p:cxnSp>
         <p:nvCxnSpPr>
-          <p:cNvPr id="24" name="Connector 23"/>
+          <p:cNvPr id="38" name="Connector 37"/>
           <p:cNvCxnSpPr/>
           <p:nvPr/>
         </p:nvCxnSpPr>
         <p:spPr>
           <a:xfrm>
-            <a:off x="6071616" y="466344"/>
-            <a:ext cx="237744" cy="0"/>
+            <a:off x="6007608" y="1216152"/>
+            <a:ext cx="329184" cy="0"/>
           </a:xfrm>
           <a:prstGeom prst="line">
             <a:avLst/>
           </a:prstGeom>
-          <a:ln w="17780">
+          <a:ln w="20320">
             <a:solidFill>
-              <a:srgbClr val="B0BEC5"/>
+              <a:srgbClr val="78909C"/>
             </a:solidFill>
             <a:tailEnd type="triangle" w="med" len="med"/>
           </a:ln>
@@ -3888,21 +4643,21 @@
       </p:cxnSp>
       <p:cxnSp>
         <p:nvCxnSpPr>
-          <p:cNvPr id="25" name="Connector 24"/>
+          <p:cNvPr id="39" name="Connector 38"/>
           <p:cNvCxnSpPr/>
           <p:nvPr/>
         </p:nvCxnSpPr>
         <p:spPr>
           <a:xfrm>
-            <a:off x="8119872" y="466344"/>
-            <a:ext cx="237744" cy="0"/>
+            <a:off x="8065008" y="1216152"/>
+            <a:ext cx="329184" cy="0"/>
           </a:xfrm>
           <a:prstGeom prst="line">
             <a:avLst/>
           </a:prstGeom>
-          <a:ln w="17780">
+          <a:ln w="20320">
             <a:solidFill>
-              <a:srgbClr val="B0BEC5"/>
+              <a:srgbClr val="78909C"/>
             </a:solidFill>
             <a:tailEnd type="triangle" w="med" len="med"/>
           </a:ln>
@@ -3924,56 +4679,14 @@
       </p:cxnSp>
       <p:sp>
         <p:nvSpPr>
-          <p:cNvPr id="26" name="TextBox 25"/>
-          <p:cNvSpPr txBox="1"/>
-          <p:nvPr/>
-        </p:nvSpPr>
-        <p:spPr>
-          <a:xfrm>
-            <a:off x="182880" y="809244"/>
-            <a:ext cx="1773936" cy="146304"/>
-          </a:xfrm>
-          <a:prstGeom prst="rect">
-            <a:avLst/>
-          </a:prstGeom>
-          <a:noFill/>
-        </p:spPr>
-        <p:txBody>
-          <a:bodyPr wrap="square" anchor="t" lIns="18288" rIns="18288" tIns="18288" bIns="18288">
-            <a:noAutofit/>
-          </a:bodyPr>
-          <a:lstStyle/>
-          <a:p>
-            <a:pPr algn="l">
-              <a:spcBef>
-                <a:spcPts val="0"/>
-              </a:spcBef>
-              <a:spcAft>
-                <a:spcPts val="300"/>
-              </a:spcAft>
-            </a:pPr>
-            <a:r>
-              <a:rPr sz="750" b="0">
-                <a:solidFill>
-                  <a:srgbClr val="90A4AE"/>
-                </a:solidFill>
-                <a:latin typeface="Calibri"/>
-              </a:rPr>
-              <a:t>the document-RAG pipeline we study</a:t>
-            </a:r>
-          </a:p>
-        </p:txBody>
-      </p:sp>
-      <p:sp>
-        <p:nvSpPr>
-          <p:cNvPr id="27" name="Rounded Rectangle 26"/>
+          <p:cNvPr id="40" name="Rounded Rectangle 39"/>
           <p:cNvSpPr/>
           <p:nvPr/>
         </p:nvSpPr>
         <p:spPr>
           <a:xfrm>
-            <a:off x="182880" y="1078992"/>
-            <a:ext cx="2249424" cy="2103120"/>
+            <a:off x="182880" y="1993392"/>
+            <a:ext cx="4480560" cy="1792224"/>
           </a:xfrm>
           <a:prstGeom prst="roundRect">
             <a:avLst>
@@ -3981,11 +4694,11 @@
             </a:avLst>
           </a:prstGeom>
           <a:solidFill>
-            <a:srgbClr val="FFFFFF"/>
+            <a:srgbClr val="E8F0FE"/>
           </a:solidFill>
-          <a:ln w="16510">
+          <a:ln w="13970">
             <a:solidFill>
-              <a:srgbClr val="C62828"/>
+              <a:srgbClr val="1565C0"/>
             </a:solidFill>
           </a:ln>
           <a:effectLst/>
@@ -4014,258 +4727,18 @@
       </p:sp>
       <p:sp>
         <p:nvSpPr>
-          <p:cNvPr id="28" name="Rounded Rectangle 27"/>
+          <p:cNvPr id="41" name="Rounded Rectangle 40"/>
           <p:cNvSpPr/>
           <p:nvPr/>
         </p:nvSpPr>
         <p:spPr>
           <a:xfrm>
-            <a:off x="182880" y="1078992"/>
-            <a:ext cx="2249424" cy="512064"/>
+            <a:off x="182880" y="1993392"/>
+            <a:ext cx="4480560" cy="310896"/>
           </a:xfrm>
           <a:prstGeom prst="roundRect">
             <a:avLst>
-              <a:gd name="adj" fmla="val 9000"/>
-            </a:avLst>
-          </a:prstGeom>
-          <a:solidFill>
-            <a:srgbClr val="C62828"/>
-          </a:solidFill>
-          <a:ln>
-            <a:noFill/>
-          </a:ln>
-          <a:effectLst/>
-        </p:spPr>
-        <p:style>
-          <a:lnRef idx="1">
-            <a:schemeClr val="accent1"/>
-          </a:lnRef>
-          <a:fillRef idx="3">
-            <a:schemeClr val="accent1"/>
-          </a:fillRef>
-          <a:effectRef idx="2">
-            <a:schemeClr val="accent1"/>
-          </a:effectRef>
-          <a:fontRef idx="minor">
-            <a:schemeClr val="lt1"/>
-          </a:fontRef>
-        </p:style>
-        <p:txBody>
-          <a:bodyPr rtlCol="0" anchor="ctr" wrap="square" lIns="36576" rIns="36576" tIns="36576" bIns="36576">
-            <a:noAutofit/>
-          </a:bodyPr>
-          <a:lstStyle/>
-          <a:p>
-            <a:pPr algn="ctr">
-              <a:spcBef>
-                <a:spcPts val="0"/>
-              </a:spcBef>
-              <a:spcAft>
-                <a:spcPts val="100"/>
-              </a:spcAft>
-            </a:pPr>
-            <a:r>
-              <a:rPr sz="800" b="1">
-                <a:solidFill>
-                  <a:srgbClr val="FFFFFF"/>
-                </a:solidFill>
-                <a:latin typeface="Calibri"/>
-              </a:rPr>
-              <a:t>PROBLEM</a:t>
-            </a:r>
-          </a:p>
-          <a:p>
-            <a:pPr algn="ctr">
-              <a:spcBef>
-                <a:spcPts val="0"/>
-              </a:spcBef>
-              <a:spcAft>
-                <a:spcPts val="300"/>
-              </a:spcAft>
-            </a:pPr>
-            <a:r>
-              <a:rPr sz="1200" b="1">
-                <a:solidFill>
-                  <a:srgbClr val="FFFFFF"/>
-                </a:solidFill>
-                <a:latin typeface="Calibri"/>
-              </a:rPr>
-              <a:t>C1 · The disconnect</a:t>
-            </a:r>
-          </a:p>
-        </p:txBody>
-      </p:sp>
-      <p:sp>
-        <p:nvSpPr>
-          <p:cNvPr id="29" name="TextBox 28"/>
-          <p:cNvSpPr txBox="1"/>
-          <p:nvPr/>
-        </p:nvSpPr>
-        <p:spPr>
-          <a:xfrm>
-            <a:off x="274320" y="1655064"/>
-            <a:ext cx="2066543" cy="1088135"/>
-          </a:xfrm>
-          <a:prstGeom prst="rect">
-            <a:avLst/>
-          </a:prstGeom>
-          <a:noFill/>
-        </p:spPr>
-        <p:txBody>
-          <a:bodyPr wrap="square" anchor="t" lIns="27432" rIns="27432" tIns="27432" bIns="27432">
-            <a:noAutofit/>
-          </a:bodyPr>
-          <a:lstStyle/>
-          <a:p>
-            <a:pPr algn="l">
-              <a:lnSpc>
-                <a:spcPct val="104000"/>
-              </a:lnSpc>
-              <a:spcBef>
-                <a:spcPts val="0"/>
-              </a:spcBef>
-              <a:spcAft>
-                <a:spcPts val="300"/>
-              </a:spcAft>
-            </a:pPr>
-            <a:r>
-              <a:rPr sz="950" b="0">
-                <a:solidFill>
-                  <a:srgbClr val="1F3247"/>
-                </a:solidFill>
-                <a:latin typeface="Calibri"/>
-              </a:rPr>
-              <a:t>Parsers that look clean don’t retrieve. Boundary Clarity anti-correlates with retrieval (r = −0.81).</a:t>
-            </a:r>
-          </a:p>
-        </p:txBody>
-      </p:sp>
-      <p:sp>
-        <p:nvSpPr>
-          <p:cNvPr id="30" name="Rounded Rectangle 29"/>
-          <p:cNvSpPr/>
-          <p:nvPr/>
-        </p:nvSpPr>
-        <p:spPr>
-          <a:xfrm>
-            <a:off x="274320" y="2761487"/>
-            <a:ext cx="2066543" cy="329184"/>
-          </a:xfrm>
-          <a:prstGeom prst="roundRect">
-            <a:avLst>
-              <a:gd name="adj" fmla="val 12000"/>
-            </a:avLst>
-          </a:prstGeom>
-          <a:solidFill>
-            <a:srgbClr val="FDEBEC"/>
-          </a:solidFill>
-          <a:ln>
-            <a:noFill/>
-          </a:ln>
-          <a:effectLst/>
-        </p:spPr>
-        <p:style>
-          <a:lnRef idx="1">
-            <a:schemeClr val="accent1"/>
-          </a:lnRef>
-          <a:fillRef idx="3">
-            <a:schemeClr val="accent1"/>
-          </a:fillRef>
-          <a:effectRef idx="2">
-            <a:schemeClr val="accent1"/>
-          </a:effectRef>
-          <a:fontRef idx="minor">
-            <a:schemeClr val="lt1"/>
-          </a:fontRef>
-        </p:style>
-        <p:txBody>
-          <a:bodyPr rtlCol="0" anchor="ctr" wrap="square" lIns="27432" rIns="27432" tIns="27432" bIns="27432">
-            <a:noAutofit/>
-          </a:bodyPr>
-          <a:lstStyle/>
-          <a:p>
-            <a:pPr algn="ctr">
-              <a:spcBef>
-                <a:spcPts val="0"/>
-              </a:spcBef>
-              <a:spcAft>
-                <a:spcPts val="300"/>
-              </a:spcAft>
-            </a:pPr>
-            <a:r>
-              <a:rPr sz="950" b="1">
-                <a:solidFill>
-                  <a:srgbClr val="C62828"/>
-                </a:solidFill>
-                <a:latin typeface="Calibri"/>
-              </a:rPr>
-              <a:t>Parser choice → Hit@1 2.8×  (0.197 → 0.549)</a:t>
-            </a:r>
-          </a:p>
-        </p:txBody>
-      </p:sp>
-      <p:sp>
-        <p:nvSpPr>
-          <p:cNvPr id="31" name="Rounded Rectangle 30"/>
-          <p:cNvSpPr/>
-          <p:nvPr/>
-        </p:nvSpPr>
-        <p:spPr>
-          <a:xfrm>
-            <a:off x="2752344" y="1078992"/>
-            <a:ext cx="2249424" cy="2103120"/>
-          </a:xfrm>
-          <a:prstGeom prst="roundRect">
-            <a:avLst>
-              <a:gd name="adj" fmla="val 5000"/>
-            </a:avLst>
-          </a:prstGeom>
-          <a:solidFill>
-            <a:srgbClr val="FFFFFF"/>
-          </a:solidFill>
-          <a:ln w="16510">
-            <a:solidFill>
-              <a:srgbClr val="1565C0"/>
-            </a:solidFill>
-          </a:ln>
-          <a:effectLst/>
-        </p:spPr>
-        <p:style>
-          <a:lnRef idx="1">
-            <a:schemeClr val="accent1"/>
-          </a:lnRef>
-          <a:fillRef idx="3">
-            <a:schemeClr val="accent1"/>
-          </a:fillRef>
-          <a:effectRef idx="2">
-            <a:schemeClr val="accent1"/>
-          </a:effectRef>
-          <a:fontRef idx="minor">
-            <a:schemeClr val="lt1"/>
-          </a:fontRef>
-        </p:style>
-        <p:txBody>
-          <a:bodyPr rtlCol="0" anchor="ctr"/>
-          <a:lstStyle/>
-          <a:p>
-            <a:pPr algn="ctr"/>
-          </a:p>
-        </p:txBody>
-      </p:sp>
-      <p:sp>
-        <p:nvSpPr>
-          <p:cNvPr id="32" name="Rounded Rectangle 31"/>
-          <p:cNvSpPr/>
-          <p:nvPr/>
-        </p:nvSpPr>
-        <p:spPr>
-          <a:xfrm>
-            <a:off x="2752344" y="1078992"/>
-            <a:ext cx="2249424" cy="512064"/>
-          </a:xfrm>
-          <a:prstGeom prst="roundRect">
-            <a:avLst>
-              <a:gd name="adj" fmla="val 9000"/>
+              <a:gd name="adj" fmla="val 10000"/>
             </a:avLst>
           </a:prstGeom>
           <a:solidFill>
@@ -4291,29 +4764,10 @@
           </a:fontRef>
         </p:style>
         <p:txBody>
-          <a:bodyPr rtlCol="0" anchor="ctr" wrap="square" lIns="36576" rIns="36576" tIns="36576" bIns="36576">
+          <a:bodyPr rtlCol="0" anchor="ctr" wrap="square" lIns="27432" rIns="27432" tIns="27432" bIns="27432">
             <a:noAutofit/>
           </a:bodyPr>
           <a:lstStyle/>
-          <a:p>
-            <a:pPr algn="ctr">
-              <a:spcBef>
-                <a:spcPts val="0"/>
-              </a:spcBef>
-              <a:spcAft>
-                <a:spcPts val="100"/>
-              </a:spcAft>
-            </a:pPr>
-            <a:r>
-              <a:rPr sz="800" b="1">
-                <a:solidFill>
-                  <a:srgbClr val="FFFFFF"/>
-                </a:solidFill>
-                <a:latin typeface="Calibri"/>
-              </a:rPr>
-              <a:t>DIAGNOSE</a:t>
-            </a:r>
-          </a:p>
           <a:p>
             <a:pPr algn="ctr">
               <a:spcBef>
@@ -4324,27 +4778,27 @@
               </a:spcAft>
             </a:pPr>
             <a:r>
-              <a:rPr sz="1200" b="1">
+              <a:rPr sz="1050" b="1">
                 <a:solidFill>
                   <a:srgbClr val="FFFFFF"/>
                 </a:solidFill>
                 <a:latin typeface="Calibri"/>
               </a:rPr>
-              <a:t>C2 · Coverage diagnostic</a:t>
-            </a:r>
-          </a:p>
-        </p:txBody>
-      </p:sp>
-      <p:sp>
-        <p:nvSpPr>
-          <p:cNvPr id="33" name="TextBox 32"/>
+              <a:t>DIAGNOSE  —  locate the real fault</a:t>
+            </a:r>
+          </a:p>
+        </p:txBody>
+      </p:sp>
+      <p:sp>
+        <p:nvSpPr>
+          <p:cNvPr id="42" name="TextBox 41"/>
           <p:cNvSpPr txBox="1"/>
           <p:nvPr/>
         </p:nvSpPr>
         <p:spPr>
           <a:xfrm>
-            <a:off x="2843784" y="1655064"/>
-            <a:ext cx="2066543" cy="1088135"/>
+            <a:off x="256032" y="2350008"/>
+            <a:ext cx="4334256" cy="1371600"/>
           </a:xfrm>
           <a:prstGeom prst="rect">
             <a:avLst/>
@@ -4352,22 +4806,28 @@
           <a:noFill/>
         </p:spPr>
         <p:txBody>
-          <a:bodyPr wrap="square" anchor="t" lIns="27432" rIns="27432" tIns="27432" bIns="27432">
+          <a:bodyPr wrap="square" anchor="t" lIns="36576" rIns="36576" tIns="36576" bIns="36576">
             <a:noAutofit/>
           </a:bodyPr>
           <a:lstStyle/>
           <a:p>
             <a:pPr algn="l">
-              <a:lnSpc>
-                <a:spcPct val="104000"/>
-              </a:lnSpc>
               <a:spcBef>
                 <a:spcPts val="0"/>
               </a:spcBef>
               <a:spcAft>
-                <a:spcPts val="300"/>
+                <a:spcPts val="500"/>
               </a:spcAft>
             </a:pPr>
+            <a:r>
+              <a:rPr sz="950" b="1">
+                <a:solidFill>
+                  <a:srgbClr val="1565C0"/>
+                </a:solidFill>
+                <a:latin typeface="Calibri"/>
+              </a:rPr>
+              <a:t>C1  </a:t>
+            </a:r>
             <a:r>
               <a:rPr sz="950" b="0">
                 <a:solidFill>
@@ -4375,61 +4835,16 @@
                 </a:solidFill>
                 <a:latin typeface="Calibri"/>
               </a:rPr>
-              <a:t>A retriever-free check labels every answer covered / split / absent. Absent means a parser fault.</a:t>
-            </a:r>
-          </a:p>
-        </p:txBody>
-      </p:sp>
-      <p:sp>
-        <p:nvSpPr>
-          <p:cNvPr id="34" name="Rounded Rectangle 33"/>
-          <p:cNvSpPr/>
-          <p:nvPr/>
-        </p:nvSpPr>
-        <p:spPr>
-          <a:xfrm>
-            <a:off x="2843784" y="2761487"/>
-            <a:ext cx="2066543" cy="329184"/>
-          </a:xfrm>
-          <a:prstGeom prst="roundRect">
-            <a:avLst>
-              <a:gd name="adj" fmla="val 12000"/>
-            </a:avLst>
-          </a:prstGeom>
-          <a:solidFill>
-            <a:srgbClr val="E8F0FE"/>
-          </a:solidFill>
-          <a:ln>
-            <a:noFill/>
-          </a:ln>
-          <a:effectLst/>
-        </p:spPr>
-        <p:style>
-          <a:lnRef idx="1">
-            <a:schemeClr val="accent1"/>
-          </a:lnRef>
-          <a:fillRef idx="3">
-            <a:schemeClr val="accent1"/>
-          </a:fillRef>
-          <a:effectRef idx="2">
-            <a:schemeClr val="accent1"/>
-          </a:effectRef>
-          <a:fontRef idx="minor">
-            <a:schemeClr val="lt1"/>
-          </a:fontRef>
-        </p:style>
-        <p:txBody>
-          <a:bodyPr rtlCol="0" anchor="ctr" wrap="square" lIns="27432" rIns="27432" tIns="27432" bIns="27432">
-            <a:noAutofit/>
-          </a:bodyPr>
-          <a:lstStyle/>
-          <a:p>
-            <a:pPr algn="ctr">
+              <a:t>Disconnect — parsers that look clean don’t retrieve. Boundary Clarity anti-correlates with retrieval (r = −0.81); parser choice alone swings Hit@1 2.8× (0.197 → 0.549).</a:t>
+            </a:r>
+          </a:p>
+          <a:p>
+            <a:pPr algn="l">
               <a:spcBef>
                 <a:spcPts val="0"/>
               </a:spcBef>
               <a:spcAft>
-                <a:spcPts val="300"/>
+                <a:spcPts val="500"/>
               </a:spcAft>
             </a:pPr>
             <a:r>
@@ -4439,21 +4854,30 @@
                 </a:solidFill>
                 <a:latin typeface="Calibri"/>
               </a:rPr>
-              <a:t>20.2% absent — constant across 8 chunkers</a:t>
-            </a:r>
-          </a:p>
-        </p:txBody>
-      </p:sp>
-      <p:sp>
-        <p:nvSpPr>
-          <p:cNvPr id="35" name="Rounded Rectangle 34"/>
+              <a:t>C2  </a:t>
+            </a:r>
+            <a:r>
+              <a:rPr sz="950" b="0">
+                <a:solidFill>
+                  <a:srgbClr val="1F3247"/>
+                </a:solidFill>
+                <a:latin typeface="Calibri"/>
+              </a:rPr>
+              <a:t>Coverage (no retriever) — 20.2% of answers are absent from the parser output, constant across 8 chunkers → fix the parser before the retriever.</a:t>
+            </a:r>
+          </a:p>
+        </p:txBody>
+      </p:sp>
+      <p:sp>
+        <p:nvSpPr>
+          <p:cNvPr id="43" name="Rounded Rectangle 42"/>
           <p:cNvSpPr/>
           <p:nvPr/>
         </p:nvSpPr>
         <p:spPr>
           <a:xfrm>
-            <a:off x="5321808" y="1078992"/>
-            <a:ext cx="2249424" cy="2103120"/>
+            <a:off x="4800600" y="1993392"/>
+            <a:ext cx="2651760" cy="1792224"/>
           </a:xfrm>
           <a:prstGeom prst="roundRect">
             <a:avLst>
@@ -4461,9 +4885,9 @@
             </a:avLst>
           </a:prstGeom>
           <a:solidFill>
-            <a:srgbClr val="FFFFFF"/>
+            <a:srgbClr val="E7F5EA"/>
           </a:solidFill>
-          <a:ln w="16510">
+          <a:ln w="13970">
             <a:solidFill>
               <a:srgbClr val="2E7D32"/>
             </a:solidFill>
@@ -4494,18 +4918,18 @@
       </p:sp>
       <p:sp>
         <p:nvSpPr>
-          <p:cNvPr id="36" name="Rounded Rectangle 35"/>
+          <p:cNvPr id="44" name="Rounded Rectangle 43"/>
           <p:cNvSpPr/>
           <p:nvPr/>
         </p:nvSpPr>
         <p:spPr>
           <a:xfrm>
-            <a:off x="5321808" y="1078992"/>
-            <a:ext cx="2249424" cy="512064"/>
+            <a:off x="4800600" y="1993392"/>
+            <a:ext cx="2651760" cy="310896"/>
           </a:xfrm>
           <a:prstGeom prst="roundRect">
             <a:avLst>
-              <a:gd name="adj" fmla="val 9000"/>
+              <a:gd name="adj" fmla="val 10000"/>
             </a:avLst>
           </a:prstGeom>
           <a:solidFill>
@@ -4531,29 +4955,10 @@
           </a:fontRef>
         </p:style>
         <p:txBody>
-          <a:bodyPr rtlCol="0" anchor="ctr" wrap="square" lIns="36576" rIns="36576" tIns="36576" bIns="36576">
+          <a:bodyPr rtlCol="0" anchor="ctr" wrap="square" lIns="27432" rIns="27432" tIns="27432" bIns="27432">
             <a:noAutofit/>
           </a:bodyPr>
           <a:lstStyle/>
-          <a:p>
-            <a:pPr algn="ctr">
-              <a:spcBef>
-                <a:spcPts val="0"/>
-              </a:spcBef>
-              <a:spcAft>
-                <a:spcPts val="100"/>
-              </a:spcAft>
-            </a:pPr>
-            <a:r>
-              <a:rPr sz="800" b="1">
-                <a:solidFill>
-                  <a:srgbClr val="FFFFFF"/>
-                </a:solidFill>
-                <a:latin typeface="Calibri"/>
-              </a:rPr>
-              <a:t>SELECT</a:t>
-            </a:r>
-          </a:p>
           <a:p>
             <a:pPr algn="ctr">
               <a:spcBef>
@@ -4564,27 +4969,27 @@
               </a:spcAft>
             </a:pPr>
             <a:r>
-              <a:rPr sz="1200" b="1">
+              <a:rPr sz="1050" b="1">
                 <a:solidFill>
                   <a:srgbClr val="FFFFFF"/>
                 </a:solidFill>
                 <a:latin typeface="Calibri"/>
               </a:rPr>
-              <a:t>C3 · RCPS protocol</a:t>
-            </a:r>
-          </a:p>
-        </p:txBody>
-      </p:sp>
-      <p:sp>
-        <p:nvSpPr>
-          <p:cNvPr id="37" name="TextBox 36"/>
+              <a:t>SELECT</a:t>
+            </a:r>
+          </a:p>
+        </p:txBody>
+      </p:sp>
+      <p:sp>
+        <p:nvSpPr>
+          <p:cNvPr id="45" name="TextBox 44"/>
           <p:cNvSpPr txBox="1"/>
           <p:nvPr/>
         </p:nvSpPr>
         <p:spPr>
           <a:xfrm>
-            <a:off x="5413248" y="1655064"/>
-            <a:ext cx="2066543" cy="1088135"/>
+            <a:off x="4873752" y="2350008"/>
+            <a:ext cx="2505456" cy="1371600"/>
           </a:xfrm>
           <a:prstGeom prst="rect">
             <a:avLst/>
@@ -4592,22 +4997,28 @@
           <a:noFill/>
         </p:spPr>
         <p:txBody>
-          <a:bodyPr wrap="square" anchor="t" lIns="27432" rIns="27432" tIns="27432" bIns="27432">
+          <a:bodyPr wrap="square" anchor="t" lIns="36576" rIns="36576" tIns="36576" bIns="36576">
             <a:noAutofit/>
           </a:bodyPr>
           <a:lstStyle/>
           <a:p>
             <a:pPr algn="l">
-              <a:lnSpc>
-                <a:spcPct val="104000"/>
-              </a:lnSpc>
               <a:spcBef>
                 <a:spcPts val="0"/>
               </a:spcBef>
               <a:spcAft>
-                <a:spcPts val="300"/>
+                <a:spcPts val="500"/>
               </a:spcAft>
             </a:pPr>
+            <a:r>
+              <a:rPr sz="950" b="1">
+                <a:solidFill>
+                  <a:srgbClr val="2E7D32"/>
+                </a:solidFill>
+                <a:latin typeface="Calibri"/>
+              </a:rPr>
+              <a:t>C3  </a:t>
+            </a:r>
             <a:r>
               <a:rPr sz="950" b="0">
                 <a:solidFill>
@@ -4615,85 +5026,21 @@
                 </a:solidFill>
                 <a:latin typeface="Calibri"/>
               </a:rPr>
-              <a:t>Rank parsers &amp; chunkers by what retrieval does, on a held-out Q–A probe. Retriever-averaged &amp; format-invariant. No training.</a:t>
-            </a:r>
-          </a:p>
-        </p:txBody>
-      </p:sp>
-      <p:sp>
-        <p:nvSpPr>
-          <p:cNvPr id="38" name="Rounded Rectangle 37"/>
+              <a:t>RCPS — rank parsers &amp; chunkers by what retrieval does, on a held-out Q–A probe. Retriever-averaged &amp; format-invariant. No training.</a:t>
+            </a:r>
+          </a:p>
+        </p:txBody>
+      </p:sp>
+      <p:sp>
+        <p:nvSpPr>
+          <p:cNvPr id="46" name="Rounded Rectangle 45"/>
           <p:cNvSpPr/>
           <p:nvPr/>
         </p:nvSpPr>
         <p:spPr>
           <a:xfrm>
-            <a:off x="5413248" y="2761487"/>
-            <a:ext cx="2066543" cy="329184"/>
-          </a:xfrm>
-          <a:prstGeom prst="roundRect">
-            <a:avLst>
-              <a:gd name="adj" fmla="val 12000"/>
-            </a:avLst>
-          </a:prstGeom>
-          <a:solidFill>
-            <a:srgbClr val="E7F5EA"/>
-          </a:solidFill>
-          <a:ln>
-            <a:noFill/>
-          </a:ln>
-          <a:effectLst/>
-        </p:spPr>
-        <p:style>
-          <a:lnRef idx="1">
-            <a:schemeClr val="accent1"/>
-          </a:lnRef>
-          <a:fillRef idx="3">
-            <a:schemeClr val="accent1"/>
-          </a:fillRef>
-          <a:effectRef idx="2">
-            <a:schemeClr val="accent1"/>
-          </a:effectRef>
-          <a:fontRef idx="minor">
-            <a:schemeClr val="lt1"/>
-          </a:fontRef>
-        </p:style>
-        <p:txBody>
-          <a:bodyPr rtlCol="0" anchor="ctr" wrap="square" lIns="27432" rIns="27432" tIns="27432" bIns="27432">
-            <a:noAutofit/>
-          </a:bodyPr>
-          <a:lstStyle/>
-          <a:p>
-            <a:pPr algn="ctr">
-              <a:spcBef>
-                <a:spcPts val="0"/>
-              </a:spcBef>
-              <a:spcAft>
-                <a:spcPts val="300"/>
-              </a:spcAft>
-            </a:pPr>
-            <a:r>
-              <a:rPr sz="950" b="1">
-                <a:solidFill>
-                  <a:srgbClr val="2E7D32"/>
-                </a:solidFill>
-                <a:latin typeface="Calibri"/>
-              </a:rPr>
-              <a:t>Picks what BC / edit-distance rank wrong</a:t>
-            </a:r>
-          </a:p>
-        </p:txBody>
-      </p:sp>
-      <p:sp>
-        <p:nvSpPr>
-          <p:cNvPr id="39" name="Rounded Rectangle 38"/>
-          <p:cNvSpPr/>
-          <p:nvPr/>
-        </p:nvSpPr>
-        <p:spPr>
-          <a:xfrm>
-            <a:off x="7891271" y="1078992"/>
-            <a:ext cx="2249424" cy="2103120"/>
+            <a:off x="7589520" y="1993392"/>
+            <a:ext cx="2514600" cy="1792224"/>
           </a:xfrm>
           <a:prstGeom prst="roundRect">
             <a:avLst>
@@ -4701,9 +5048,9 @@
             </a:avLst>
           </a:prstGeom>
           <a:solidFill>
-            <a:srgbClr val="FFFFFF"/>
+            <a:srgbClr val="FFF3E0"/>
           </a:solidFill>
-          <a:ln w="16510">
+          <a:ln w="13970">
             <a:solidFill>
               <a:srgbClr val="E65100"/>
             </a:solidFill>
@@ -4734,18 +5081,18 @@
       </p:sp>
       <p:sp>
         <p:nvSpPr>
-          <p:cNvPr id="40" name="Rounded Rectangle 39"/>
+          <p:cNvPr id="47" name="Rounded Rectangle 46"/>
           <p:cNvSpPr/>
           <p:nvPr/>
         </p:nvSpPr>
         <p:spPr>
           <a:xfrm>
-            <a:off x="7891271" y="1078992"/>
-            <a:ext cx="2249424" cy="512064"/>
+            <a:off x="7589520" y="1993392"/>
+            <a:ext cx="2514600" cy="310896"/>
           </a:xfrm>
           <a:prstGeom prst="roundRect">
             <a:avLst>
-              <a:gd name="adj" fmla="val 9000"/>
+              <a:gd name="adj" fmla="val 10000"/>
             </a:avLst>
           </a:prstGeom>
           <a:solidFill>
@@ -4771,29 +5118,10 @@
           </a:fontRef>
         </p:style>
         <p:txBody>
-          <a:bodyPr rtlCol="0" anchor="ctr" wrap="square" lIns="36576" rIns="36576" tIns="36576" bIns="36576">
+          <a:bodyPr rtlCol="0" anchor="ctr" wrap="square" lIns="27432" rIns="27432" tIns="27432" bIns="27432">
             <a:noAutofit/>
           </a:bodyPr>
           <a:lstStyle/>
-          <a:p>
-            <a:pPr algn="ctr">
-              <a:spcBef>
-                <a:spcPts val="0"/>
-              </a:spcBef>
-              <a:spcAft>
-                <a:spcPts val="100"/>
-              </a:spcAft>
-            </a:pPr>
-            <a:r>
-              <a:rPr sz="800" b="1">
-                <a:solidFill>
-                  <a:srgbClr val="FFFFFF"/>
-                </a:solidFill>
-                <a:latin typeface="Calibri"/>
-              </a:rPr>
-              <a:t>IMPROVE</a:t>
-            </a:r>
-          </a:p>
           <a:p>
             <a:pPr algn="ctr">
               <a:spcBef>
@@ -4804,27 +5132,27 @@
               </a:spcAft>
             </a:pPr>
             <a:r>
-              <a:rPr sz="1200" b="1">
+              <a:rPr sz="1050" b="1">
                 <a:solidFill>
                   <a:srgbClr val="FFFFFF"/>
                 </a:solidFill>
                 <a:latin typeface="Calibri"/>
               </a:rPr>
-              <a:t>C4 · Bounded training</a:t>
-            </a:r>
-          </a:p>
-        </p:txBody>
-      </p:sp>
-      <p:sp>
-        <p:nvSpPr>
-          <p:cNvPr id="41" name="TextBox 40"/>
+              <a:t>IMPROVE  (bounded)</a:t>
+            </a:r>
+          </a:p>
+        </p:txBody>
+      </p:sp>
+      <p:sp>
+        <p:nvSpPr>
+          <p:cNvPr id="48" name="TextBox 47"/>
           <p:cNvSpPr txBox="1"/>
           <p:nvPr/>
         </p:nvSpPr>
         <p:spPr>
           <a:xfrm>
-            <a:off x="7982711" y="1655064"/>
-            <a:ext cx="2066543" cy="1088135"/>
+            <a:off x="7662672" y="2350008"/>
+            <a:ext cx="2368296" cy="1371600"/>
           </a:xfrm>
           <a:prstGeom prst="rect">
             <a:avLst/>
@@ -4832,22 +5160,28 @@
           <a:noFill/>
         </p:spPr>
         <p:txBody>
-          <a:bodyPr wrap="square" anchor="t" lIns="27432" rIns="27432" tIns="27432" bIns="27432">
+          <a:bodyPr wrap="square" anchor="t" lIns="36576" rIns="36576" tIns="36576" bIns="36576">
             <a:noAutofit/>
           </a:bodyPr>
           <a:lstStyle/>
           <a:p>
             <a:pPr algn="l">
-              <a:lnSpc>
-                <a:spcPct val="104000"/>
-              </a:lnSpc>
               <a:spcBef>
                 <a:spcPts val="0"/>
               </a:spcBef>
               <a:spcAft>
-                <a:spcPts val="300"/>
+                <a:spcPts val="500"/>
               </a:spcAft>
             </a:pPr>
+            <a:r>
+              <a:rPr sz="950" b="1">
+                <a:solidFill>
+                  <a:srgbClr val="E65100"/>
+                </a:solidFill>
+                <a:latin typeface="Calibri"/>
+              </a:rPr>
+              <a:t>C4  </a:t>
+            </a:r>
             <a:r>
               <a:rPr sz="950" b="0">
                 <a:solidFill>
@@ -4855,183 +5189,11 @@
                 </a:solidFill>
                 <a:latin typeface="Calibri"/>
               </a:rPr>
-              <a:t>Best-of-K fidelity distillation improves the parser; a matched control shows the retrieval reward is unnecessary.</a:t>
-            </a:r>
-          </a:p>
-        </p:txBody>
-      </p:sp>
-      <p:sp>
-        <p:nvSpPr>
-          <p:cNvPr id="42" name="Rounded Rectangle 41"/>
-          <p:cNvSpPr/>
-          <p:nvPr/>
-        </p:nvSpPr>
-        <p:spPr>
-          <a:xfrm>
-            <a:off x="7982711" y="2761487"/>
-            <a:ext cx="2066543" cy="329184"/>
-          </a:xfrm>
-          <a:prstGeom prst="roundRect">
-            <a:avLst>
-              <a:gd name="adj" fmla="val 12000"/>
-            </a:avLst>
-          </a:prstGeom>
-          <a:solidFill>
-            <a:srgbClr val="FFF3E0"/>
-          </a:solidFill>
-          <a:ln>
-            <a:noFill/>
-          </a:ln>
-          <a:effectLst/>
-        </p:spPr>
-        <p:style>
-          <a:lnRef idx="1">
-            <a:schemeClr val="accent1"/>
-          </a:lnRef>
-          <a:fillRef idx="3">
-            <a:schemeClr val="accent1"/>
-          </a:fillRef>
-          <a:effectRef idx="2">
-            <a:schemeClr val="accent1"/>
-          </a:effectRef>
-          <a:fontRef idx="minor">
-            <a:schemeClr val="lt1"/>
-          </a:fontRef>
-        </p:style>
-        <p:txBody>
-          <a:bodyPr rtlCol="0" anchor="ctr" wrap="square" lIns="27432" rIns="27432" tIns="27432" bIns="27432">
-            <a:noAutofit/>
-          </a:bodyPr>
-          <a:lstStyle/>
-          <a:p>
-            <a:pPr algn="ctr">
-              <a:spcBef>
-                <a:spcPts val="0"/>
-              </a:spcBef>
-              <a:spcAft>
-                <a:spcPts val="300"/>
-              </a:spcAft>
-            </a:pPr>
-            <a:r>
-              <a:rPr sz="950" b="1">
-                <a:solidFill>
-                  <a:srgbClr val="E65100"/>
-                </a:solidFill>
-                <a:latin typeface="Calibri"/>
-              </a:rPr>
-              <a:t>+1.22 pp Hit@5  (OHR-Bench)</a:t>
-            </a:r>
-          </a:p>
-        </p:txBody>
-      </p:sp>
-      <p:cxnSp>
-        <p:nvCxnSpPr>
-          <p:cNvPr id="43" name="Connector 42"/>
-          <p:cNvCxnSpPr/>
-          <p:nvPr/>
-        </p:nvCxnSpPr>
-        <p:spPr>
-          <a:xfrm>
-            <a:off x="2450592" y="2130552"/>
-            <a:ext cx="283464" cy="0"/>
-          </a:xfrm>
-          <a:prstGeom prst="line">
-            <a:avLst/>
-          </a:prstGeom>
-          <a:ln w="25400">
-            <a:solidFill>
-              <a:srgbClr val="90A4AE"/>
-            </a:solidFill>
-            <a:tailEnd type="triangle" w="med" len="med"/>
-          </a:ln>
-        </p:spPr>
-        <p:style>
-          <a:lnRef idx="2">
-            <a:schemeClr val="accent1"/>
-          </a:lnRef>
-          <a:fillRef idx="0">
-            <a:schemeClr val="accent1"/>
-          </a:fillRef>
-          <a:effectRef idx="1">
-            <a:schemeClr val="accent1"/>
-          </a:effectRef>
-          <a:fontRef idx="minor">
-            <a:schemeClr val="tx1"/>
-          </a:fontRef>
-        </p:style>
-      </p:cxnSp>
-      <p:cxnSp>
-        <p:nvCxnSpPr>
-          <p:cNvPr id="44" name="Connector 43"/>
-          <p:cNvCxnSpPr/>
-          <p:nvPr/>
-        </p:nvCxnSpPr>
-        <p:spPr>
-          <a:xfrm>
-            <a:off x="5020056" y="2130552"/>
-            <a:ext cx="283464" cy="0"/>
-          </a:xfrm>
-          <a:prstGeom prst="line">
-            <a:avLst/>
-          </a:prstGeom>
-          <a:ln w="25400">
-            <a:solidFill>
-              <a:srgbClr val="90A4AE"/>
-            </a:solidFill>
-            <a:tailEnd type="triangle" w="med" len="med"/>
-          </a:ln>
-        </p:spPr>
-        <p:style>
-          <a:lnRef idx="2">
-            <a:schemeClr val="accent1"/>
-          </a:lnRef>
-          <a:fillRef idx="0">
-            <a:schemeClr val="accent1"/>
-          </a:fillRef>
-          <a:effectRef idx="1">
-            <a:schemeClr val="accent1"/>
-          </a:effectRef>
-          <a:fontRef idx="minor">
-            <a:schemeClr val="tx1"/>
-          </a:fontRef>
-        </p:style>
-      </p:cxnSp>
-      <p:cxnSp>
-        <p:nvCxnSpPr>
-          <p:cNvPr id="45" name="Connector 44"/>
-          <p:cNvCxnSpPr/>
-          <p:nvPr/>
-        </p:nvCxnSpPr>
-        <p:spPr>
-          <a:xfrm>
-            <a:off x="7589520" y="2130552"/>
-            <a:ext cx="283463" cy="0"/>
-          </a:xfrm>
-          <a:prstGeom prst="line">
-            <a:avLst/>
-          </a:prstGeom>
-          <a:ln w="25400">
-            <a:solidFill>
-              <a:srgbClr val="90A4AE"/>
-            </a:solidFill>
-            <a:tailEnd type="triangle" w="med" len="med"/>
-          </a:ln>
-        </p:spPr>
-        <p:style>
-          <a:lnRef idx="2">
-            <a:schemeClr val="accent1"/>
-          </a:lnRef>
-          <a:fillRef idx="0">
-            <a:schemeClr val="accent1"/>
-          </a:fillRef>
-          <a:effectRef idx="1">
-            <a:schemeClr val="accent1"/>
-          </a:effectRef>
-          <a:fontRef idx="minor">
-            <a:schemeClr val="tx1"/>
-          </a:fontRef>
-        </p:style>
-      </p:cxnSp>
+              <a:t>Best-of-K fidelity distillation: +1.22 pp Hit@5 (OHR-Bench). A matched control shows the retrieval reward is unnecessary.</a:t>
+            </a:r>
+          </a:p>
+        </p:txBody>
+      </p:sp>
     </p:spTree>
   </p:cSld>
   <p:clrMapOvr>

</xml_diff>

<commit_message>
fig: Figure 1 — detailed 2x2 per-contribution architecture (C1–C4)
Replace the pipeline+zones overview with a detailed 2x2 architecture where each
contribution is its own real schematic, per request to keep detailed architecture
in the body: C1 two opposing scoring axes (appearance vs retrieval; r=−0.81,
Hit@1 2.8×), C2 the covered/split/absent decision tree (absent 20.2%), C3 the
RCPS protocol flow (3 choices, τ=0.87), C4 the best-of-K training pipeline
(edit-dist distillation; retrieval reward unnecessary; +1.22 pp). 2x2 (not 1x4)
so panels stay legible when scaled to \textwidth. Calibri; no text overflow
(verified at 300 dpi). Editable PPTX + preview PNG.
</commit_message>
<xml_diff>
--- a/paper/figures/fig1_overview.pptx
+++ b/paper/figures/fig1_overview.pptx
@@ -7,7 +7,7 @@
   <p:sldIdLst>
     <p:sldId id="256" r:id="rId7"/>
   </p:sldIdLst>
-  <p:sldSz cx="10332720" cy="3931920" type="screen4x3"/>
+  <p:sldSz cx="8778240" cy="6126480" type="screen4x3"/>
   <p:notesSz cx="6858000" cy="9144000"/>
   <p:defaultTextStyle>
     <a:defPPr>
@@ -3096,12 +3096,12 @@
         </p:nvSpPr>
         <p:spPr>
           <a:xfrm>
-            <a:off x="182880" y="146304"/>
-            <a:ext cx="1691640" cy="310896"/>
+            <a:off x="182880" y="109728"/>
+            <a:ext cx="8412480" cy="365760"/>
           </a:xfrm>
           <a:prstGeom prst="roundRect">
             <a:avLst>
-              <a:gd name="adj" fmla="val 18000"/>
+              <a:gd name="adj" fmla="val 16000"/>
             </a:avLst>
           </a:prstGeom>
           <a:solidFill>
@@ -3127,7 +3127,7 @@
           </a:fontRef>
         </p:style>
         <p:txBody>
-          <a:bodyPr rtlCol="0" anchor="ctr" wrap="square" lIns="18288" rIns="18288" tIns="18288" bIns="18288">
+          <a:bodyPr rtlCol="0" anchor="ctr" wrap="square" lIns="36576" rIns="36576" tIns="13716" bIns="13716">
             <a:noAutofit/>
           </a:bodyPr>
           <a:lstStyle/>
@@ -3137,17 +3137,35 @@
                 <a:spcPts val="0"/>
               </a:spcBef>
               <a:spcAft>
-                <a:spcPts val="300"/>
+                <a:spcPts val="150"/>
               </a:spcAft>
             </a:pPr>
             <a:r>
-              <a:rPr sz="1250" b="1">
+              <a:rPr sz="1150" b="1">
                 <a:solidFill>
                   <a:srgbClr val="FFFFFF"/>
                 </a:solidFill>
                 <a:latin typeface="Calibri"/>
               </a:rPr>
-              <a:t>Document</a:t>
+              <a:t>RADP — choose the parser by </a:t>
+            </a:r>
+            <a:r>
+              <a:rPr sz="1150" b="1">
+                <a:solidFill>
+                  <a:srgbClr val="FFD54F"/>
+                </a:solidFill>
+                <a:latin typeface="Calibri"/>
+              </a:rPr>
+              <a:t>retrieval</a:t>
+            </a:r>
+            <a:r>
+              <a:rPr sz="1150" b="1">
+                <a:solidFill>
+                  <a:srgbClr val="FFFFFF"/>
+                </a:solidFill>
+                <a:latin typeface="Calibri"/>
+              </a:rPr>
+              <a:t>, not by appearance; train only where it helps</a:t>
             </a:r>
           </a:p>
         </p:txBody>
@@ -3160,8 +3178,838 @@
         </p:nvSpPr>
         <p:spPr>
           <a:xfrm>
-            <a:off x="2240280" y="146304"/>
-            <a:ext cx="1691640" cy="310896"/>
+            <a:off x="182880" y="603504"/>
+            <a:ext cx="4114800" cy="2615184"/>
+          </a:xfrm>
+          <a:prstGeom prst="roundRect">
+            <a:avLst>
+              <a:gd name="adj" fmla="val 4000"/>
+            </a:avLst>
+          </a:prstGeom>
+          <a:solidFill>
+            <a:srgbClr val="FDF4F4"/>
+          </a:solidFill>
+          <a:ln w="16510">
+            <a:solidFill>
+              <a:srgbClr val="C62828"/>
+            </a:solidFill>
+          </a:ln>
+          <a:effectLst/>
+        </p:spPr>
+        <p:style>
+          <a:lnRef idx="1">
+            <a:schemeClr val="accent1"/>
+          </a:lnRef>
+          <a:fillRef idx="3">
+            <a:schemeClr val="accent1"/>
+          </a:fillRef>
+          <a:effectRef idx="2">
+            <a:schemeClr val="accent1"/>
+          </a:effectRef>
+          <a:fontRef idx="minor">
+            <a:schemeClr val="lt1"/>
+          </a:fontRef>
+        </p:style>
+        <p:txBody>
+          <a:bodyPr rtlCol="0" anchor="ctr"/>
+          <a:lstStyle/>
+          <a:p>
+            <a:pPr algn="ctr"/>
+          </a:p>
+        </p:txBody>
+      </p:sp>
+      <p:sp>
+        <p:nvSpPr>
+          <p:cNvPr id="4" name="Rounded Rectangle 3"/>
+          <p:cNvSpPr/>
+          <p:nvPr/>
+        </p:nvSpPr>
+        <p:spPr>
+          <a:xfrm>
+            <a:off x="182880" y="603504"/>
+            <a:ext cx="4114800" cy="420624"/>
+          </a:xfrm>
+          <a:prstGeom prst="roundRect">
+            <a:avLst>
+              <a:gd name="adj" fmla="val 12000"/>
+            </a:avLst>
+          </a:prstGeom>
+          <a:solidFill>
+            <a:srgbClr val="C62828"/>
+          </a:solidFill>
+          <a:ln>
+            <a:noFill/>
+          </a:ln>
+          <a:effectLst/>
+        </p:spPr>
+        <p:style>
+          <a:lnRef idx="1">
+            <a:schemeClr val="accent1"/>
+          </a:lnRef>
+          <a:fillRef idx="3">
+            <a:schemeClr val="accent1"/>
+          </a:fillRef>
+          <a:effectRef idx="2">
+            <a:schemeClr val="accent1"/>
+          </a:effectRef>
+          <a:fontRef idx="minor">
+            <a:schemeClr val="lt1"/>
+          </a:fontRef>
+        </p:style>
+        <p:txBody>
+          <a:bodyPr rtlCol="0" anchor="ctr" wrap="square" lIns="36576" rIns="36576" tIns="13716" bIns="13716">
+            <a:noAutofit/>
+          </a:bodyPr>
+          <a:lstStyle/>
+          <a:p>
+            <a:pPr algn="ctr">
+              <a:spcBef>
+                <a:spcPts val="0"/>
+              </a:spcBef>
+              <a:spcAft>
+                <a:spcPts val="150"/>
+              </a:spcAft>
+            </a:pPr>
+            <a:r>
+              <a:rPr sz="850" b="1">
+                <a:solidFill>
+                  <a:srgbClr val="FFFFFF"/>
+                </a:solidFill>
+                <a:latin typeface="Calibri"/>
+              </a:rPr>
+              <a:t>PROBLEM   </a:t>
+            </a:r>
+            <a:r>
+              <a:rPr sz="1150" b="1">
+                <a:solidFill>
+                  <a:srgbClr val="FFFFFF"/>
+                </a:solidFill>
+                <a:latin typeface="Calibri"/>
+              </a:rPr>
+              <a:t>C1 · The disconnect</a:t>
+            </a:r>
+          </a:p>
+        </p:txBody>
+      </p:sp>
+      <p:sp>
+        <p:nvSpPr>
+          <p:cNvPr id="5" name="Rounded Rectangle 4"/>
+          <p:cNvSpPr/>
+          <p:nvPr/>
+        </p:nvSpPr>
+        <p:spPr>
+          <a:xfrm>
+            <a:off x="4572000" y="603504"/>
+            <a:ext cx="4114800" cy="2615184"/>
+          </a:xfrm>
+          <a:prstGeom prst="roundRect">
+            <a:avLst>
+              <a:gd name="adj" fmla="val 4000"/>
+            </a:avLst>
+          </a:prstGeom>
+          <a:solidFill>
+            <a:srgbClr val="F3F7FD"/>
+          </a:solidFill>
+          <a:ln w="16510">
+            <a:solidFill>
+              <a:srgbClr val="1565C0"/>
+            </a:solidFill>
+          </a:ln>
+          <a:effectLst/>
+        </p:spPr>
+        <p:style>
+          <a:lnRef idx="1">
+            <a:schemeClr val="accent1"/>
+          </a:lnRef>
+          <a:fillRef idx="3">
+            <a:schemeClr val="accent1"/>
+          </a:fillRef>
+          <a:effectRef idx="2">
+            <a:schemeClr val="accent1"/>
+          </a:effectRef>
+          <a:fontRef idx="minor">
+            <a:schemeClr val="lt1"/>
+          </a:fontRef>
+        </p:style>
+        <p:txBody>
+          <a:bodyPr rtlCol="0" anchor="ctr"/>
+          <a:lstStyle/>
+          <a:p>
+            <a:pPr algn="ctr"/>
+          </a:p>
+        </p:txBody>
+      </p:sp>
+      <p:sp>
+        <p:nvSpPr>
+          <p:cNvPr id="6" name="Rounded Rectangle 5"/>
+          <p:cNvSpPr/>
+          <p:nvPr/>
+        </p:nvSpPr>
+        <p:spPr>
+          <a:xfrm>
+            <a:off x="4572000" y="603504"/>
+            <a:ext cx="4114800" cy="420624"/>
+          </a:xfrm>
+          <a:prstGeom prst="roundRect">
+            <a:avLst>
+              <a:gd name="adj" fmla="val 12000"/>
+            </a:avLst>
+          </a:prstGeom>
+          <a:solidFill>
+            <a:srgbClr val="1565C0"/>
+          </a:solidFill>
+          <a:ln>
+            <a:noFill/>
+          </a:ln>
+          <a:effectLst/>
+        </p:spPr>
+        <p:style>
+          <a:lnRef idx="1">
+            <a:schemeClr val="accent1"/>
+          </a:lnRef>
+          <a:fillRef idx="3">
+            <a:schemeClr val="accent1"/>
+          </a:fillRef>
+          <a:effectRef idx="2">
+            <a:schemeClr val="accent1"/>
+          </a:effectRef>
+          <a:fontRef idx="minor">
+            <a:schemeClr val="lt1"/>
+          </a:fontRef>
+        </p:style>
+        <p:txBody>
+          <a:bodyPr rtlCol="0" anchor="ctr" wrap="square" lIns="36576" rIns="36576" tIns="13716" bIns="13716">
+            <a:noAutofit/>
+          </a:bodyPr>
+          <a:lstStyle/>
+          <a:p>
+            <a:pPr algn="ctr">
+              <a:spcBef>
+                <a:spcPts val="0"/>
+              </a:spcBef>
+              <a:spcAft>
+                <a:spcPts val="150"/>
+              </a:spcAft>
+            </a:pPr>
+            <a:r>
+              <a:rPr sz="850" b="1">
+                <a:solidFill>
+                  <a:srgbClr val="FFFFFF"/>
+                </a:solidFill>
+                <a:latin typeface="Calibri"/>
+              </a:rPr>
+              <a:t>DIAGNOSE   </a:t>
+            </a:r>
+            <a:r>
+              <a:rPr sz="1150" b="1">
+                <a:solidFill>
+                  <a:srgbClr val="FFFFFF"/>
+                </a:solidFill>
+                <a:latin typeface="Calibri"/>
+              </a:rPr>
+              <a:t>C2 · Coverage diagnostic</a:t>
+            </a:r>
+          </a:p>
+        </p:txBody>
+      </p:sp>
+      <p:sp>
+        <p:nvSpPr>
+          <p:cNvPr id="7" name="Rounded Rectangle 6"/>
+          <p:cNvSpPr/>
+          <p:nvPr/>
+        </p:nvSpPr>
+        <p:spPr>
+          <a:xfrm>
+            <a:off x="182880" y="3493008"/>
+            <a:ext cx="4114800" cy="2615184"/>
+          </a:xfrm>
+          <a:prstGeom prst="roundRect">
+            <a:avLst>
+              <a:gd name="adj" fmla="val 4000"/>
+            </a:avLst>
+          </a:prstGeom>
+          <a:solidFill>
+            <a:srgbClr val="F2F9F3"/>
+          </a:solidFill>
+          <a:ln w="16510">
+            <a:solidFill>
+              <a:srgbClr val="2E7D32"/>
+            </a:solidFill>
+          </a:ln>
+          <a:effectLst/>
+        </p:spPr>
+        <p:style>
+          <a:lnRef idx="1">
+            <a:schemeClr val="accent1"/>
+          </a:lnRef>
+          <a:fillRef idx="3">
+            <a:schemeClr val="accent1"/>
+          </a:fillRef>
+          <a:effectRef idx="2">
+            <a:schemeClr val="accent1"/>
+          </a:effectRef>
+          <a:fontRef idx="minor">
+            <a:schemeClr val="lt1"/>
+          </a:fontRef>
+        </p:style>
+        <p:txBody>
+          <a:bodyPr rtlCol="0" anchor="ctr"/>
+          <a:lstStyle/>
+          <a:p>
+            <a:pPr algn="ctr"/>
+          </a:p>
+        </p:txBody>
+      </p:sp>
+      <p:sp>
+        <p:nvSpPr>
+          <p:cNvPr id="8" name="Rounded Rectangle 7"/>
+          <p:cNvSpPr/>
+          <p:nvPr/>
+        </p:nvSpPr>
+        <p:spPr>
+          <a:xfrm>
+            <a:off x="182880" y="3493008"/>
+            <a:ext cx="4114800" cy="420624"/>
+          </a:xfrm>
+          <a:prstGeom prst="roundRect">
+            <a:avLst>
+              <a:gd name="adj" fmla="val 12000"/>
+            </a:avLst>
+          </a:prstGeom>
+          <a:solidFill>
+            <a:srgbClr val="2E7D32"/>
+          </a:solidFill>
+          <a:ln>
+            <a:noFill/>
+          </a:ln>
+          <a:effectLst/>
+        </p:spPr>
+        <p:style>
+          <a:lnRef idx="1">
+            <a:schemeClr val="accent1"/>
+          </a:lnRef>
+          <a:fillRef idx="3">
+            <a:schemeClr val="accent1"/>
+          </a:fillRef>
+          <a:effectRef idx="2">
+            <a:schemeClr val="accent1"/>
+          </a:effectRef>
+          <a:fontRef idx="minor">
+            <a:schemeClr val="lt1"/>
+          </a:fontRef>
+        </p:style>
+        <p:txBody>
+          <a:bodyPr rtlCol="0" anchor="ctr" wrap="square" lIns="36576" rIns="36576" tIns="13716" bIns="13716">
+            <a:noAutofit/>
+          </a:bodyPr>
+          <a:lstStyle/>
+          <a:p>
+            <a:pPr algn="ctr">
+              <a:spcBef>
+                <a:spcPts val="0"/>
+              </a:spcBef>
+              <a:spcAft>
+                <a:spcPts val="150"/>
+              </a:spcAft>
+            </a:pPr>
+            <a:r>
+              <a:rPr sz="850" b="1">
+                <a:solidFill>
+                  <a:srgbClr val="FFFFFF"/>
+                </a:solidFill>
+                <a:latin typeface="Calibri"/>
+              </a:rPr>
+              <a:t>SELECT   </a:t>
+            </a:r>
+            <a:r>
+              <a:rPr sz="1150" b="1">
+                <a:solidFill>
+                  <a:srgbClr val="FFFFFF"/>
+                </a:solidFill>
+                <a:latin typeface="Calibri"/>
+              </a:rPr>
+              <a:t>C3 · RCPS protocol</a:t>
+            </a:r>
+          </a:p>
+        </p:txBody>
+      </p:sp>
+      <p:sp>
+        <p:nvSpPr>
+          <p:cNvPr id="9" name="Rounded Rectangle 8"/>
+          <p:cNvSpPr/>
+          <p:nvPr/>
+        </p:nvSpPr>
+        <p:spPr>
+          <a:xfrm>
+            <a:off x="4572000" y="3493008"/>
+            <a:ext cx="4114800" cy="2615184"/>
+          </a:xfrm>
+          <a:prstGeom prst="roundRect">
+            <a:avLst>
+              <a:gd name="adj" fmla="val 4000"/>
+            </a:avLst>
+          </a:prstGeom>
+          <a:solidFill>
+            <a:srgbClr val="FDF6EF"/>
+          </a:solidFill>
+          <a:ln w="16510">
+            <a:solidFill>
+              <a:srgbClr val="E65100"/>
+            </a:solidFill>
+          </a:ln>
+          <a:effectLst/>
+        </p:spPr>
+        <p:style>
+          <a:lnRef idx="1">
+            <a:schemeClr val="accent1"/>
+          </a:lnRef>
+          <a:fillRef idx="3">
+            <a:schemeClr val="accent1"/>
+          </a:fillRef>
+          <a:effectRef idx="2">
+            <a:schemeClr val="accent1"/>
+          </a:effectRef>
+          <a:fontRef idx="minor">
+            <a:schemeClr val="lt1"/>
+          </a:fontRef>
+        </p:style>
+        <p:txBody>
+          <a:bodyPr rtlCol="0" anchor="ctr"/>
+          <a:lstStyle/>
+          <a:p>
+            <a:pPr algn="ctr"/>
+          </a:p>
+        </p:txBody>
+      </p:sp>
+      <p:sp>
+        <p:nvSpPr>
+          <p:cNvPr id="10" name="Rounded Rectangle 9"/>
+          <p:cNvSpPr/>
+          <p:nvPr/>
+        </p:nvSpPr>
+        <p:spPr>
+          <a:xfrm>
+            <a:off x="4572000" y="3493008"/>
+            <a:ext cx="4114800" cy="420624"/>
+          </a:xfrm>
+          <a:prstGeom prst="roundRect">
+            <a:avLst>
+              <a:gd name="adj" fmla="val 12000"/>
+            </a:avLst>
+          </a:prstGeom>
+          <a:solidFill>
+            <a:srgbClr val="E65100"/>
+          </a:solidFill>
+          <a:ln>
+            <a:noFill/>
+          </a:ln>
+          <a:effectLst/>
+        </p:spPr>
+        <p:style>
+          <a:lnRef idx="1">
+            <a:schemeClr val="accent1"/>
+          </a:lnRef>
+          <a:fillRef idx="3">
+            <a:schemeClr val="accent1"/>
+          </a:fillRef>
+          <a:effectRef idx="2">
+            <a:schemeClr val="accent1"/>
+          </a:effectRef>
+          <a:fontRef idx="minor">
+            <a:schemeClr val="lt1"/>
+          </a:fontRef>
+        </p:style>
+        <p:txBody>
+          <a:bodyPr rtlCol="0" anchor="ctr" wrap="square" lIns="36576" rIns="36576" tIns="13716" bIns="13716">
+            <a:noAutofit/>
+          </a:bodyPr>
+          <a:lstStyle/>
+          <a:p>
+            <a:pPr algn="ctr">
+              <a:spcBef>
+                <a:spcPts val="0"/>
+              </a:spcBef>
+              <a:spcAft>
+                <a:spcPts val="150"/>
+              </a:spcAft>
+            </a:pPr>
+            <a:r>
+              <a:rPr sz="850" b="1">
+                <a:solidFill>
+                  <a:srgbClr val="FFFFFF"/>
+                </a:solidFill>
+                <a:latin typeface="Calibri"/>
+              </a:rPr>
+              <a:t>IMPROVE   </a:t>
+            </a:r>
+            <a:r>
+              <a:rPr sz="1150" b="1">
+                <a:solidFill>
+                  <a:srgbClr val="FFFFFF"/>
+                </a:solidFill>
+                <a:latin typeface="Calibri"/>
+              </a:rPr>
+              <a:t>C4 · Bounded training</a:t>
+            </a:r>
+          </a:p>
+        </p:txBody>
+      </p:sp>
+      <p:sp>
+        <p:nvSpPr>
+          <p:cNvPr id="11" name="Rounded Rectangle 10"/>
+          <p:cNvSpPr/>
+          <p:nvPr/>
+        </p:nvSpPr>
+        <p:spPr>
+          <a:xfrm>
+            <a:off x="1673351" y="1115568"/>
+            <a:ext cx="1133856" cy="310896"/>
+          </a:xfrm>
+          <a:prstGeom prst="roundRect">
+            <a:avLst>
+              <a:gd name="adj" fmla="val 12000"/>
+            </a:avLst>
+          </a:prstGeom>
+          <a:solidFill>
+            <a:srgbClr val="FFFFFF"/>
+          </a:solidFill>
+          <a:ln w="12700">
+            <a:solidFill>
+              <a:srgbClr val="C2CBD2"/>
+            </a:solidFill>
+          </a:ln>
+          <a:effectLst/>
+        </p:spPr>
+        <p:style>
+          <a:lnRef idx="1">
+            <a:schemeClr val="accent1"/>
+          </a:lnRef>
+          <a:fillRef idx="3">
+            <a:schemeClr val="accent1"/>
+          </a:fillRef>
+          <a:effectRef idx="2">
+            <a:schemeClr val="accent1"/>
+          </a:effectRef>
+          <a:fontRef idx="minor">
+            <a:schemeClr val="lt1"/>
+          </a:fontRef>
+        </p:style>
+        <p:txBody>
+          <a:bodyPr rtlCol="0" anchor="ctr" wrap="square" lIns="36576" rIns="36576" tIns="13716" bIns="13716">
+            <a:noAutofit/>
+          </a:bodyPr>
+          <a:lstStyle/>
+          <a:p>
+            <a:pPr algn="ctr">
+              <a:spcBef>
+                <a:spcPts val="0"/>
+              </a:spcBef>
+              <a:spcAft>
+                <a:spcPts val="150"/>
+              </a:spcAft>
+            </a:pPr>
+            <a:r>
+              <a:rPr sz="900" b="1">
+                <a:solidFill>
+                  <a:srgbClr val="1F3247"/>
+                </a:solidFill>
+                <a:latin typeface="Calibri"/>
+              </a:rPr>
+              <a:t>Parser output</a:t>
+            </a:r>
+          </a:p>
+        </p:txBody>
+      </p:sp>
+      <p:sp>
+        <p:nvSpPr>
+          <p:cNvPr id="12" name="Rounded Rectangle 11"/>
+          <p:cNvSpPr/>
+          <p:nvPr/>
+        </p:nvSpPr>
+        <p:spPr>
+          <a:xfrm>
+            <a:off x="310896" y="1700784"/>
+            <a:ext cx="1847088" cy="713232"/>
+          </a:xfrm>
+          <a:prstGeom prst="roundRect">
+            <a:avLst>
+              <a:gd name="adj" fmla="val 12000"/>
+            </a:avLst>
+          </a:prstGeom>
+          <a:solidFill>
+            <a:srgbClr val="F4F5F6"/>
+          </a:solidFill>
+          <a:ln w="12700">
+            <a:solidFill>
+              <a:srgbClr val="C2CBD2"/>
+            </a:solidFill>
+          </a:ln>
+          <a:effectLst/>
+        </p:spPr>
+        <p:style>
+          <a:lnRef idx="1">
+            <a:schemeClr val="accent1"/>
+          </a:lnRef>
+          <a:fillRef idx="3">
+            <a:schemeClr val="accent1"/>
+          </a:fillRef>
+          <a:effectRef idx="2">
+            <a:schemeClr val="accent1"/>
+          </a:effectRef>
+          <a:fontRef idx="minor">
+            <a:schemeClr val="lt1"/>
+          </a:fontRef>
+        </p:style>
+        <p:txBody>
+          <a:bodyPr rtlCol="0" anchor="ctr" wrap="square" lIns="36576" rIns="36576" tIns="13716" bIns="13716">
+            <a:noAutofit/>
+          </a:bodyPr>
+          <a:lstStyle/>
+          <a:p>
+            <a:pPr algn="ctr">
+              <a:spcBef>
+                <a:spcPts val="0"/>
+              </a:spcBef>
+              <a:spcAft>
+                <a:spcPts val="150"/>
+              </a:spcAft>
+            </a:pPr>
+            <a:r>
+              <a:rPr sz="850" b="1">
+                <a:solidFill>
+                  <a:srgbClr val="8A8F96"/>
+                </a:solidFill>
+                <a:latin typeface="Calibri"/>
+              </a:rPr>
+              <a:t>Appearance</a:t>
+            </a:r>
+          </a:p>
+          <a:p>
+            <a:pPr algn="ctr">
+              <a:spcBef>
+                <a:spcPts val="0"/>
+              </a:spcBef>
+              <a:spcAft>
+                <a:spcPts val="200"/>
+              </a:spcAft>
+            </a:pPr>
+            <a:r>
+              <a:rPr sz="750" b="0">
+                <a:solidFill>
+                  <a:srgbClr val="55636E"/>
+                </a:solidFill>
+                <a:latin typeface="Calibri"/>
+              </a:rPr>
+              <a:t>BC · edit-dist</a:t>
+            </a:r>
+          </a:p>
+          <a:p>
+            <a:pPr algn="ctr">
+              <a:spcBef>
+                <a:spcPts val="0"/>
+              </a:spcBef>
+              <a:spcAft>
+                <a:spcPts val="150"/>
+              </a:spcAft>
+            </a:pPr>
+            <a:r>
+              <a:rPr sz="800" b="1">
+                <a:solidFill>
+                  <a:srgbClr val="C62828"/>
+                </a:solidFill>
+                <a:latin typeface="Calibri"/>
+              </a:rPr>
+              <a:t>MinerU ranks #1</a:t>
+            </a:r>
+          </a:p>
+        </p:txBody>
+      </p:sp>
+      <p:sp>
+        <p:nvSpPr>
+          <p:cNvPr id="13" name="Rounded Rectangle 12"/>
+          <p:cNvSpPr/>
+          <p:nvPr/>
+        </p:nvSpPr>
+        <p:spPr>
+          <a:xfrm>
+            <a:off x="2322576" y="1700784"/>
+            <a:ext cx="1847088" cy="713232"/>
+          </a:xfrm>
+          <a:prstGeom prst="roundRect">
+            <a:avLst>
+              <a:gd name="adj" fmla="val 12000"/>
+            </a:avLst>
+          </a:prstGeom>
+          <a:solidFill>
+            <a:srgbClr val="EAF4EC"/>
+          </a:solidFill>
+          <a:ln w="12700">
+            <a:solidFill>
+              <a:srgbClr val="C2CBD2"/>
+            </a:solidFill>
+          </a:ln>
+          <a:effectLst/>
+        </p:spPr>
+        <p:style>
+          <a:lnRef idx="1">
+            <a:schemeClr val="accent1"/>
+          </a:lnRef>
+          <a:fillRef idx="3">
+            <a:schemeClr val="accent1"/>
+          </a:fillRef>
+          <a:effectRef idx="2">
+            <a:schemeClr val="accent1"/>
+          </a:effectRef>
+          <a:fontRef idx="minor">
+            <a:schemeClr val="lt1"/>
+          </a:fontRef>
+        </p:style>
+        <p:txBody>
+          <a:bodyPr rtlCol="0" anchor="ctr" wrap="square" lIns="36576" rIns="36576" tIns="13716" bIns="13716">
+            <a:noAutofit/>
+          </a:bodyPr>
+          <a:lstStyle/>
+          <a:p>
+            <a:pPr algn="ctr">
+              <a:spcBef>
+                <a:spcPts val="0"/>
+              </a:spcBef>
+              <a:spcAft>
+                <a:spcPts val="150"/>
+              </a:spcAft>
+            </a:pPr>
+            <a:r>
+              <a:rPr sz="850" b="1">
+                <a:solidFill>
+                  <a:srgbClr val="2E7D32"/>
+                </a:solidFill>
+                <a:latin typeface="Calibri"/>
+              </a:rPr>
+              <a:t>Retrieval</a:t>
+            </a:r>
+          </a:p>
+          <a:p>
+            <a:pPr algn="ctr">
+              <a:spcBef>
+                <a:spcPts val="0"/>
+              </a:spcBef>
+              <a:spcAft>
+                <a:spcPts val="200"/>
+              </a:spcAft>
+            </a:pPr>
+            <a:r>
+              <a:rPr sz="750" b="0">
+                <a:solidFill>
+                  <a:srgbClr val="55636E"/>
+                </a:solidFill>
+                <a:latin typeface="Calibri"/>
+              </a:rPr>
+              <a:t>RCPS</a:t>
+            </a:r>
+          </a:p>
+          <a:p>
+            <a:pPr algn="ctr">
+              <a:spcBef>
+                <a:spcPts val="0"/>
+              </a:spcBef>
+              <a:spcAft>
+                <a:spcPts val="150"/>
+              </a:spcAft>
+            </a:pPr>
+            <a:r>
+              <a:rPr sz="800" b="1">
+                <a:solidFill>
+                  <a:srgbClr val="2E7D32"/>
+                </a:solidFill>
+                <a:latin typeface="Calibri"/>
+              </a:rPr>
+              <a:t>MinerU ranks LAST</a:t>
+            </a:r>
+          </a:p>
+        </p:txBody>
+      </p:sp>
+      <p:cxnSp>
+        <p:nvCxnSpPr>
+          <p:cNvPr id="14" name="Connector 13"/>
+          <p:cNvCxnSpPr/>
+          <p:nvPr/>
+        </p:nvCxnSpPr>
+        <p:spPr>
+          <a:xfrm flipH="1">
+            <a:off x="1234440" y="1426464"/>
+            <a:ext cx="731520" cy="274320"/>
+          </a:xfrm>
+          <a:prstGeom prst="line">
+            <a:avLst/>
+          </a:prstGeom>
+          <a:ln w="19050">
+            <a:solidFill>
+              <a:srgbClr val="8A98A4"/>
+            </a:solidFill>
+            <a:tailEnd type="triangle" w="med" len="med"/>
+          </a:ln>
+        </p:spPr>
+        <p:style>
+          <a:lnRef idx="2">
+            <a:schemeClr val="accent1"/>
+          </a:lnRef>
+          <a:fillRef idx="0">
+            <a:schemeClr val="accent1"/>
+          </a:fillRef>
+          <a:effectRef idx="1">
+            <a:schemeClr val="accent1"/>
+          </a:effectRef>
+          <a:fontRef idx="minor">
+            <a:schemeClr val="tx1"/>
+          </a:fontRef>
+        </p:style>
+      </p:cxnSp>
+      <p:cxnSp>
+        <p:nvCxnSpPr>
+          <p:cNvPr id="15" name="Connector 14"/>
+          <p:cNvCxnSpPr/>
+          <p:nvPr/>
+        </p:nvCxnSpPr>
+        <p:spPr>
+          <a:xfrm>
+            <a:off x="2514599" y="1426464"/>
+            <a:ext cx="731521" cy="274320"/>
+          </a:xfrm>
+          <a:prstGeom prst="line">
+            <a:avLst/>
+          </a:prstGeom>
+          <a:ln w="19050">
+            <a:solidFill>
+              <a:srgbClr val="8A98A4"/>
+            </a:solidFill>
+            <a:tailEnd type="triangle" w="med" len="med"/>
+          </a:ln>
+        </p:spPr>
+        <p:style>
+          <a:lnRef idx="2">
+            <a:schemeClr val="accent1"/>
+          </a:lnRef>
+          <a:fillRef idx="0">
+            <a:schemeClr val="accent1"/>
+          </a:fillRef>
+          <a:effectRef idx="1">
+            <a:schemeClr val="accent1"/>
+          </a:effectRef>
+          <a:fontRef idx="minor">
+            <a:schemeClr val="tx1"/>
+          </a:fontRef>
+        </p:style>
+      </p:cxnSp>
+      <p:sp>
+        <p:nvSpPr>
+          <p:cNvPr id="16" name="Rounded Rectangle 15"/>
+          <p:cNvSpPr/>
+          <p:nvPr/>
+        </p:nvSpPr>
+        <p:spPr>
+          <a:xfrm>
+            <a:off x="310896" y="2743200"/>
+            <a:ext cx="3858768" cy="347472"/>
           </a:xfrm>
           <a:prstGeom prst="roundRect">
             <a:avLst>
@@ -3169,7 +4017,7 @@
             </a:avLst>
           </a:prstGeom>
           <a:solidFill>
-            <a:srgbClr val="37474F"/>
+            <a:srgbClr val="FBE9EA"/>
           </a:solidFill>
           <a:ln>
             <a:noFill/>
@@ -3191,7 +4039,7 @@
           </a:fontRef>
         </p:style>
         <p:txBody>
-          <a:bodyPr rtlCol="0" anchor="ctr" wrap="square" lIns="18288" rIns="18288" tIns="18288" bIns="18288">
+          <a:bodyPr rtlCol="0" anchor="ctr" wrap="square" lIns="36576" rIns="36576" tIns="13716" bIns="13716">
             <a:noAutofit/>
           </a:bodyPr>
           <a:lstStyle/>
@@ -3201,39 +4049,198 @@
                 <a:spcPts val="0"/>
               </a:spcBef>
               <a:spcAft>
-                <a:spcPts val="300"/>
+                <a:spcPts val="150"/>
               </a:spcAft>
             </a:pPr>
             <a:r>
-              <a:rPr sz="1250" b="1">
-                <a:solidFill>
-                  <a:srgbClr val="FFFFFF"/>
+              <a:rPr sz="900" b="1">
+                <a:solidFill>
+                  <a:srgbClr val="C62828"/>
                 </a:solidFill>
                 <a:latin typeface="Calibri"/>
               </a:rPr>
-              <a:t>Parse</a:t>
-            </a:r>
-          </a:p>
-        </p:txBody>
-      </p:sp>
-      <p:sp>
-        <p:nvSpPr>
-          <p:cNvPr id="4" name="Rounded Rectangle 3"/>
+              <a:t>BC ↔ RCPS  r = −0.81</a:t>
+            </a:r>
+            <a:r>
+              <a:rPr sz="850" b="0">
+                <a:solidFill>
+                  <a:srgbClr val="1F3247"/>
+                </a:solidFill>
+                <a:latin typeface="Calibri"/>
+              </a:rPr>
+              <a:t>   ·   parser choice → Hit@1 </a:t>
+            </a:r>
+            <a:r>
+              <a:rPr sz="950" b="1">
+                <a:solidFill>
+                  <a:srgbClr val="C62828"/>
+                </a:solidFill>
+                <a:latin typeface="Calibri"/>
+              </a:rPr>
+              <a:t>2.8×</a:t>
+            </a:r>
+            <a:r>
+              <a:rPr sz="850" b="0">
+                <a:solidFill>
+                  <a:srgbClr val="1F3247"/>
+                </a:solidFill>
+                <a:latin typeface="Calibri"/>
+              </a:rPr>
+              <a:t> (0.20→0.55)</a:t>
+            </a:r>
+          </a:p>
+        </p:txBody>
+      </p:sp>
+      <p:sp>
+        <p:nvSpPr>
+          <p:cNvPr id="17" name="Rounded Rectangle 16"/>
           <p:cNvSpPr/>
           <p:nvPr/>
         </p:nvSpPr>
         <p:spPr>
           <a:xfrm>
-            <a:off x="4297680" y="146304"/>
-            <a:ext cx="1691640" cy="310896"/>
+            <a:off x="5971032" y="1115568"/>
+            <a:ext cx="1316736" cy="292608"/>
           </a:xfrm>
           <a:prstGeom prst="roundRect">
             <a:avLst>
-              <a:gd name="adj" fmla="val 18000"/>
+              <a:gd name="adj" fmla="val 12000"/>
             </a:avLst>
           </a:prstGeom>
           <a:solidFill>
-            <a:srgbClr val="37474F"/>
+            <a:srgbClr val="FFFFFF"/>
+          </a:solidFill>
+          <a:ln w="12700">
+            <a:solidFill>
+              <a:srgbClr val="C2CBD2"/>
+            </a:solidFill>
+          </a:ln>
+          <a:effectLst/>
+        </p:spPr>
+        <p:style>
+          <a:lnRef idx="1">
+            <a:schemeClr val="accent1"/>
+          </a:lnRef>
+          <a:fillRef idx="3">
+            <a:schemeClr val="accent1"/>
+          </a:fillRef>
+          <a:effectRef idx="2">
+            <a:schemeClr val="accent1"/>
+          </a:effectRef>
+          <a:fontRef idx="minor">
+            <a:schemeClr val="lt1"/>
+          </a:fontRef>
+        </p:style>
+        <p:txBody>
+          <a:bodyPr rtlCol="0" anchor="ctr" wrap="square" lIns="36576" rIns="36576" tIns="13716" bIns="13716">
+            <a:noAutofit/>
+          </a:bodyPr>
+          <a:lstStyle/>
+          <a:p>
+            <a:pPr algn="ctr">
+              <a:spcBef>
+                <a:spcPts val="0"/>
+              </a:spcBef>
+              <a:spcAft>
+                <a:spcPts val="150"/>
+              </a:spcAft>
+            </a:pPr>
+            <a:r>
+              <a:rPr sz="850" b="1">
+                <a:solidFill>
+                  <a:srgbClr val="1F3247"/>
+                </a:solidFill>
+                <a:latin typeface="Calibri"/>
+              </a:rPr>
+              <a:t>gold answer span</a:t>
+            </a:r>
+          </a:p>
+        </p:txBody>
+      </p:sp>
+      <p:sp>
+        <p:nvSpPr>
+          <p:cNvPr id="18" name="Rounded Rectangle 17"/>
+          <p:cNvSpPr/>
+          <p:nvPr/>
+        </p:nvSpPr>
+        <p:spPr>
+          <a:xfrm>
+            <a:off x="4974336" y="1499616"/>
+            <a:ext cx="3310127" cy="274320"/>
+          </a:xfrm>
+          <a:prstGeom prst="roundRect">
+            <a:avLst>
+              <a:gd name="adj" fmla="val 12000"/>
+            </a:avLst>
+          </a:prstGeom>
+          <a:solidFill>
+            <a:srgbClr val="E7EFFB"/>
+          </a:solidFill>
+          <a:ln w="12700">
+            <a:solidFill>
+              <a:srgbClr val="C2CBD2"/>
+            </a:solidFill>
+          </a:ln>
+          <a:effectLst/>
+        </p:spPr>
+        <p:style>
+          <a:lnRef idx="1">
+            <a:schemeClr val="accent1"/>
+          </a:lnRef>
+          <a:fillRef idx="3">
+            <a:schemeClr val="accent1"/>
+          </a:fillRef>
+          <a:effectRef idx="2">
+            <a:schemeClr val="accent1"/>
+          </a:effectRef>
+          <a:fontRef idx="minor">
+            <a:schemeClr val="lt1"/>
+          </a:fontRef>
+        </p:style>
+        <p:txBody>
+          <a:bodyPr rtlCol="0" anchor="ctr" wrap="square" lIns="36576" rIns="36576" tIns="13716" bIns="13716">
+            <a:noAutofit/>
+          </a:bodyPr>
+          <a:lstStyle/>
+          <a:p>
+            <a:pPr algn="ctr">
+              <a:spcBef>
+                <a:spcPts val="0"/>
+              </a:spcBef>
+              <a:spcAft>
+                <a:spcPts val="150"/>
+              </a:spcAft>
+            </a:pPr>
+            <a:r>
+              <a:rPr sz="850" b="1">
+                <a:solidFill>
+                  <a:srgbClr val="1565C0"/>
+                </a:solidFill>
+                <a:latin typeface="Calibri"/>
+              </a:rPr>
+              <a:t>in parser output?</a:t>
+            </a:r>
+          </a:p>
+        </p:txBody>
+      </p:sp>
+      <p:sp>
+        <p:nvSpPr>
+          <p:cNvPr id="19" name="Rounded Rectangle 18"/>
+          <p:cNvSpPr/>
+          <p:nvPr/>
+        </p:nvSpPr>
+        <p:spPr>
+          <a:xfrm>
+            <a:off x="7077455" y="1865376"/>
+            <a:ext cx="1481328" cy="310896"/>
+          </a:xfrm>
+          <a:prstGeom prst="roundRect">
+            <a:avLst>
+              <a:gd name="adj" fmla="val 12000"/>
+            </a:avLst>
+          </a:prstGeom>
+          <a:solidFill>
+            <a:srgbClr val="C62828"/>
           </a:solidFill>
           <a:ln>
             <a:noFill/>
@@ -3255,7 +4262,7 @@
           </a:fontRef>
         </p:style>
         <p:txBody>
-          <a:bodyPr rtlCol="0" anchor="ctr" wrap="square" lIns="18288" rIns="18288" tIns="18288" bIns="18288">
+          <a:bodyPr rtlCol="0" anchor="ctr" wrap="square" lIns="36576" rIns="36576" tIns="13716" bIns="13716">
             <a:noAutofit/>
           </a:bodyPr>
           <a:lstStyle/>
@@ -3265,39 +4272,114 @@
                 <a:spcPts val="0"/>
               </a:spcBef>
               <a:spcAft>
-                <a:spcPts val="300"/>
+                <a:spcPts val="150"/>
               </a:spcAft>
             </a:pPr>
             <a:r>
-              <a:rPr sz="1250" b="1">
+              <a:rPr sz="850" b="1">
                 <a:solidFill>
                   <a:srgbClr val="FFFFFF"/>
                 </a:solidFill>
                 <a:latin typeface="Calibri"/>
               </a:rPr>
-              <a:t>Chunk</a:t>
-            </a:r>
-          </a:p>
-        </p:txBody>
-      </p:sp>
-      <p:sp>
-        <p:nvSpPr>
-          <p:cNvPr id="5" name="Rounded Rectangle 4"/>
+              <a:t>ABSENT  20.2%</a:t>
+            </a:r>
+            <a:r>
+              <a:rPr sz="750" b="0">
+                <a:solidFill>
+                  <a:srgbClr val="FFFFFF"/>
+                </a:solidFill>
+                <a:latin typeface="Calibri"/>
+              </a:rPr>
+              <a:t>  parser fault</a:t>
+            </a:r>
+          </a:p>
+        </p:txBody>
+      </p:sp>
+      <p:sp>
+        <p:nvSpPr>
+          <p:cNvPr id="20" name="Rounded Rectangle 19"/>
           <p:cNvSpPr/>
           <p:nvPr/>
         </p:nvSpPr>
         <p:spPr>
           <a:xfrm>
-            <a:off x="6355080" y="146304"/>
-            <a:ext cx="1691640" cy="310896"/>
+            <a:off x="4700016" y="1865376"/>
+            <a:ext cx="1700784" cy="274320"/>
           </a:xfrm>
           <a:prstGeom prst="roundRect">
             <a:avLst>
-              <a:gd name="adj" fmla="val 18000"/>
+              <a:gd name="adj" fmla="val 12000"/>
             </a:avLst>
           </a:prstGeom>
           <a:solidFill>
-            <a:srgbClr val="37474F"/>
+            <a:srgbClr val="E7EFFB"/>
+          </a:solidFill>
+          <a:ln w="12700">
+            <a:solidFill>
+              <a:srgbClr val="C2CBD2"/>
+            </a:solidFill>
+          </a:ln>
+          <a:effectLst/>
+        </p:spPr>
+        <p:style>
+          <a:lnRef idx="1">
+            <a:schemeClr val="accent1"/>
+          </a:lnRef>
+          <a:fillRef idx="3">
+            <a:schemeClr val="accent1"/>
+          </a:fillRef>
+          <a:effectRef idx="2">
+            <a:schemeClr val="accent1"/>
+          </a:effectRef>
+          <a:fontRef idx="minor">
+            <a:schemeClr val="lt1"/>
+          </a:fontRef>
+        </p:style>
+        <p:txBody>
+          <a:bodyPr rtlCol="0" anchor="ctr" wrap="square" lIns="36576" rIns="36576" tIns="13716" bIns="13716">
+            <a:noAutofit/>
+          </a:bodyPr>
+          <a:lstStyle/>
+          <a:p>
+            <a:pPr algn="ctr">
+              <a:spcBef>
+                <a:spcPts val="0"/>
+              </a:spcBef>
+              <a:spcAft>
+                <a:spcPts val="150"/>
+              </a:spcAft>
+            </a:pPr>
+            <a:r>
+              <a:rPr sz="850" b="1">
+                <a:solidFill>
+                  <a:srgbClr val="1565C0"/>
+                </a:solidFill>
+                <a:latin typeface="Calibri"/>
+              </a:rPr>
+              <a:t>fits one chunk?</a:t>
+            </a:r>
+          </a:p>
+        </p:txBody>
+      </p:sp>
+      <p:sp>
+        <p:nvSpPr>
+          <p:cNvPr id="21" name="Rounded Rectangle 20"/>
+          <p:cNvSpPr/>
+          <p:nvPr/>
+        </p:nvSpPr>
+        <p:spPr>
+          <a:xfrm>
+            <a:off x="4700016" y="2231136"/>
+            <a:ext cx="1700784" cy="310896"/>
+          </a:xfrm>
+          <a:prstGeom prst="roundRect">
+            <a:avLst>
+              <a:gd name="adj" fmla="val 12000"/>
+            </a:avLst>
+          </a:prstGeom>
+          <a:solidFill>
+            <a:srgbClr val="E68A00"/>
           </a:solidFill>
           <a:ln>
             <a:noFill/>
@@ -3319,7 +4401,7 @@
           </a:fontRef>
         </p:style>
         <p:txBody>
-          <a:bodyPr rtlCol="0" anchor="ctr" wrap="square" lIns="18288" rIns="18288" tIns="18288" bIns="18288">
+          <a:bodyPr rtlCol="0" anchor="ctr" wrap="square" lIns="36576" rIns="36576" tIns="13716" bIns="13716">
             <a:noAutofit/>
           </a:bodyPr>
           <a:lstStyle/>
@@ -3329,39 +4411,48 @@
                 <a:spcPts val="0"/>
               </a:spcBef>
               <a:spcAft>
-                <a:spcPts val="300"/>
+                <a:spcPts val="150"/>
               </a:spcAft>
             </a:pPr>
             <a:r>
-              <a:rPr sz="1250" b="1">
+              <a:rPr sz="850" b="1">
                 <a:solidFill>
                   <a:srgbClr val="FFFFFF"/>
                 </a:solidFill>
                 <a:latin typeface="Calibri"/>
               </a:rPr>
-              <a:t>Retrieve</a:t>
-            </a:r>
-          </a:p>
-        </p:txBody>
-      </p:sp>
-      <p:sp>
-        <p:nvSpPr>
-          <p:cNvPr id="6" name="Rounded Rectangle 5"/>
+              <a:t>SPLIT  ≤2.3%</a:t>
+            </a:r>
+            <a:r>
+              <a:rPr sz="750" b="0">
+                <a:solidFill>
+                  <a:srgbClr val="FFFFFF"/>
+                </a:solidFill>
+                <a:latin typeface="Calibri"/>
+              </a:rPr>
+              <a:t>  chunker fault</a:t>
+            </a:r>
+          </a:p>
+        </p:txBody>
+      </p:sp>
+      <p:sp>
+        <p:nvSpPr>
+          <p:cNvPr id="22" name="Rounded Rectangle 21"/>
           <p:cNvSpPr/>
           <p:nvPr/>
         </p:nvSpPr>
         <p:spPr>
           <a:xfrm>
-            <a:off x="8412480" y="146304"/>
-            <a:ext cx="1691640" cy="310896"/>
+            <a:off x="7077455" y="2231136"/>
+            <a:ext cx="1481328" cy="310896"/>
           </a:xfrm>
           <a:prstGeom prst="roundRect">
             <a:avLst>
-              <a:gd name="adj" fmla="val 18000"/>
+              <a:gd name="adj" fmla="val 12000"/>
             </a:avLst>
           </a:prstGeom>
           <a:solidFill>
-            <a:srgbClr val="37474F"/>
+            <a:srgbClr val="2E7D32"/>
           </a:solidFill>
           <a:ln>
             <a:noFill/>
@@ -3383,7 +4474,7 @@
           </a:fontRef>
         </p:style>
         <p:txBody>
-          <a:bodyPr rtlCol="0" anchor="ctr" wrap="square" lIns="18288" rIns="18288" tIns="18288" bIns="18288">
+          <a:bodyPr rtlCol="0" anchor="ctr" wrap="square" lIns="36576" rIns="36576" tIns="13716" bIns="13716">
             <a:noAutofit/>
           </a:bodyPr>
           <a:lstStyle/>
@@ -3393,43 +4484,265 @@
                 <a:spcPts val="0"/>
               </a:spcBef>
               <a:spcAft>
-                <a:spcPts val="300"/>
+                <a:spcPts val="150"/>
               </a:spcAft>
             </a:pPr>
             <a:r>
-              <a:rPr sz="1250" b="1">
+              <a:rPr sz="850" b="1">
                 <a:solidFill>
                   <a:srgbClr val="FFFFFF"/>
                 </a:solidFill>
                 <a:latin typeface="Calibri"/>
               </a:rPr>
-              <a:t>Generate</a:t>
-            </a:r>
-          </a:p>
-        </p:txBody>
-      </p:sp>
-      <p:sp>
-        <p:nvSpPr>
-          <p:cNvPr id="7" name="Rounded Rectangle 6"/>
+              <a:t>COVERED</a:t>
+            </a:r>
+          </a:p>
+        </p:txBody>
+      </p:sp>
+      <p:cxnSp>
+        <p:nvCxnSpPr>
+          <p:cNvPr id="23" name="Connector 22"/>
+          <p:cNvCxnSpPr/>
+          <p:nvPr/>
+        </p:nvCxnSpPr>
+        <p:spPr>
+          <a:xfrm>
+            <a:off x="6629400" y="1408176"/>
+            <a:ext cx="0" cy="91440"/>
+          </a:xfrm>
+          <a:prstGeom prst="line">
+            <a:avLst/>
+          </a:prstGeom>
+          <a:ln w="19050">
+            <a:solidFill>
+              <a:srgbClr val="8A98A4"/>
+            </a:solidFill>
+            <a:tailEnd type="triangle" w="med" len="med"/>
+          </a:ln>
+        </p:spPr>
+        <p:style>
+          <a:lnRef idx="2">
+            <a:schemeClr val="accent1"/>
+          </a:lnRef>
+          <a:fillRef idx="0">
+            <a:schemeClr val="accent1"/>
+          </a:fillRef>
+          <a:effectRef idx="1">
+            <a:schemeClr val="accent1"/>
+          </a:effectRef>
+          <a:fontRef idx="minor">
+            <a:schemeClr val="tx1"/>
+          </a:fontRef>
+        </p:style>
+      </p:cxnSp>
+      <p:cxnSp>
+        <p:nvCxnSpPr>
+          <p:cNvPr id="24" name="Connector 23"/>
+          <p:cNvCxnSpPr/>
+          <p:nvPr/>
+        </p:nvCxnSpPr>
+        <p:spPr>
+          <a:xfrm flipH="1">
+            <a:off x="7827263" y="1773936"/>
+            <a:ext cx="228600" cy="91440"/>
+          </a:xfrm>
+          <a:prstGeom prst="line">
+            <a:avLst/>
+          </a:prstGeom>
+          <a:ln w="19050">
+            <a:solidFill>
+              <a:srgbClr val="C62828"/>
+            </a:solidFill>
+            <a:tailEnd type="triangle" w="med" len="med"/>
+          </a:ln>
+        </p:spPr>
+        <p:style>
+          <a:lnRef idx="2">
+            <a:schemeClr val="accent1"/>
+          </a:lnRef>
+          <a:fillRef idx="0">
+            <a:schemeClr val="accent1"/>
+          </a:fillRef>
+          <a:effectRef idx="1">
+            <a:schemeClr val="accent1"/>
+          </a:effectRef>
+          <a:fontRef idx="minor">
+            <a:schemeClr val="tx1"/>
+          </a:fontRef>
+        </p:style>
+      </p:cxnSp>
+      <p:cxnSp>
+        <p:nvCxnSpPr>
+          <p:cNvPr id="25" name="Connector 24"/>
+          <p:cNvCxnSpPr/>
+          <p:nvPr/>
+        </p:nvCxnSpPr>
+        <p:spPr>
+          <a:xfrm>
+            <a:off x="5248655" y="1773936"/>
+            <a:ext cx="0" cy="91440"/>
+          </a:xfrm>
+          <a:prstGeom prst="line">
+            <a:avLst/>
+          </a:prstGeom>
+          <a:ln w="19050">
+            <a:solidFill>
+              <a:srgbClr val="1565C0"/>
+            </a:solidFill>
+            <a:tailEnd type="triangle" w="med" len="med"/>
+          </a:ln>
+        </p:spPr>
+        <p:style>
+          <a:lnRef idx="2">
+            <a:schemeClr val="accent1"/>
+          </a:lnRef>
+          <a:fillRef idx="0">
+            <a:schemeClr val="accent1"/>
+          </a:fillRef>
+          <a:effectRef idx="1">
+            <a:schemeClr val="accent1"/>
+          </a:effectRef>
+          <a:fontRef idx="minor">
+            <a:schemeClr val="tx1"/>
+          </a:fontRef>
+        </p:style>
+      </p:cxnSp>
+      <p:cxnSp>
+        <p:nvCxnSpPr>
+          <p:cNvPr id="26" name="Connector 25"/>
+          <p:cNvCxnSpPr/>
+          <p:nvPr/>
+        </p:nvCxnSpPr>
+        <p:spPr>
+          <a:xfrm>
+            <a:off x="5202936" y="2139696"/>
+            <a:ext cx="0" cy="91440"/>
+          </a:xfrm>
+          <a:prstGeom prst="line">
+            <a:avLst/>
+          </a:prstGeom>
+          <a:ln w="19050">
+            <a:solidFill>
+              <a:srgbClr val="E68A00"/>
+            </a:solidFill>
+            <a:tailEnd type="triangle" w="med" len="med"/>
+          </a:ln>
+        </p:spPr>
+        <p:style>
+          <a:lnRef idx="2">
+            <a:schemeClr val="accent1"/>
+          </a:lnRef>
+          <a:fillRef idx="0">
+            <a:schemeClr val="accent1"/>
+          </a:fillRef>
+          <a:effectRef idx="1">
+            <a:schemeClr val="accent1"/>
+          </a:effectRef>
+          <a:fontRef idx="minor">
+            <a:schemeClr val="tx1"/>
+          </a:fontRef>
+        </p:style>
+      </p:cxnSp>
+      <p:cxnSp>
+        <p:nvCxnSpPr>
+          <p:cNvPr id="27" name="Connector 26"/>
+          <p:cNvCxnSpPr/>
+          <p:nvPr/>
+        </p:nvCxnSpPr>
+        <p:spPr>
+          <a:xfrm>
+            <a:off x="6071616" y="2139696"/>
+            <a:ext cx="1572767" cy="91440"/>
+          </a:xfrm>
+          <a:prstGeom prst="line">
+            <a:avLst/>
+          </a:prstGeom>
+          <a:ln w="19050">
+            <a:solidFill>
+              <a:srgbClr val="2E7D32"/>
+            </a:solidFill>
+            <a:tailEnd type="triangle" w="med" len="med"/>
+          </a:ln>
+        </p:spPr>
+        <p:style>
+          <a:lnRef idx="2">
+            <a:schemeClr val="accent1"/>
+          </a:lnRef>
+          <a:fillRef idx="0">
+            <a:schemeClr val="accent1"/>
+          </a:fillRef>
+          <a:effectRef idx="1">
+            <a:schemeClr val="accent1"/>
+          </a:effectRef>
+          <a:fontRef idx="minor">
+            <a:schemeClr val="tx1"/>
+          </a:fontRef>
+        </p:style>
+      </p:cxnSp>
+      <p:sp>
+        <p:nvSpPr>
+          <p:cNvPr id="28" name="TextBox 27"/>
+          <p:cNvSpPr txBox="1"/>
+          <p:nvPr/>
+        </p:nvSpPr>
+        <p:spPr>
+          <a:xfrm>
+            <a:off x="4700016" y="2871215"/>
+            <a:ext cx="3858768" cy="219456"/>
+          </a:xfrm>
+          <a:prstGeom prst="rect">
+            <a:avLst/>
+          </a:prstGeom>
+          <a:noFill/>
+        </p:spPr>
+        <p:txBody>
+          <a:bodyPr wrap="square" anchor="ctr" lIns="36576" rIns="36576" tIns="13716" bIns="13716">
+            <a:noAutofit/>
+          </a:bodyPr>
+          <a:lstStyle/>
+          <a:p>
+            <a:pPr algn="ctr">
+              <a:spcBef>
+                <a:spcPts val="0"/>
+              </a:spcBef>
+              <a:spcAft>
+                <a:spcPts val="150"/>
+              </a:spcAft>
+            </a:pPr>
+            <a:r>
+              <a:rPr sz="750" b="0">
+                <a:solidFill>
+                  <a:srgbClr val="55636E"/>
+                </a:solidFill>
+                <a:latin typeface="Calibri"/>
+              </a:rPr>
+              <a:t>absent constant across 8 chunkers → fix the parser, not the chunker</a:t>
+            </a:r>
+          </a:p>
+        </p:txBody>
+      </p:sp>
+      <p:sp>
+        <p:nvSpPr>
+          <p:cNvPr id="29" name="Rounded Rectangle 28"/>
           <p:cNvSpPr/>
           <p:nvPr/>
         </p:nvSpPr>
         <p:spPr>
           <a:xfrm>
-            <a:off x="182880" y="548640"/>
-            <a:ext cx="1691640" cy="1335024"/>
+            <a:off x="310896" y="4005072"/>
+            <a:ext cx="3858768" cy="274320"/>
           </a:xfrm>
           <a:prstGeom prst="roundRect">
             <a:avLst>
-              <a:gd name="adj" fmla="val 6000"/>
+              <a:gd name="adj" fmla="val 12000"/>
             </a:avLst>
           </a:prstGeom>
           <a:solidFill>
             <a:srgbClr val="FFFFFF"/>
           </a:solidFill>
-          <a:ln w="13970">
+          <a:ln w="12700">
             <a:solidFill>
-              <a:srgbClr val="B0BEC5"/>
+              <a:srgbClr val="C2CBD2"/>
             </a:solidFill>
           </a:ln>
           <a:effectLst/>
@@ -3449,55 +4762,139 @@
           </a:fontRef>
         </p:style>
         <p:txBody>
-          <a:bodyPr rtlCol="0" anchor="ctr"/>
-          <a:lstStyle/>
-          <a:p>
-            <a:pPr algn="ctr"/>
-          </a:p>
-        </p:txBody>
-      </p:sp>
-      <p:pic>
-        <p:nvPicPr>
-          <p:cNvPr id="8" name="Picture 7" descr="document.png"/>
-          <p:cNvPicPr>
-            <a:picLocks noChangeAspect="1"/>
-          </p:cNvPicPr>
+          <a:bodyPr rtlCol="0" anchor="ctr" wrap="square" lIns="36576" rIns="36576" tIns="13716" bIns="13716">
+            <a:noAutofit/>
+          </a:bodyPr>
+          <a:lstStyle/>
+          <a:p>
+            <a:pPr algn="ctr">
+              <a:spcBef>
+                <a:spcPts val="0"/>
+              </a:spcBef>
+              <a:spcAft>
+                <a:spcPts val="150"/>
+              </a:spcAft>
+            </a:pPr>
+            <a:r>
+              <a:rPr sz="850" b="1">
+                <a:solidFill>
+                  <a:srgbClr val="1F3247"/>
+                </a:solidFill>
+                <a:latin typeface="Calibri"/>
+              </a:rPr>
+              <a:t>held-out Q–A probe  +  parsed corpus</a:t>
+            </a:r>
+          </a:p>
+        </p:txBody>
+      </p:sp>
+      <p:sp>
+        <p:nvSpPr>
+          <p:cNvPr id="30" name="Rounded Rectangle 29"/>
+          <p:cNvSpPr/>
           <p:nvPr/>
-        </p:nvPicPr>
-        <p:blipFill>
-          <a:blip r:embed="rId2"/>
-          <a:stretch>
-            <a:fillRect/>
-          </a:stretch>
-        </p:blipFill>
-        <p:spPr>
-          <a:xfrm>
-            <a:off x="772668" y="694944"/>
-            <a:ext cx="512064" cy="512064"/>
-          </a:xfrm>
-          <a:prstGeom prst="rect">
-            <a:avLst/>
+        </p:nvSpPr>
+        <p:spPr>
+          <a:xfrm>
+            <a:off x="1417319" y="4370832"/>
+            <a:ext cx="1645920" cy="256032"/>
+          </a:xfrm>
+          <a:prstGeom prst="roundRect">
+            <a:avLst>
+              <a:gd name="adj" fmla="val 12000"/>
+            </a:avLst>
           </a:prstGeom>
-        </p:spPr>
-      </p:pic>
-      <p:sp>
-        <p:nvSpPr>
-          <p:cNvPr id="9" name="TextBox 8"/>
-          <p:cNvSpPr txBox="1"/>
+          <a:solidFill>
+            <a:srgbClr val="EAF4EC"/>
+          </a:solidFill>
+          <a:ln w="12700">
+            <a:solidFill>
+              <a:srgbClr val="C2CBD2"/>
+            </a:solidFill>
+          </a:ln>
+          <a:effectLst/>
+        </p:spPr>
+        <p:style>
+          <a:lnRef idx="1">
+            <a:schemeClr val="accent1"/>
+          </a:lnRef>
+          <a:fillRef idx="3">
+            <a:schemeClr val="accent1"/>
+          </a:fillRef>
+          <a:effectRef idx="2">
+            <a:schemeClr val="accent1"/>
+          </a:effectRef>
+          <a:fontRef idx="minor">
+            <a:schemeClr val="lt1"/>
+          </a:fontRef>
+        </p:style>
+        <p:txBody>
+          <a:bodyPr rtlCol="0" anchor="ctr" wrap="square" lIns="36576" rIns="36576" tIns="13716" bIns="13716">
+            <a:noAutofit/>
+          </a:bodyPr>
+          <a:lstStyle/>
+          <a:p>
+            <a:pPr algn="ctr">
+              <a:spcBef>
+                <a:spcPts val="0"/>
+              </a:spcBef>
+              <a:spcAft>
+                <a:spcPts val="150"/>
+              </a:spcAft>
+            </a:pPr>
+            <a:r>
+              <a:rPr sz="800" b="1">
+                <a:solidFill>
+                  <a:srgbClr val="2E7D32"/>
+                </a:solidFill>
+                <a:latin typeface="Calibri"/>
+              </a:rPr>
+              <a:t>chunk → retrieve (MRR)</a:t>
+            </a:r>
+          </a:p>
+        </p:txBody>
+      </p:sp>
+      <p:sp>
+        <p:nvSpPr>
+          <p:cNvPr id="31" name="Rounded Rectangle 30"/>
+          <p:cNvSpPr/>
           <p:nvPr/>
         </p:nvSpPr>
         <p:spPr>
           <a:xfrm>
-            <a:off x="182880" y="1426464"/>
-            <a:ext cx="1691640" cy="420624"/>
-          </a:xfrm>
-          <a:prstGeom prst="rect">
-            <a:avLst/>
+            <a:off x="310896" y="4718304"/>
+            <a:ext cx="1237488" cy="475488"/>
+          </a:xfrm>
+          <a:prstGeom prst="roundRect">
+            <a:avLst>
+              <a:gd name="adj" fmla="val 12000"/>
+            </a:avLst>
           </a:prstGeom>
-          <a:noFill/>
-        </p:spPr>
-        <p:txBody>
-          <a:bodyPr wrap="square" anchor="t" lIns="45720" rIns="45720" tIns="36576" bIns="36576">
+          <a:solidFill>
+            <a:srgbClr val="F2F9F3"/>
+          </a:solidFill>
+          <a:ln w="12700">
+            <a:solidFill>
+              <a:srgbClr val="C2CBD2"/>
+            </a:solidFill>
+          </a:ln>
+          <a:effectLst/>
+        </p:spPr>
+        <p:style>
+          <a:lnRef idx="1">
+            <a:schemeClr val="accent1"/>
+          </a:lnRef>
+          <a:fillRef idx="3">
+            <a:schemeClr val="accent1"/>
+          </a:fillRef>
+          <a:effectRef idx="2">
+            <a:schemeClr val="accent1"/>
+          </a:effectRef>
+          <a:fontRef idx="minor">
+            <a:schemeClr val="lt1"/>
+          </a:fontRef>
+        </p:style>
+        <p:txBody>
+          <a:bodyPr rtlCol="0" anchor="ctr" wrap="square" lIns="36576" rIns="36576" tIns="13716" bIns="13716">
             <a:noAutofit/>
           </a:bodyPr>
           <a:lstStyle/>
@@ -3511,13 +4908,13 @@
               </a:spcAft>
             </a:pPr>
             <a:r>
-              <a:rPr sz="1100" b="1">
-                <a:solidFill>
-                  <a:srgbClr val="1F3247"/>
+              <a:rPr sz="780" b="1">
+                <a:solidFill>
+                  <a:srgbClr val="2E7D32"/>
                 </a:solidFill>
                 <a:latin typeface="Calibri"/>
               </a:rPr>
-              <a:t>Korean gov doc</a:t>
+              <a:t>✓ extrinsic</a:t>
             </a:r>
           </a:p>
           <a:p>
@@ -3526,43 +4923,43 @@
                 <a:spcPts val="0"/>
               </a:spcBef>
               <a:spcAft>
-                <a:spcPts val="400"/>
+                <a:spcPts val="150"/>
               </a:spcAft>
             </a:pPr>
             <a:r>
-              <a:rPr sz="850" b="0">
-                <a:solidFill>
-                  <a:srgbClr val="546E7A"/>
+              <a:rPr sz="720" b="0">
+                <a:solidFill>
+                  <a:srgbClr val="55636E"/>
                 </a:solidFill>
                 <a:latin typeface="Calibri"/>
               </a:rPr>
-              <a:t>PDF / scanned page</a:t>
-            </a:r>
-          </a:p>
-        </p:txBody>
-      </p:sp>
-      <p:sp>
-        <p:nvSpPr>
-          <p:cNvPr id="10" name="Rounded Rectangle 9"/>
+              <a:t>(probe)</a:t>
+            </a:r>
+          </a:p>
+        </p:txBody>
+      </p:sp>
+      <p:sp>
+        <p:nvSpPr>
+          <p:cNvPr id="32" name="Rounded Rectangle 31"/>
           <p:cNvSpPr/>
           <p:nvPr/>
         </p:nvSpPr>
         <p:spPr>
           <a:xfrm>
-            <a:off x="4297680" y="548640"/>
-            <a:ext cx="1691640" cy="1335024"/>
+            <a:off x="1621536" y="4718304"/>
+            <a:ext cx="1237488" cy="475488"/>
           </a:xfrm>
           <a:prstGeom prst="roundRect">
             <a:avLst>
-              <a:gd name="adj" fmla="val 6000"/>
+              <a:gd name="adj" fmla="val 12000"/>
             </a:avLst>
           </a:prstGeom>
           <a:solidFill>
-            <a:srgbClr val="FFFFFF"/>
+            <a:srgbClr val="F2F9F3"/>
           </a:solidFill>
-          <a:ln w="13970">
+          <a:ln w="12700">
             <a:solidFill>
-              <a:srgbClr val="B0BEC5"/>
+              <a:srgbClr val="C2CBD2"/>
             </a:solidFill>
           </a:ln>
           <a:effectLst/>
@@ -3582,55 +4979,7 @@
           </a:fontRef>
         </p:style>
         <p:txBody>
-          <a:bodyPr rtlCol="0" anchor="ctr"/>
-          <a:lstStyle/>
-          <a:p>
-            <a:pPr algn="ctr"/>
-          </a:p>
-        </p:txBody>
-      </p:sp>
-      <p:pic>
-        <p:nvPicPr>
-          <p:cNvPr id="11" name="Picture 10" descr="chunk.png"/>
-          <p:cNvPicPr>
-            <a:picLocks noChangeAspect="1"/>
-          </p:cNvPicPr>
-          <p:nvPr/>
-        </p:nvPicPr>
-        <p:blipFill>
-          <a:blip r:embed="rId3"/>
-          <a:stretch>
-            <a:fillRect/>
-          </a:stretch>
-        </p:blipFill>
-        <p:spPr>
-          <a:xfrm>
-            <a:off x="4887468" y="694944"/>
-            <a:ext cx="512064" cy="512064"/>
-          </a:xfrm>
-          <a:prstGeom prst="rect">
-            <a:avLst/>
-          </a:prstGeom>
-        </p:spPr>
-      </p:pic>
-      <p:sp>
-        <p:nvSpPr>
-          <p:cNvPr id="12" name="TextBox 11"/>
-          <p:cNvSpPr txBox="1"/>
-          <p:nvPr/>
-        </p:nvSpPr>
-        <p:spPr>
-          <a:xfrm>
-            <a:off x="4297680" y="1426464"/>
-            <a:ext cx="1691640" cy="420624"/>
-          </a:xfrm>
-          <a:prstGeom prst="rect">
-            <a:avLst/>
-          </a:prstGeom>
-          <a:noFill/>
-        </p:spPr>
-        <p:txBody>
-          <a:bodyPr wrap="square" anchor="t" lIns="45720" rIns="45720" tIns="36576" bIns="36576">
+          <a:bodyPr rtlCol="0" anchor="ctr" wrap="square" lIns="36576" rIns="36576" tIns="13716" bIns="13716">
             <a:noAutofit/>
           </a:bodyPr>
           <a:lstStyle/>
@@ -3644,13 +4993,13 @@
               </a:spcAft>
             </a:pPr>
             <a:r>
-              <a:rPr sz="1100" b="1">
-                <a:solidFill>
-                  <a:srgbClr val="1F3247"/>
+              <a:rPr sz="780" b="1">
+                <a:solidFill>
+                  <a:srgbClr val="2E7D32"/>
                 </a:solidFill>
                 <a:latin typeface="Calibri"/>
               </a:rPr>
-              <a:t>Chunker</a:t>
+              <a:t>✓ retriever-avg</a:t>
             </a:r>
           </a:p>
           <a:p>
@@ -3659,43 +5008,43 @@
                 <a:spcPts val="0"/>
               </a:spcBef>
               <a:spcAft>
-                <a:spcPts val="400"/>
+                <a:spcPts val="150"/>
               </a:spcAft>
             </a:pPr>
             <a:r>
-              <a:rPr sz="850" b="0">
-                <a:solidFill>
-                  <a:srgbClr val="546E7A"/>
+              <a:rPr sz="720" b="0">
+                <a:solidFill>
+                  <a:srgbClr val="55636E"/>
                 </a:solidFill>
                 <a:latin typeface="Calibri"/>
               </a:rPr>
-              <a:t>md-header · native · fixed</a:t>
-            </a:r>
-          </a:p>
-        </p:txBody>
-      </p:sp>
-      <p:sp>
-        <p:nvSpPr>
-          <p:cNvPr id="13" name="Rounded Rectangle 12"/>
+              <a:t>×3</a:t>
+            </a:r>
+          </a:p>
+        </p:txBody>
+      </p:sp>
+      <p:sp>
+        <p:nvSpPr>
+          <p:cNvPr id="33" name="Rounded Rectangle 32"/>
           <p:cNvSpPr/>
           <p:nvPr/>
         </p:nvSpPr>
         <p:spPr>
           <a:xfrm>
-            <a:off x="8412480" y="548640"/>
-            <a:ext cx="1691640" cy="1335024"/>
+            <a:off x="2932176" y="4718304"/>
+            <a:ext cx="1237488" cy="475488"/>
           </a:xfrm>
           <a:prstGeom prst="roundRect">
             <a:avLst>
-              <a:gd name="adj" fmla="val 6000"/>
+              <a:gd name="adj" fmla="val 12000"/>
             </a:avLst>
           </a:prstGeom>
           <a:solidFill>
-            <a:srgbClr val="FFFFFF"/>
+            <a:srgbClr val="F2F9F3"/>
           </a:solidFill>
-          <a:ln w="13970">
+          <a:ln w="12700">
             <a:solidFill>
-              <a:srgbClr val="B0BEC5"/>
+              <a:srgbClr val="C2CBD2"/>
             </a:solidFill>
           </a:ln>
           <a:effectLst/>
@@ -3715,55 +5064,7 @@
           </a:fontRef>
         </p:style>
         <p:txBody>
-          <a:bodyPr rtlCol="0" anchor="ctr"/>
-          <a:lstStyle/>
-          <a:p>
-            <a:pPr algn="ctr"/>
-          </a:p>
-        </p:txBody>
-      </p:sp>
-      <p:pic>
-        <p:nvPicPr>
-          <p:cNvPr id="14" name="Picture 13" descr="answer.png"/>
-          <p:cNvPicPr>
-            <a:picLocks noChangeAspect="1"/>
-          </p:cNvPicPr>
-          <p:nvPr/>
-        </p:nvPicPr>
-        <p:blipFill>
-          <a:blip r:embed="rId4"/>
-          <a:stretch>
-            <a:fillRect/>
-          </a:stretch>
-        </p:blipFill>
-        <p:spPr>
-          <a:xfrm>
-            <a:off x="9002268" y="694944"/>
-            <a:ext cx="512064" cy="512064"/>
-          </a:xfrm>
-          <a:prstGeom prst="rect">
-            <a:avLst/>
-          </a:prstGeom>
-        </p:spPr>
-      </p:pic>
-      <p:sp>
-        <p:nvSpPr>
-          <p:cNvPr id="15" name="TextBox 14"/>
-          <p:cNvSpPr txBox="1"/>
-          <p:nvPr/>
-        </p:nvSpPr>
-        <p:spPr>
-          <a:xfrm>
-            <a:off x="8412480" y="1426464"/>
-            <a:ext cx="1691640" cy="420624"/>
-          </a:xfrm>
-          <a:prstGeom prst="rect">
-            <a:avLst/>
-          </a:prstGeom>
-          <a:noFill/>
-        </p:spPr>
-        <p:txBody>
-          <a:bodyPr wrap="square" anchor="t" lIns="45720" rIns="45720" tIns="36576" bIns="36576">
+          <a:bodyPr rtlCol="0" anchor="ctr" wrap="square" lIns="36576" rIns="36576" tIns="13716" bIns="13716">
             <a:noAutofit/>
           </a:bodyPr>
           <a:lstStyle/>
@@ -3777,13 +5078,13 @@
               </a:spcAft>
             </a:pPr>
             <a:r>
-              <a:rPr sz="1100" b="1">
-                <a:solidFill>
-                  <a:srgbClr val="1F3247"/>
+              <a:rPr sz="780" b="1">
+                <a:solidFill>
+                  <a:srgbClr val="2E7D32"/>
                 </a:solidFill>
                 <a:latin typeface="Calibri"/>
               </a:rPr>
-              <a:t>RAG answer</a:t>
+              <a:t>✓ format-</a:t>
             </a:r>
           </a:p>
           <a:p>
@@ -3792,44 +5093,42 @@
                 <a:spcPts val="0"/>
               </a:spcBef>
               <a:spcAft>
-                <a:spcPts val="400"/>
+                <a:spcPts val="150"/>
               </a:spcAft>
             </a:pPr>
             <a:r>
-              <a:rPr sz="850" b="0">
-                <a:solidFill>
-                  <a:srgbClr val="546E7A"/>
+              <a:rPr sz="720" b="0">
+                <a:solidFill>
+                  <a:srgbClr val="55636E"/>
                 </a:solidFill>
                 <a:latin typeface="Calibri"/>
               </a:rPr>
-              <a:t>grounded generation</a:t>
-            </a:r>
-          </a:p>
-        </p:txBody>
-      </p:sp>
-      <p:sp>
-        <p:nvSpPr>
-          <p:cNvPr id="16" name="Rounded Rectangle 15"/>
+              <a:t>invariant</a:t>
+            </a:r>
+          </a:p>
+        </p:txBody>
+      </p:sp>
+      <p:sp>
+        <p:nvSpPr>
+          <p:cNvPr id="34" name="Rounded Rectangle 33"/>
           <p:cNvSpPr/>
           <p:nvPr/>
         </p:nvSpPr>
         <p:spPr>
           <a:xfrm>
-            <a:off x="2240280" y="548640"/>
-            <a:ext cx="1691640" cy="1335024"/>
+            <a:off x="493776" y="5431536"/>
+            <a:ext cx="3493008" cy="310896"/>
           </a:xfrm>
           <a:prstGeom prst="roundRect">
             <a:avLst>
-              <a:gd name="adj" fmla="val 6000"/>
+              <a:gd name="adj" fmla="val 12000"/>
             </a:avLst>
           </a:prstGeom>
           <a:solidFill>
-            <a:srgbClr val="FFFFFF"/>
+            <a:srgbClr val="E6F3E9"/>
           </a:solidFill>
-          <a:ln w="13970">
-            <a:solidFill>
-              <a:srgbClr val="B0BEC5"/>
-            </a:solidFill>
+          <a:ln>
+            <a:noFill/>
           </a:ln>
           <a:effectLst/>
         </p:spPr>
@@ -3848,31 +5147,7 @@
           </a:fontRef>
         </p:style>
         <p:txBody>
-          <a:bodyPr rtlCol="0" anchor="ctr"/>
-          <a:lstStyle/>
-          <a:p>
-            <a:pPr algn="ctr"/>
-          </a:p>
-        </p:txBody>
-      </p:sp>
-      <p:sp>
-        <p:nvSpPr>
-          <p:cNvPr id="17" name="TextBox 16"/>
-          <p:cNvSpPr txBox="1"/>
-          <p:nvPr/>
-        </p:nvSpPr>
-        <p:spPr>
-          <a:xfrm>
-            <a:off x="2240280" y="594360"/>
-            <a:ext cx="1691640" cy="201168"/>
-          </a:xfrm>
-          <a:prstGeom prst="rect">
-            <a:avLst/>
-          </a:prstGeom>
-          <a:noFill/>
-        </p:spPr>
-        <p:txBody>
-          <a:bodyPr wrap="square" anchor="ctr" lIns="18288" rIns="18288" tIns="18288" bIns="18288">
+          <a:bodyPr rtlCol="0" anchor="ctr" wrap="square" lIns="36576" rIns="36576" tIns="13716" bIns="13716">
             <a:noAutofit/>
           </a:bodyPr>
           <a:lstStyle/>
@@ -3882,55 +5157,31 @@
                 <a:spcPts val="0"/>
               </a:spcBef>
               <a:spcAft>
-                <a:spcPts val="400"/>
+                <a:spcPts val="150"/>
               </a:spcAft>
             </a:pPr>
             <a:r>
-              <a:rPr sz="1000" b="1">
-                <a:solidFill>
-                  <a:srgbClr val="1F3247"/>
+              <a:rPr sz="830" b="1">
+                <a:solidFill>
+                  <a:srgbClr val="2E7D32"/>
                 </a:solidFill>
                 <a:latin typeface="Calibri"/>
               </a:rPr>
-              <a:t>Parsers</a:t>
-            </a:r>
-          </a:p>
-        </p:txBody>
-      </p:sp>
-      <p:pic>
-        <p:nvPicPr>
-          <p:cNvPr id="18" name="Picture 17" descr="qwen.png"/>
-          <p:cNvPicPr>
-            <a:picLocks noChangeAspect="1"/>
-          </p:cNvPicPr>
-          <p:nvPr/>
-        </p:nvPicPr>
-        <p:blipFill>
-          <a:blip r:embed="rId5"/>
-          <a:stretch>
-            <a:fillRect/>
-          </a:stretch>
-        </p:blipFill>
-        <p:spPr>
-          <a:xfrm>
-            <a:off x="2551816" y="822959"/>
-            <a:ext cx="277611" cy="277611"/>
-          </a:xfrm>
-          <a:prstGeom prst="rect">
-            <a:avLst/>
-          </a:prstGeom>
-        </p:spPr>
-      </p:pic>
-      <p:sp>
-        <p:nvSpPr>
-          <p:cNvPr id="19" name="TextBox 18"/>
+              <a:t>RCPS ranking → pick parser + chunker  (no training)</a:t>
+            </a:r>
+          </a:p>
+        </p:txBody>
+      </p:sp>
+      <p:sp>
+        <p:nvSpPr>
+          <p:cNvPr id="35" name="TextBox 34"/>
           <p:cNvSpPr txBox="1"/>
           <p:nvPr/>
         </p:nvSpPr>
         <p:spPr>
           <a:xfrm>
-            <a:off x="2295144" y="1109715"/>
-            <a:ext cx="790956" cy="133868"/>
+            <a:off x="310896" y="5779007"/>
+            <a:ext cx="3858768" cy="201168"/>
           </a:xfrm>
           <a:prstGeom prst="rect">
             <a:avLst/>
@@ -3938,7 +5189,7 @@
           <a:noFill/>
         </p:spPr>
         <p:txBody>
-          <a:bodyPr wrap="square" anchor="t" lIns="0" rIns="0" tIns="0" bIns="0">
+          <a:bodyPr wrap="square" anchor="ctr" lIns="36576" rIns="36576" tIns="13716" bIns="13716">
             <a:noAutofit/>
           </a:bodyPr>
           <a:lstStyle/>
@@ -3948,587 +5199,17 @@
                 <a:spcPts val="0"/>
               </a:spcBef>
               <a:spcAft>
-                <a:spcPts val="400"/>
+                <a:spcPts val="150"/>
               </a:spcAft>
             </a:pPr>
             <a:r>
-              <a:rPr sz="650" b="0">
-                <a:solidFill>
-                  <a:srgbClr val="546E7A"/>
+              <a:rPr sz="730" b="0">
+                <a:solidFill>
+                  <a:srgbClr val="55636E"/>
                 </a:solidFill>
                 <a:latin typeface="Calibri"/>
               </a:rPr>
-              <a:t>Qwen-VL</a:t>
-            </a:r>
-          </a:p>
-        </p:txBody>
-      </p:sp>
-      <p:pic>
-        <p:nvPicPr>
-          <p:cNvPr id="20" name="Picture 19" descr="mineru.png"/>
-          <p:cNvPicPr>
-            <a:picLocks noChangeAspect="1"/>
-          </p:cNvPicPr>
-          <p:nvPr/>
-        </p:nvPicPr>
-        <p:blipFill>
-          <a:blip r:embed="rId6"/>
-          <a:stretch>
-            <a:fillRect/>
-          </a:stretch>
-        </p:blipFill>
-        <p:spPr>
-          <a:xfrm>
-            <a:off x="3342772" y="822959"/>
-            <a:ext cx="277611" cy="277611"/>
-          </a:xfrm>
-          <a:prstGeom prst="rect">
-            <a:avLst/>
-          </a:prstGeom>
-        </p:spPr>
-      </p:pic>
-      <p:sp>
-        <p:nvSpPr>
-          <p:cNvPr id="21" name="TextBox 20"/>
-          <p:cNvSpPr txBox="1"/>
-          <p:nvPr/>
-        </p:nvSpPr>
-        <p:spPr>
-          <a:xfrm>
-            <a:off x="3086100" y="1109715"/>
-            <a:ext cx="790956" cy="133868"/>
-          </a:xfrm>
-          <a:prstGeom prst="rect">
-            <a:avLst/>
-          </a:prstGeom>
-          <a:noFill/>
-        </p:spPr>
-        <p:txBody>
-          <a:bodyPr wrap="square" anchor="t" lIns="0" rIns="0" tIns="0" bIns="0">
-            <a:noAutofit/>
-          </a:bodyPr>
-          <a:lstStyle/>
-          <a:p>
-            <a:pPr algn="ctr">
-              <a:spcBef>
-                <a:spcPts val="0"/>
-              </a:spcBef>
-              <a:spcAft>
-                <a:spcPts val="400"/>
-              </a:spcAft>
-            </a:pPr>
-            <a:r>
-              <a:rPr sz="650" b="0">
-                <a:solidFill>
-                  <a:srgbClr val="546E7A"/>
-                </a:solidFill>
-                <a:latin typeface="Calibri"/>
-              </a:rPr>
-              <a:t>MinerU</a:t>
-            </a:r>
-          </a:p>
-        </p:txBody>
-      </p:sp>
-      <p:pic>
-        <p:nvPicPr>
-          <p:cNvPr id="22" name="Picture 21" descr="paddle.png"/>
-          <p:cNvPicPr>
-            <a:picLocks noChangeAspect="1"/>
-          </p:cNvPicPr>
-          <p:nvPr/>
-        </p:nvPicPr>
-        <p:blipFill>
-          <a:blip r:embed="rId7"/>
-          <a:stretch>
-            <a:fillRect/>
-          </a:stretch>
-        </p:blipFill>
-        <p:spPr>
-          <a:xfrm>
-            <a:off x="2551816" y="1243584"/>
-            <a:ext cx="277611" cy="277611"/>
-          </a:xfrm>
-          <a:prstGeom prst="rect">
-            <a:avLst/>
-          </a:prstGeom>
-        </p:spPr>
-      </p:pic>
-      <p:sp>
-        <p:nvSpPr>
-          <p:cNvPr id="23" name="TextBox 22"/>
-          <p:cNvSpPr txBox="1"/>
-          <p:nvPr/>
-        </p:nvSpPr>
-        <p:spPr>
-          <a:xfrm>
-            <a:off x="2295144" y="1530339"/>
-            <a:ext cx="790956" cy="133868"/>
-          </a:xfrm>
-          <a:prstGeom prst="rect">
-            <a:avLst/>
-          </a:prstGeom>
-          <a:noFill/>
-        </p:spPr>
-        <p:txBody>
-          <a:bodyPr wrap="square" anchor="t" lIns="0" rIns="0" tIns="0" bIns="0">
-            <a:noAutofit/>
-          </a:bodyPr>
-          <a:lstStyle/>
-          <a:p>
-            <a:pPr algn="ctr">
-              <a:spcBef>
-                <a:spcPts val="0"/>
-              </a:spcBef>
-              <a:spcAft>
-                <a:spcPts val="400"/>
-              </a:spcAft>
-            </a:pPr>
-            <a:r>
-              <a:rPr sz="650" b="0">
-                <a:solidFill>
-                  <a:srgbClr val="546E7A"/>
-                </a:solidFill>
-                <a:latin typeface="Calibri"/>
-              </a:rPr>
-              <a:t>PaddleOCR</a:t>
-            </a:r>
-          </a:p>
-        </p:txBody>
-      </p:sp>
-      <p:pic>
-        <p:nvPicPr>
-          <p:cNvPr id="24" name="Picture 23" descr="marker.png"/>
-          <p:cNvPicPr>
-            <a:picLocks noChangeAspect="1"/>
-          </p:cNvPicPr>
-          <p:nvPr/>
-        </p:nvPicPr>
-        <p:blipFill>
-          <a:blip r:embed="rId8"/>
-          <a:stretch>
-            <a:fillRect/>
-          </a:stretch>
-        </p:blipFill>
-        <p:spPr>
-          <a:xfrm>
-            <a:off x="3342772" y="1243584"/>
-            <a:ext cx="277611" cy="277611"/>
-          </a:xfrm>
-          <a:prstGeom prst="rect">
-            <a:avLst/>
-          </a:prstGeom>
-        </p:spPr>
-      </p:pic>
-      <p:sp>
-        <p:nvSpPr>
-          <p:cNvPr id="25" name="TextBox 24"/>
-          <p:cNvSpPr txBox="1"/>
-          <p:nvPr/>
-        </p:nvSpPr>
-        <p:spPr>
-          <a:xfrm>
-            <a:off x="3086100" y="1530339"/>
-            <a:ext cx="790956" cy="133868"/>
-          </a:xfrm>
-          <a:prstGeom prst="rect">
-            <a:avLst/>
-          </a:prstGeom>
-          <a:noFill/>
-        </p:spPr>
-        <p:txBody>
-          <a:bodyPr wrap="square" anchor="t" lIns="0" rIns="0" tIns="0" bIns="0">
-            <a:noAutofit/>
-          </a:bodyPr>
-          <a:lstStyle/>
-          <a:p>
-            <a:pPr algn="ctr">
-              <a:spcBef>
-                <a:spcPts val="0"/>
-              </a:spcBef>
-              <a:spcAft>
-                <a:spcPts val="400"/>
-              </a:spcAft>
-            </a:pPr>
-            <a:r>
-              <a:rPr sz="650" b="0">
-                <a:solidFill>
-                  <a:srgbClr val="546E7A"/>
-                </a:solidFill>
-                <a:latin typeface="Calibri"/>
-              </a:rPr>
-              <a:t>Marker</a:t>
-            </a:r>
-          </a:p>
-        </p:txBody>
-      </p:sp>
-      <p:sp>
-        <p:nvSpPr>
-          <p:cNvPr id="26" name="TextBox 25"/>
-          <p:cNvSpPr txBox="1"/>
-          <p:nvPr/>
-        </p:nvSpPr>
-        <p:spPr>
-          <a:xfrm>
-            <a:off x="2240280" y="1600200"/>
-            <a:ext cx="1691640" cy="219456"/>
-          </a:xfrm>
-          <a:prstGeom prst="rect">
-            <a:avLst/>
-          </a:prstGeom>
-          <a:noFill/>
-        </p:spPr>
-        <p:txBody>
-          <a:bodyPr wrap="square" anchor="ctr" lIns="18288" rIns="18288" tIns="18288" bIns="18288">
-            <a:noAutofit/>
-          </a:bodyPr>
-          <a:lstStyle/>
-          <a:p>
-            <a:pPr algn="ctr">
-              <a:spcBef>
-                <a:spcPts val="0"/>
-              </a:spcBef>
-              <a:spcAft>
-                <a:spcPts val="400"/>
-              </a:spcAft>
-            </a:pPr>
-            <a:r>
-              <a:rPr sz="900" b="1">
-                <a:solidFill>
-                  <a:srgbClr val="00695C"/>
-                </a:solidFill>
-                <a:latin typeface="Calibri"/>
-              </a:rPr>
-              <a:t>fine-tune → Prod (2B)</a:t>
-            </a:r>
-          </a:p>
-        </p:txBody>
-      </p:sp>
-      <p:sp>
-        <p:nvSpPr>
-          <p:cNvPr id="27" name="Rounded Rectangle 26"/>
-          <p:cNvSpPr/>
-          <p:nvPr/>
-        </p:nvSpPr>
-        <p:spPr>
-          <a:xfrm>
-            <a:off x="6355080" y="548640"/>
-            <a:ext cx="1691640" cy="1335024"/>
-          </a:xfrm>
-          <a:prstGeom prst="roundRect">
-            <a:avLst>
-              <a:gd name="adj" fmla="val 6000"/>
-            </a:avLst>
-          </a:prstGeom>
-          <a:solidFill>
-            <a:srgbClr val="FFFFFF"/>
-          </a:solidFill>
-          <a:ln w="13970">
-            <a:solidFill>
-              <a:srgbClr val="B0BEC5"/>
-            </a:solidFill>
-          </a:ln>
-          <a:effectLst/>
-        </p:spPr>
-        <p:style>
-          <a:lnRef idx="1">
-            <a:schemeClr val="accent1"/>
-          </a:lnRef>
-          <a:fillRef idx="3">
-            <a:schemeClr val="accent1"/>
-          </a:fillRef>
-          <a:effectRef idx="2">
-            <a:schemeClr val="accent1"/>
-          </a:effectRef>
-          <a:fontRef idx="minor">
-            <a:schemeClr val="lt1"/>
-          </a:fontRef>
-        </p:style>
-        <p:txBody>
-          <a:bodyPr rtlCol="0" anchor="ctr"/>
-          <a:lstStyle/>
-          <a:p>
-            <a:pPr algn="ctr"/>
-          </a:p>
-        </p:txBody>
-      </p:sp>
-      <p:sp>
-        <p:nvSpPr>
-          <p:cNvPr id="28" name="TextBox 27"/>
-          <p:cNvSpPr txBox="1"/>
-          <p:nvPr/>
-        </p:nvSpPr>
-        <p:spPr>
-          <a:xfrm>
-            <a:off x="6355080" y="594360"/>
-            <a:ext cx="1691640" cy="201168"/>
-          </a:xfrm>
-          <a:prstGeom prst="rect">
-            <a:avLst/>
-          </a:prstGeom>
-          <a:noFill/>
-        </p:spPr>
-        <p:txBody>
-          <a:bodyPr wrap="square" anchor="ctr" lIns="18288" rIns="18288" tIns="18288" bIns="18288">
-            <a:noAutofit/>
-          </a:bodyPr>
-          <a:lstStyle/>
-          <a:p>
-            <a:pPr algn="ctr">
-              <a:spcBef>
-                <a:spcPts val="0"/>
-              </a:spcBef>
-              <a:spcAft>
-                <a:spcPts val="400"/>
-              </a:spcAft>
-            </a:pPr>
-            <a:r>
-              <a:rPr sz="1000" b="1">
-                <a:solidFill>
-                  <a:srgbClr val="1F3247"/>
-                </a:solidFill>
-                <a:latin typeface="Calibri"/>
-              </a:rPr>
-              <a:t>Retrievers ×3</a:t>
-            </a:r>
-          </a:p>
-        </p:txBody>
-      </p:sp>
-      <p:pic>
-        <p:nvPicPr>
-          <p:cNvPr id="29" name="Picture 28" descr="bge.png"/>
-          <p:cNvPicPr>
-            <a:picLocks noChangeAspect="1"/>
-          </p:cNvPicPr>
-          <p:nvPr/>
-        </p:nvPicPr>
-        <p:blipFill>
-          <a:blip r:embed="rId9"/>
-          <a:stretch>
-            <a:fillRect/>
-          </a:stretch>
-        </p:blipFill>
-        <p:spPr>
-          <a:xfrm>
-            <a:off x="6480413" y="859536"/>
-            <a:ext cx="374172" cy="374172"/>
-          </a:xfrm>
-          <a:prstGeom prst="rect">
-            <a:avLst/>
-          </a:prstGeom>
-        </p:spPr>
-      </p:pic>
-      <p:sp>
-        <p:nvSpPr>
-          <p:cNvPr id="30" name="TextBox 29"/>
-          <p:cNvSpPr txBox="1"/>
-          <p:nvPr/>
-        </p:nvSpPr>
-        <p:spPr>
-          <a:xfrm>
-            <a:off x="6400800" y="1242852"/>
-            <a:ext cx="533400" cy="183611"/>
-          </a:xfrm>
-          <a:prstGeom prst="rect">
-            <a:avLst/>
-          </a:prstGeom>
-          <a:noFill/>
-        </p:spPr>
-        <p:txBody>
-          <a:bodyPr wrap="square" anchor="t" lIns="0" rIns="0" tIns="0" bIns="0">
-            <a:noAutofit/>
-          </a:bodyPr>
-          <a:lstStyle/>
-          <a:p>
-            <a:pPr algn="ctr">
-              <a:spcBef>
-                <a:spcPts val="0"/>
-              </a:spcBef>
-              <a:spcAft>
-                <a:spcPts val="400"/>
-              </a:spcAft>
-            </a:pPr>
-            <a:r>
-              <a:rPr sz="650" b="0">
-                <a:solidFill>
-                  <a:srgbClr val="546E7A"/>
-                </a:solidFill>
-                <a:latin typeface="Calibri"/>
-              </a:rPr>
-              <a:t>BGE-M3</a:t>
-            </a:r>
-          </a:p>
-        </p:txBody>
-      </p:sp>
-      <p:pic>
-        <p:nvPicPr>
-          <p:cNvPr id="31" name="Picture 30" descr="me5.png"/>
-          <p:cNvPicPr>
-            <a:picLocks noChangeAspect="1"/>
-          </p:cNvPicPr>
-          <p:nvPr/>
-        </p:nvPicPr>
-        <p:blipFill>
-          <a:blip r:embed="rId10"/>
-          <a:stretch>
-            <a:fillRect/>
-          </a:stretch>
-        </p:blipFill>
-        <p:spPr>
-          <a:xfrm>
-            <a:off x="7013813" y="859536"/>
-            <a:ext cx="374172" cy="374172"/>
-          </a:xfrm>
-          <a:prstGeom prst="rect">
-            <a:avLst/>
-          </a:prstGeom>
-        </p:spPr>
-      </p:pic>
-      <p:sp>
-        <p:nvSpPr>
-          <p:cNvPr id="32" name="TextBox 31"/>
-          <p:cNvSpPr txBox="1"/>
-          <p:nvPr/>
-        </p:nvSpPr>
-        <p:spPr>
-          <a:xfrm>
-            <a:off x="6934200" y="1242852"/>
-            <a:ext cx="533400" cy="183611"/>
-          </a:xfrm>
-          <a:prstGeom prst="rect">
-            <a:avLst/>
-          </a:prstGeom>
-          <a:noFill/>
-        </p:spPr>
-        <p:txBody>
-          <a:bodyPr wrap="square" anchor="t" lIns="0" rIns="0" tIns="0" bIns="0">
-            <a:noAutofit/>
-          </a:bodyPr>
-          <a:lstStyle/>
-          <a:p>
-            <a:pPr algn="ctr">
-              <a:spcBef>
-                <a:spcPts val="0"/>
-              </a:spcBef>
-              <a:spcAft>
-                <a:spcPts val="400"/>
-              </a:spcAft>
-            </a:pPr>
-            <a:r>
-              <a:rPr sz="650" b="0">
-                <a:solidFill>
-                  <a:srgbClr val="546E7A"/>
-                </a:solidFill>
-                <a:latin typeface="Calibri"/>
-              </a:rPr>
-              <a:t>mE5</a:t>
-            </a:r>
-          </a:p>
-        </p:txBody>
-      </p:sp>
-      <p:pic>
-        <p:nvPicPr>
-          <p:cNvPr id="33" name="Picture 32" descr="qwen.png"/>
-          <p:cNvPicPr>
-            <a:picLocks noChangeAspect="1"/>
-          </p:cNvPicPr>
-          <p:nvPr/>
-        </p:nvPicPr>
-        <p:blipFill>
-          <a:blip r:embed="rId5"/>
-          <a:stretch>
-            <a:fillRect/>
-          </a:stretch>
-        </p:blipFill>
-        <p:spPr>
-          <a:xfrm>
-            <a:off x="7547213" y="859536"/>
-            <a:ext cx="374172" cy="374172"/>
-          </a:xfrm>
-          <a:prstGeom prst="rect">
-            <a:avLst/>
-          </a:prstGeom>
-        </p:spPr>
-      </p:pic>
-      <p:sp>
-        <p:nvSpPr>
-          <p:cNvPr id="34" name="TextBox 33"/>
-          <p:cNvSpPr txBox="1"/>
-          <p:nvPr/>
-        </p:nvSpPr>
-        <p:spPr>
-          <a:xfrm>
-            <a:off x="7467599" y="1242852"/>
-            <a:ext cx="533400" cy="183611"/>
-          </a:xfrm>
-          <a:prstGeom prst="rect">
-            <a:avLst/>
-          </a:prstGeom>
-          <a:noFill/>
-        </p:spPr>
-        <p:txBody>
-          <a:bodyPr wrap="square" anchor="t" lIns="0" rIns="0" tIns="0" bIns="0">
-            <a:noAutofit/>
-          </a:bodyPr>
-          <a:lstStyle/>
-          <a:p>
-            <a:pPr algn="ctr">
-              <a:spcBef>
-                <a:spcPts val="0"/>
-              </a:spcBef>
-              <a:spcAft>
-                <a:spcPts val="400"/>
-              </a:spcAft>
-            </a:pPr>
-            <a:r>
-              <a:rPr sz="650" b="0">
-                <a:solidFill>
-                  <a:srgbClr val="546E7A"/>
-                </a:solidFill>
-                <a:latin typeface="Calibri"/>
-              </a:rPr>
-              <a:t>Qwen3-Emb</a:t>
-            </a:r>
-          </a:p>
-        </p:txBody>
-      </p:sp>
-      <p:sp>
-        <p:nvSpPr>
-          <p:cNvPr id="35" name="TextBox 34"/>
-          <p:cNvSpPr txBox="1"/>
-          <p:nvPr/>
-        </p:nvSpPr>
-        <p:spPr>
-          <a:xfrm>
-            <a:off x="6355080" y="1609344"/>
-            <a:ext cx="1691640" cy="237744"/>
-          </a:xfrm>
-          <a:prstGeom prst="rect">
-            <a:avLst/>
-          </a:prstGeom>
-          <a:noFill/>
-        </p:spPr>
-        <p:txBody>
-          <a:bodyPr wrap="square" anchor="ctr" lIns="18288" rIns="18288" tIns="18288" bIns="18288">
-            <a:noAutofit/>
-          </a:bodyPr>
-          <a:lstStyle/>
-          <a:p>
-            <a:pPr algn="ctr">
-              <a:spcBef>
-                <a:spcPts val="0"/>
-              </a:spcBef>
-              <a:spcAft>
-                <a:spcPts val="400"/>
-              </a:spcAft>
-            </a:pPr>
-            <a:r>
-              <a:rPr sz="850" b="0">
-                <a:solidFill>
-                  <a:srgbClr val="546E7A"/>
-                </a:solidFill>
-                <a:latin typeface="Calibri"/>
-              </a:rPr>
-              <a:t>k ∈ {1, 5, 10}</a:t>
+              <a:t>retriever-avg flips the top parser a single embedder gets wrong (τ = 0.87)</a:t>
             </a:r>
           </a:p>
         </p:txBody>
@@ -4541,15 +5222,15 @@
         </p:nvCxnSpPr>
         <p:spPr>
           <a:xfrm>
-            <a:off x="1892808" y="1216152"/>
-            <a:ext cx="329184" cy="0"/>
+            <a:off x="2240279" y="4279392"/>
+            <a:ext cx="0" cy="91440"/>
           </a:xfrm>
           <a:prstGeom prst="line">
             <a:avLst/>
           </a:prstGeom>
-          <a:ln w="20320">
+          <a:ln w="19050">
             <a:solidFill>
-              <a:srgbClr val="78909C"/>
+              <a:srgbClr val="2E7D32"/>
             </a:solidFill>
             <a:tailEnd type="triangle" w="med" len="med"/>
           </a:ln>
@@ -4577,15 +5258,670 @@
         </p:nvCxnSpPr>
         <p:spPr>
           <a:xfrm>
-            <a:off x="3950208" y="1216152"/>
-            <a:ext cx="329184" cy="0"/>
+            <a:off x="2240279" y="4626864"/>
+            <a:ext cx="0" cy="91440"/>
           </a:xfrm>
           <a:prstGeom prst="line">
             <a:avLst/>
           </a:prstGeom>
-          <a:ln w="20320">
+          <a:ln w="19050">
             <a:solidFill>
-              <a:srgbClr val="78909C"/>
+              <a:srgbClr val="2E7D32"/>
+            </a:solidFill>
+            <a:tailEnd type="triangle" w="med" len="med"/>
+          </a:ln>
+        </p:spPr>
+        <p:style>
+          <a:lnRef idx="2">
+            <a:schemeClr val="accent1"/>
+          </a:lnRef>
+          <a:fillRef idx="0">
+            <a:schemeClr val="accent1"/>
+          </a:fillRef>
+          <a:effectRef idx="1">
+            <a:schemeClr val="accent1"/>
+          </a:effectRef>
+          <a:fontRef idx="minor">
+            <a:schemeClr val="tx1"/>
+          </a:fontRef>
+        </p:style>
+      </p:cxnSp>
+      <p:sp>
+        <p:nvSpPr>
+          <p:cNvPr id="38" name="Rounded Rectangle 37"/>
+          <p:cNvSpPr/>
+          <p:nvPr/>
+        </p:nvSpPr>
+        <p:spPr>
+          <a:xfrm>
+            <a:off x="4700016" y="4059935"/>
+            <a:ext cx="813815" cy="512064"/>
+          </a:xfrm>
+          <a:prstGeom prst="roundRect">
+            <a:avLst>
+              <a:gd name="adj" fmla="val 12000"/>
+            </a:avLst>
+          </a:prstGeom>
+          <a:solidFill>
+            <a:srgbClr val="FFFFFF"/>
+          </a:solidFill>
+          <a:ln w="12700">
+            <a:solidFill>
+              <a:srgbClr val="C2CBD2"/>
+            </a:solidFill>
+          </a:ln>
+          <a:effectLst/>
+        </p:spPr>
+        <p:style>
+          <a:lnRef idx="1">
+            <a:schemeClr val="accent1"/>
+          </a:lnRef>
+          <a:fillRef idx="3">
+            <a:schemeClr val="accent1"/>
+          </a:fillRef>
+          <a:effectRef idx="2">
+            <a:schemeClr val="accent1"/>
+          </a:effectRef>
+          <a:fontRef idx="minor">
+            <a:schemeClr val="lt1"/>
+          </a:fontRef>
+        </p:style>
+        <p:txBody>
+          <a:bodyPr rtlCol="0" anchor="ctr" wrap="square" lIns="36576" rIns="36576" tIns="13716" bIns="13716">
+            <a:noAutofit/>
+          </a:bodyPr>
+          <a:lstStyle/>
+          <a:p>
+            <a:pPr algn="ctr">
+              <a:spcBef>
+                <a:spcPts val="0"/>
+              </a:spcBef>
+              <a:spcAft>
+                <a:spcPts val="100"/>
+              </a:spcAft>
+            </a:pPr>
+            <a:r>
+              <a:rPr sz="780" b="1">
+                <a:solidFill>
+                  <a:srgbClr val="1F3247"/>
+                </a:solidFill>
+                <a:latin typeface="Calibri"/>
+              </a:rPr>
+              <a:t>Prod</a:t>
+            </a:r>
+          </a:p>
+          <a:p>
+            <a:pPr algn="ctr">
+              <a:spcBef>
+                <a:spcPts val="0"/>
+              </a:spcBef>
+              <a:spcAft>
+                <a:spcPts val="150"/>
+              </a:spcAft>
+            </a:pPr>
+            <a:r>
+              <a:rPr sz="720" b="0">
+                <a:solidFill>
+                  <a:srgbClr val="55636E"/>
+                </a:solidFill>
+                <a:latin typeface="Calibri"/>
+              </a:rPr>
+              <a:t>parser</a:t>
+            </a:r>
+          </a:p>
+        </p:txBody>
+      </p:sp>
+      <p:sp>
+        <p:nvSpPr>
+          <p:cNvPr id="39" name="Rounded Rectangle 38"/>
+          <p:cNvSpPr/>
+          <p:nvPr/>
+        </p:nvSpPr>
+        <p:spPr>
+          <a:xfrm>
+            <a:off x="5715000" y="4059935"/>
+            <a:ext cx="813815" cy="512064"/>
+          </a:xfrm>
+          <a:prstGeom prst="roundRect">
+            <a:avLst>
+              <a:gd name="adj" fmla="val 12000"/>
+            </a:avLst>
+          </a:prstGeom>
+          <a:solidFill>
+            <a:srgbClr val="FDF6EF"/>
+          </a:solidFill>
+          <a:ln w="12700">
+            <a:solidFill>
+              <a:srgbClr val="C2CBD2"/>
+            </a:solidFill>
+          </a:ln>
+          <a:effectLst/>
+        </p:spPr>
+        <p:style>
+          <a:lnRef idx="1">
+            <a:schemeClr val="accent1"/>
+          </a:lnRef>
+          <a:fillRef idx="3">
+            <a:schemeClr val="accent1"/>
+          </a:fillRef>
+          <a:effectRef idx="2">
+            <a:schemeClr val="accent1"/>
+          </a:effectRef>
+          <a:fontRef idx="minor">
+            <a:schemeClr val="lt1"/>
+          </a:fontRef>
+        </p:style>
+        <p:txBody>
+          <a:bodyPr rtlCol="0" anchor="ctr" wrap="square" lIns="36576" rIns="36576" tIns="13716" bIns="13716">
+            <a:noAutofit/>
+          </a:bodyPr>
+          <a:lstStyle/>
+          <a:p>
+            <a:pPr algn="ctr">
+              <a:spcBef>
+                <a:spcPts val="0"/>
+              </a:spcBef>
+              <a:spcAft>
+                <a:spcPts val="100"/>
+              </a:spcAft>
+            </a:pPr>
+            <a:r>
+              <a:rPr sz="780" b="1">
+                <a:solidFill>
+                  <a:srgbClr val="1F3247"/>
+                </a:solidFill>
+                <a:latin typeface="Calibri"/>
+              </a:rPr>
+              <a:t>sample K</a:t>
+            </a:r>
+          </a:p>
+          <a:p>
+            <a:pPr algn="ctr">
+              <a:spcBef>
+                <a:spcPts val="0"/>
+              </a:spcBef>
+              <a:spcAft>
+                <a:spcPts val="150"/>
+              </a:spcAft>
+            </a:pPr>
+            <a:r>
+              <a:rPr sz="720" b="0">
+                <a:solidFill>
+                  <a:srgbClr val="55636E"/>
+                </a:solidFill>
+                <a:latin typeface="Calibri"/>
+              </a:rPr>
+              <a:t>parses</a:t>
+            </a:r>
+          </a:p>
+        </p:txBody>
+      </p:sp>
+      <p:cxnSp>
+        <p:nvCxnSpPr>
+          <p:cNvPr id="40" name="Connector 39"/>
+          <p:cNvCxnSpPr/>
+          <p:nvPr/>
+        </p:nvCxnSpPr>
+        <p:spPr>
+          <a:xfrm>
+            <a:off x="5522976" y="4315968"/>
+            <a:ext cx="201168" cy="0"/>
+          </a:xfrm>
+          <a:prstGeom prst="line">
+            <a:avLst/>
+          </a:prstGeom>
+          <a:ln w="19050">
+            <a:solidFill>
+              <a:srgbClr val="E65100"/>
+            </a:solidFill>
+            <a:tailEnd type="triangle" w="med" len="med"/>
+          </a:ln>
+        </p:spPr>
+        <p:style>
+          <a:lnRef idx="2">
+            <a:schemeClr val="accent1"/>
+          </a:lnRef>
+          <a:fillRef idx="0">
+            <a:schemeClr val="accent1"/>
+          </a:fillRef>
+          <a:effectRef idx="1">
+            <a:schemeClr val="accent1"/>
+          </a:effectRef>
+          <a:fontRef idx="minor">
+            <a:schemeClr val="tx1"/>
+          </a:fontRef>
+        </p:style>
+      </p:cxnSp>
+      <p:sp>
+        <p:nvSpPr>
+          <p:cNvPr id="41" name="Rounded Rectangle 40"/>
+          <p:cNvSpPr/>
+          <p:nvPr/>
+        </p:nvSpPr>
+        <p:spPr>
+          <a:xfrm>
+            <a:off x="6729983" y="4059935"/>
+            <a:ext cx="813815" cy="512064"/>
+          </a:xfrm>
+          <a:prstGeom prst="roundRect">
+            <a:avLst>
+              <a:gd name="adj" fmla="val 12000"/>
+            </a:avLst>
+          </a:prstGeom>
+          <a:solidFill>
+            <a:srgbClr val="FDF6EF"/>
+          </a:solidFill>
+          <a:ln w="12700">
+            <a:solidFill>
+              <a:srgbClr val="C2CBD2"/>
+            </a:solidFill>
+          </a:ln>
+          <a:effectLst/>
+        </p:spPr>
+        <p:style>
+          <a:lnRef idx="1">
+            <a:schemeClr val="accent1"/>
+          </a:lnRef>
+          <a:fillRef idx="3">
+            <a:schemeClr val="accent1"/>
+          </a:fillRef>
+          <a:effectRef idx="2">
+            <a:schemeClr val="accent1"/>
+          </a:effectRef>
+          <a:fontRef idx="minor">
+            <a:schemeClr val="lt1"/>
+          </a:fontRef>
+        </p:style>
+        <p:txBody>
+          <a:bodyPr rtlCol="0" anchor="ctr" wrap="square" lIns="36576" rIns="36576" tIns="13716" bIns="13716">
+            <a:noAutofit/>
+          </a:bodyPr>
+          <a:lstStyle/>
+          <a:p>
+            <a:pPr algn="ctr">
+              <a:spcBef>
+                <a:spcPts val="0"/>
+              </a:spcBef>
+              <a:spcAft>
+                <a:spcPts val="100"/>
+              </a:spcAft>
+            </a:pPr>
+            <a:r>
+              <a:rPr sz="780" b="1">
+                <a:solidFill>
+                  <a:srgbClr val="1F3247"/>
+                </a:solidFill>
+                <a:latin typeface="Calibri"/>
+              </a:rPr>
+              <a:t>rank</a:t>
+            </a:r>
+          </a:p>
+          <a:p>
+            <a:pPr algn="ctr">
+              <a:spcBef>
+                <a:spcPts val="0"/>
+              </a:spcBef>
+              <a:spcAft>
+                <a:spcPts val="150"/>
+              </a:spcAft>
+            </a:pPr>
+            <a:r>
+              <a:rPr sz="720" b="0">
+                <a:solidFill>
+                  <a:srgbClr val="55636E"/>
+                </a:solidFill>
+                <a:latin typeface="Calibri"/>
+              </a:rPr>
+              <a:t>candidates</a:t>
+            </a:r>
+          </a:p>
+        </p:txBody>
+      </p:sp>
+      <p:cxnSp>
+        <p:nvCxnSpPr>
+          <p:cNvPr id="42" name="Connector 41"/>
+          <p:cNvCxnSpPr/>
+          <p:nvPr/>
+        </p:nvCxnSpPr>
+        <p:spPr>
+          <a:xfrm>
+            <a:off x="6537959" y="4315968"/>
+            <a:ext cx="201168" cy="0"/>
+          </a:xfrm>
+          <a:prstGeom prst="line">
+            <a:avLst/>
+          </a:prstGeom>
+          <a:ln w="19050">
+            <a:solidFill>
+              <a:srgbClr val="E65100"/>
+            </a:solidFill>
+            <a:tailEnd type="triangle" w="med" len="med"/>
+          </a:ln>
+        </p:spPr>
+        <p:style>
+          <a:lnRef idx="2">
+            <a:schemeClr val="accent1"/>
+          </a:lnRef>
+          <a:fillRef idx="0">
+            <a:schemeClr val="accent1"/>
+          </a:fillRef>
+          <a:effectRef idx="1">
+            <a:schemeClr val="accent1"/>
+          </a:effectRef>
+          <a:fontRef idx="minor">
+            <a:schemeClr val="tx1"/>
+          </a:fontRef>
+        </p:style>
+      </p:cxnSp>
+      <p:sp>
+        <p:nvSpPr>
+          <p:cNvPr id="43" name="Rounded Rectangle 42"/>
+          <p:cNvSpPr/>
+          <p:nvPr/>
+        </p:nvSpPr>
+        <p:spPr>
+          <a:xfrm>
+            <a:off x="7744967" y="4059935"/>
+            <a:ext cx="813815" cy="512064"/>
+          </a:xfrm>
+          <a:prstGeom prst="roundRect">
+            <a:avLst>
+              <a:gd name="adj" fmla="val 12000"/>
+            </a:avLst>
+          </a:prstGeom>
+          <a:solidFill>
+            <a:srgbClr val="FDF6EF"/>
+          </a:solidFill>
+          <a:ln w="12700">
+            <a:solidFill>
+              <a:srgbClr val="C2CBD2"/>
+            </a:solidFill>
+          </a:ln>
+          <a:effectLst/>
+        </p:spPr>
+        <p:style>
+          <a:lnRef idx="1">
+            <a:schemeClr val="accent1"/>
+          </a:lnRef>
+          <a:fillRef idx="3">
+            <a:schemeClr val="accent1"/>
+          </a:fillRef>
+          <a:effectRef idx="2">
+            <a:schemeClr val="accent1"/>
+          </a:effectRef>
+          <a:fontRef idx="minor">
+            <a:schemeClr val="lt1"/>
+          </a:fontRef>
+        </p:style>
+        <p:txBody>
+          <a:bodyPr rtlCol="0" anchor="ctr" wrap="square" lIns="36576" rIns="36576" tIns="13716" bIns="13716">
+            <a:noAutofit/>
+          </a:bodyPr>
+          <a:lstStyle/>
+          <a:p>
+            <a:pPr algn="ctr">
+              <a:spcBef>
+                <a:spcPts val="0"/>
+              </a:spcBef>
+              <a:spcAft>
+                <a:spcPts val="100"/>
+              </a:spcAft>
+            </a:pPr>
+            <a:r>
+              <a:rPr sz="780" b="1">
+                <a:solidFill>
+                  <a:srgbClr val="1F3247"/>
+                </a:solidFill>
+                <a:latin typeface="Calibri"/>
+              </a:rPr>
+              <a:t>LoRA-toggle</a:t>
+            </a:r>
+          </a:p>
+          <a:p>
+            <a:pPr algn="ctr">
+              <a:spcBef>
+                <a:spcPts val="0"/>
+              </a:spcBef>
+              <a:spcAft>
+                <a:spcPts val="150"/>
+              </a:spcAft>
+            </a:pPr>
+            <a:r>
+              <a:rPr sz="720" b="0">
+                <a:solidFill>
+                  <a:srgbClr val="55636E"/>
+                </a:solidFill>
+                <a:latin typeface="Calibri"/>
+              </a:rPr>
+              <a:t>DPO</a:t>
+            </a:r>
+          </a:p>
+        </p:txBody>
+      </p:sp>
+      <p:cxnSp>
+        <p:nvCxnSpPr>
+          <p:cNvPr id="44" name="Connector 43"/>
+          <p:cNvCxnSpPr/>
+          <p:nvPr/>
+        </p:nvCxnSpPr>
+        <p:spPr>
+          <a:xfrm>
+            <a:off x="7552943" y="4315968"/>
+            <a:ext cx="201168" cy="0"/>
+          </a:xfrm>
+          <a:prstGeom prst="line">
+            <a:avLst/>
+          </a:prstGeom>
+          <a:ln w="19050">
+            <a:solidFill>
+              <a:srgbClr val="E65100"/>
+            </a:solidFill>
+            <a:tailEnd type="triangle" w="med" len="med"/>
+          </a:ln>
+        </p:spPr>
+        <p:style>
+          <a:lnRef idx="2">
+            <a:schemeClr val="accent1"/>
+          </a:lnRef>
+          <a:fillRef idx="0">
+            <a:schemeClr val="accent1"/>
+          </a:fillRef>
+          <a:effectRef idx="1">
+            <a:schemeClr val="accent1"/>
+          </a:effectRef>
+          <a:fontRef idx="minor">
+            <a:schemeClr val="tx1"/>
+          </a:fontRef>
+        </p:style>
+      </p:cxnSp>
+      <p:sp>
+        <p:nvSpPr>
+          <p:cNvPr id="45" name="TextBox 44"/>
+          <p:cNvSpPr txBox="1"/>
+          <p:nvPr/>
+        </p:nvSpPr>
+        <p:spPr>
+          <a:xfrm>
+            <a:off x="4700016" y="4608575"/>
+            <a:ext cx="3858768" cy="365760"/>
+          </a:xfrm>
+          <a:prstGeom prst="rect">
+            <a:avLst/>
+          </a:prstGeom>
+          <a:noFill/>
+        </p:spPr>
+        <p:txBody>
+          <a:bodyPr wrap="square" anchor="t" lIns="36576" rIns="36576" tIns="13716" bIns="13716">
+            <a:noAutofit/>
+          </a:bodyPr>
+          <a:lstStyle/>
+          <a:p>
+            <a:pPr algn="ctr">
+              <a:spcBef>
+                <a:spcPts val="0"/>
+              </a:spcBef>
+              <a:spcAft>
+                <a:spcPts val="150"/>
+              </a:spcAft>
+            </a:pPr>
+            <a:r>
+              <a:rPr sz="780" b="1">
+                <a:solidFill>
+                  <a:srgbClr val="1F3247"/>
+                </a:solidFill>
+                <a:latin typeface="Calibri"/>
+              </a:rPr>
+              <a:t>rank by: </a:t>
+            </a:r>
+            <a:r>
+              <a:rPr sz="800" b="1">
+                <a:solidFill>
+                  <a:srgbClr val="2E7D32"/>
+                </a:solidFill>
+                <a:latin typeface="Calibri"/>
+              </a:rPr>
+              <a:t>edit-dist → GT</a:t>
+            </a:r>
+            <a:r>
+              <a:rPr sz="780" b="1">
+                <a:solidFill>
+                  <a:srgbClr val="2E7D32"/>
+                </a:solidFill>
+                <a:latin typeface="Calibri"/>
+              </a:rPr>
+              <a:t>  (RADP-Distill ✓)</a:t>
+            </a:r>
+          </a:p>
+          <a:p>
+            <a:pPr algn="ctr">
+              <a:spcBef>
+                <a:spcPts val="0"/>
+              </a:spcBef>
+              <a:spcAft>
+                <a:spcPts val="100"/>
+              </a:spcAft>
+            </a:pPr>
+            <a:r>
+              <a:rPr sz="780" b="0">
+                <a:solidFill>
+                  <a:srgbClr val="55636E"/>
+                </a:solidFill>
+                <a:latin typeface="Calibri"/>
+              </a:rPr>
+              <a:t>vs  page-RCPS  (RADP-DPO) — same result</a:t>
+            </a:r>
+          </a:p>
+        </p:txBody>
+      </p:sp>
+      <p:sp>
+        <p:nvSpPr>
+          <p:cNvPr id="46" name="Rounded Rectangle 45"/>
+          <p:cNvSpPr/>
+          <p:nvPr/>
+        </p:nvSpPr>
+        <p:spPr>
+          <a:xfrm>
+            <a:off x="4700016" y="5614416"/>
+            <a:ext cx="3858768" cy="365760"/>
+          </a:xfrm>
+          <a:prstGeom prst="roundRect">
+            <a:avLst>
+              <a:gd name="adj" fmla="val 16000"/>
+            </a:avLst>
+          </a:prstGeom>
+          <a:solidFill>
+            <a:srgbClr val="FCEEE0"/>
+          </a:solidFill>
+          <a:ln>
+            <a:noFill/>
+          </a:ln>
+          <a:effectLst/>
+        </p:spPr>
+        <p:style>
+          <a:lnRef idx="1">
+            <a:schemeClr val="accent1"/>
+          </a:lnRef>
+          <a:fillRef idx="3">
+            <a:schemeClr val="accent1"/>
+          </a:fillRef>
+          <a:effectRef idx="2">
+            <a:schemeClr val="accent1"/>
+          </a:effectRef>
+          <a:fontRef idx="minor">
+            <a:schemeClr val="lt1"/>
+          </a:fontRef>
+        </p:style>
+        <p:txBody>
+          <a:bodyPr rtlCol="0" anchor="ctr" wrap="square" lIns="36576" rIns="36576" tIns="13716" bIns="13716">
+            <a:noAutofit/>
+          </a:bodyPr>
+          <a:lstStyle/>
+          <a:p>
+            <a:pPr algn="ctr">
+              <a:spcBef>
+                <a:spcPts val="0"/>
+              </a:spcBef>
+              <a:spcAft>
+                <a:spcPts val="150"/>
+              </a:spcAft>
+            </a:pPr>
+            <a:r>
+              <a:rPr sz="850" b="1">
+                <a:solidFill>
+                  <a:srgbClr val="E65100"/>
+                </a:solidFill>
+                <a:latin typeface="Calibri"/>
+              </a:rPr>
+              <a:t>retrieval reward unnecessary</a:t>
+            </a:r>
+            <a:r>
+              <a:rPr sz="830" b="0">
+                <a:solidFill>
+                  <a:srgbClr val="1F3247"/>
+                </a:solidFill>
+                <a:latin typeface="Calibri"/>
+              </a:rPr>
+              <a:t>  →  distil to clean GT text</a:t>
+            </a:r>
+          </a:p>
+          <a:p>
+            <a:pPr algn="ctr">
+              <a:spcBef>
+                <a:spcPts val="0"/>
+              </a:spcBef>
+              <a:spcAft>
+                <a:spcPts val="100"/>
+              </a:spcAft>
+            </a:pPr>
+            <a:r>
+              <a:rPr sz="850" b="1">
+                <a:solidFill>
+                  <a:srgbClr val="E65100"/>
+                </a:solidFill>
+                <a:latin typeface="Calibri"/>
+              </a:rPr>
+              <a:t>+1.22 pp Hit@5 (OHR-Bench)</a:t>
+            </a:r>
+          </a:p>
+        </p:txBody>
+      </p:sp>
+      <p:cxnSp>
+        <p:nvCxnSpPr>
+          <p:cNvPr id="47" name="Connector 46"/>
+          <p:cNvCxnSpPr/>
+          <p:nvPr/>
+        </p:nvCxnSpPr>
+        <p:spPr>
+          <a:xfrm>
+            <a:off x="4315968" y="1911095"/>
+            <a:ext cx="237744" cy="0"/>
+          </a:xfrm>
+          <a:prstGeom prst="line">
+            <a:avLst/>
+          </a:prstGeom>
+          <a:ln w="25400">
+            <a:solidFill>
+              <a:srgbClr val="6B7780"/>
             </a:solidFill>
             <a:tailEnd type="triangle" w="med" len="med"/>
           </a:ln>
@@ -4607,21 +5943,21 @@
       </p:cxnSp>
       <p:cxnSp>
         <p:nvCxnSpPr>
-          <p:cNvPr id="38" name="Connector 37"/>
+          <p:cNvPr id="48" name="Connector 47"/>
           <p:cNvCxnSpPr/>
           <p:nvPr/>
         </p:nvCxnSpPr>
         <p:spPr>
           <a:xfrm>
-            <a:off x="6007608" y="1216152"/>
-            <a:ext cx="329184" cy="0"/>
+            <a:off x="4315968" y="4800600"/>
+            <a:ext cx="237744" cy="0"/>
           </a:xfrm>
           <a:prstGeom prst="line">
             <a:avLst/>
           </a:prstGeom>
-          <a:ln w="20320">
+          <a:ln w="25400">
             <a:solidFill>
-              <a:srgbClr val="78909C"/>
+              <a:srgbClr val="6B7780"/>
             </a:solidFill>
             <a:tailEnd type="triangle" w="med" len="med"/>
           </a:ln>
@@ -4643,21 +5979,21 @@
       </p:cxnSp>
       <p:cxnSp>
         <p:nvCxnSpPr>
-          <p:cNvPr id="39" name="Connector 38"/>
+          <p:cNvPr id="49" name="Connector 48"/>
           <p:cNvCxnSpPr/>
           <p:nvPr/>
         </p:nvCxnSpPr>
         <p:spPr>
-          <a:xfrm>
-            <a:off x="8065008" y="1216152"/>
-            <a:ext cx="329184" cy="0"/>
+          <a:xfrm flipH="1">
+            <a:off x="2240280" y="3236976"/>
+            <a:ext cx="4389120" cy="237744"/>
           </a:xfrm>
           <a:prstGeom prst="line">
             <a:avLst/>
           </a:prstGeom>
-          <a:ln w="20320">
+          <a:ln w="25400">
             <a:solidFill>
-              <a:srgbClr val="78909C"/>
+              <a:srgbClr val="6B7780"/>
             </a:solidFill>
             <a:tailEnd type="triangle" w="med" len="med"/>
           </a:ln>
@@ -4677,523 +6013,6 @@
           </a:fontRef>
         </p:style>
       </p:cxnSp>
-      <p:sp>
-        <p:nvSpPr>
-          <p:cNvPr id="40" name="Rounded Rectangle 39"/>
-          <p:cNvSpPr/>
-          <p:nvPr/>
-        </p:nvSpPr>
-        <p:spPr>
-          <a:xfrm>
-            <a:off x="182880" y="1993392"/>
-            <a:ext cx="4480560" cy="1792224"/>
-          </a:xfrm>
-          <a:prstGeom prst="roundRect">
-            <a:avLst>
-              <a:gd name="adj" fmla="val 5000"/>
-            </a:avLst>
-          </a:prstGeom>
-          <a:solidFill>
-            <a:srgbClr val="E8F0FE"/>
-          </a:solidFill>
-          <a:ln w="13970">
-            <a:solidFill>
-              <a:srgbClr val="1565C0"/>
-            </a:solidFill>
-          </a:ln>
-          <a:effectLst/>
-        </p:spPr>
-        <p:style>
-          <a:lnRef idx="1">
-            <a:schemeClr val="accent1"/>
-          </a:lnRef>
-          <a:fillRef idx="3">
-            <a:schemeClr val="accent1"/>
-          </a:fillRef>
-          <a:effectRef idx="2">
-            <a:schemeClr val="accent1"/>
-          </a:effectRef>
-          <a:fontRef idx="minor">
-            <a:schemeClr val="lt1"/>
-          </a:fontRef>
-        </p:style>
-        <p:txBody>
-          <a:bodyPr rtlCol="0" anchor="ctr"/>
-          <a:lstStyle/>
-          <a:p>
-            <a:pPr algn="ctr"/>
-          </a:p>
-        </p:txBody>
-      </p:sp>
-      <p:sp>
-        <p:nvSpPr>
-          <p:cNvPr id="41" name="Rounded Rectangle 40"/>
-          <p:cNvSpPr/>
-          <p:nvPr/>
-        </p:nvSpPr>
-        <p:spPr>
-          <a:xfrm>
-            <a:off x="182880" y="1993392"/>
-            <a:ext cx="4480560" cy="310896"/>
-          </a:xfrm>
-          <a:prstGeom prst="roundRect">
-            <a:avLst>
-              <a:gd name="adj" fmla="val 10000"/>
-            </a:avLst>
-          </a:prstGeom>
-          <a:solidFill>
-            <a:srgbClr val="1565C0"/>
-          </a:solidFill>
-          <a:ln>
-            <a:noFill/>
-          </a:ln>
-          <a:effectLst/>
-        </p:spPr>
-        <p:style>
-          <a:lnRef idx="1">
-            <a:schemeClr val="accent1"/>
-          </a:lnRef>
-          <a:fillRef idx="3">
-            <a:schemeClr val="accent1"/>
-          </a:fillRef>
-          <a:effectRef idx="2">
-            <a:schemeClr val="accent1"/>
-          </a:effectRef>
-          <a:fontRef idx="minor">
-            <a:schemeClr val="lt1"/>
-          </a:fontRef>
-        </p:style>
-        <p:txBody>
-          <a:bodyPr rtlCol="0" anchor="ctr" wrap="square" lIns="27432" rIns="27432" tIns="27432" bIns="27432">
-            <a:noAutofit/>
-          </a:bodyPr>
-          <a:lstStyle/>
-          <a:p>
-            <a:pPr algn="ctr">
-              <a:spcBef>
-                <a:spcPts val="0"/>
-              </a:spcBef>
-              <a:spcAft>
-                <a:spcPts val="300"/>
-              </a:spcAft>
-            </a:pPr>
-            <a:r>
-              <a:rPr sz="1050" b="1">
-                <a:solidFill>
-                  <a:srgbClr val="FFFFFF"/>
-                </a:solidFill>
-                <a:latin typeface="Calibri"/>
-              </a:rPr>
-              <a:t>DIAGNOSE  —  locate the real fault</a:t>
-            </a:r>
-          </a:p>
-        </p:txBody>
-      </p:sp>
-      <p:sp>
-        <p:nvSpPr>
-          <p:cNvPr id="42" name="TextBox 41"/>
-          <p:cNvSpPr txBox="1"/>
-          <p:nvPr/>
-        </p:nvSpPr>
-        <p:spPr>
-          <a:xfrm>
-            <a:off x="256032" y="2350008"/>
-            <a:ext cx="4334256" cy="1371600"/>
-          </a:xfrm>
-          <a:prstGeom prst="rect">
-            <a:avLst/>
-          </a:prstGeom>
-          <a:noFill/>
-        </p:spPr>
-        <p:txBody>
-          <a:bodyPr wrap="square" anchor="t" lIns="36576" rIns="36576" tIns="36576" bIns="36576">
-            <a:noAutofit/>
-          </a:bodyPr>
-          <a:lstStyle/>
-          <a:p>
-            <a:pPr algn="l">
-              <a:spcBef>
-                <a:spcPts val="0"/>
-              </a:spcBef>
-              <a:spcAft>
-                <a:spcPts val="500"/>
-              </a:spcAft>
-            </a:pPr>
-            <a:r>
-              <a:rPr sz="950" b="1">
-                <a:solidFill>
-                  <a:srgbClr val="1565C0"/>
-                </a:solidFill>
-                <a:latin typeface="Calibri"/>
-              </a:rPr>
-              <a:t>C1  </a:t>
-            </a:r>
-            <a:r>
-              <a:rPr sz="950" b="0">
-                <a:solidFill>
-                  <a:srgbClr val="1F3247"/>
-                </a:solidFill>
-                <a:latin typeface="Calibri"/>
-              </a:rPr>
-              <a:t>Disconnect — parsers that look clean don’t retrieve. Boundary Clarity anti-correlates with retrieval (r = −0.81); parser choice alone swings Hit@1 2.8× (0.197 → 0.549).</a:t>
-            </a:r>
-          </a:p>
-          <a:p>
-            <a:pPr algn="l">
-              <a:spcBef>
-                <a:spcPts val="0"/>
-              </a:spcBef>
-              <a:spcAft>
-                <a:spcPts val="500"/>
-              </a:spcAft>
-            </a:pPr>
-            <a:r>
-              <a:rPr sz="950" b="1">
-                <a:solidFill>
-                  <a:srgbClr val="1565C0"/>
-                </a:solidFill>
-                <a:latin typeface="Calibri"/>
-              </a:rPr>
-              <a:t>C2  </a:t>
-            </a:r>
-            <a:r>
-              <a:rPr sz="950" b="0">
-                <a:solidFill>
-                  <a:srgbClr val="1F3247"/>
-                </a:solidFill>
-                <a:latin typeface="Calibri"/>
-              </a:rPr>
-              <a:t>Coverage (no retriever) — 20.2% of answers are absent from the parser output, constant across 8 chunkers → fix the parser before the retriever.</a:t>
-            </a:r>
-          </a:p>
-        </p:txBody>
-      </p:sp>
-      <p:sp>
-        <p:nvSpPr>
-          <p:cNvPr id="43" name="Rounded Rectangle 42"/>
-          <p:cNvSpPr/>
-          <p:nvPr/>
-        </p:nvSpPr>
-        <p:spPr>
-          <a:xfrm>
-            <a:off x="4800600" y="1993392"/>
-            <a:ext cx="2651760" cy="1792224"/>
-          </a:xfrm>
-          <a:prstGeom prst="roundRect">
-            <a:avLst>
-              <a:gd name="adj" fmla="val 5000"/>
-            </a:avLst>
-          </a:prstGeom>
-          <a:solidFill>
-            <a:srgbClr val="E7F5EA"/>
-          </a:solidFill>
-          <a:ln w="13970">
-            <a:solidFill>
-              <a:srgbClr val="2E7D32"/>
-            </a:solidFill>
-          </a:ln>
-          <a:effectLst/>
-        </p:spPr>
-        <p:style>
-          <a:lnRef idx="1">
-            <a:schemeClr val="accent1"/>
-          </a:lnRef>
-          <a:fillRef idx="3">
-            <a:schemeClr val="accent1"/>
-          </a:fillRef>
-          <a:effectRef idx="2">
-            <a:schemeClr val="accent1"/>
-          </a:effectRef>
-          <a:fontRef idx="minor">
-            <a:schemeClr val="lt1"/>
-          </a:fontRef>
-        </p:style>
-        <p:txBody>
-          <a:bodyPr rtlCol="0" anchor="ctr"/>
-          <a:lstStyle/>
-          <a:p>
-            <a:pPr algn="ctr"/>
-          </a:p>
-        </p:txBody>
-      </p:sp>
-      <p:sp>
-        <p:nvSpPr>
-          <p:cNvPr id="44" name="Rounded Rectangle 43"/>
-          <p:cNvSpPr/>
-          <p:nvPr/>
-        </p:nvSpPr>
-        <p:spPr>
-          <a:xfrm>
-            <a:off x="4800600" y="1993392"/>
-            <a:ext cx="2651760" cy="310896"/>
-          </a:xfrm>
-          <a:prstGeom prst="roundRect">
-            <a:avLst>
-              <a:gd name="adj" fmla="val 10000"/>
-            </a:avLst>
-          </a:prstGeom>
-          <a:solidFill>
-            <a:srgbClr val="2E7D32"/>
-          </a:solidFill>
-          <a:ln>
-            <a:noFill/>
-          </a:ln>
-          <a:effectLst/>
-        </p:spPr>
-        <p:style>
-          <a:lnRef idx="1">
-            <a:schemeClr val="accent1"/>
-          </a:lnRef>
-          <a:fillRef idx="3">
-            <a:schemeClr val="accent1"/>
-          </a:fillRef>
-          <a:effectRef idx="2">
-            <a:schemeClr val="accent1"/>
-          </a:effectRef>
-          <a:fontRef idx="minor">
-            <a:schemeClr val="lt1"/>
-          </a:fontRef>
-        </p:style>
-        <p:txBody>
-          <a:bodyPr rtlCol="0" anchor="ctr" wrap="square" lIns="27432" rIns="27432" tIns="27432" bIns="27432">
-            <a:noAutofit/>
-          </a:bodyPr>
-          <a:lstStyle/>
-          <a:p>
-            <a:pPr algn="ctr">
-              <a:spcBef>
-                <a:spcPts val="0"/>
-              </a:spcBef>
-              <a:spcAft>
-                <a:spcPts val="300"/>
-              </a:spcAft>
-            </a:pPr>
-            <a:r>
-              <a:rPr sz="1050" b="1">
-                <a:solidFill>
-                  <a:srgbClr val="FFFFFF"/>
-                </a:solidFill>
-                <a:latin typeface="Calibri"/>
-              </a:rPr>
-              <a:t>SELECT</a:t>
-            </a:r>
-          </a:p>
-        </p:txBody>
-      </p:sp>
-      <p:sp>
-        <p:nvSpPr>
-          <p:cNvPr id="45" name="TextBox 44"/>
-          <p:cNvSpPr txBox="1"/>
-          <p:nvPr/>
-        </p:nvSpPr>
-        <p:spPr>
-          <a:xfrm>
-            <a:off x="4873752" y="2350008"/>
-            <a:ext cx="2505456" cy="1371600"/>
-          </a:xfrm>
-          <a:prstGeom prst="rect">
-            <a:avLst/>
-          </a:prstGeom>
-          <a:noFill/>
-        </p:spPr>
-        <p:txBody>
-          <a:bodyPr wrap="square" anchor="t" lIns="36576" rIns="36576" tIns="36576" bIns="36576">
-            <a:noAutofit/>
-          </a:bodyPr>
-          <a:lstStyle/>
-          <a:p>
-            <a:pPr algn="l">
-              <a:spcBef>
-                <a:spcPts val="0"/>
-              </a:spcBef>
-              <a:spcAft>
-                <a:spcPts val="500"/>
-              </a:spcAft>
-            </a:pPr>
-            <a:r>
-              <a:rPr sz="950" b="1">
-                <a:solidFill>
-                  <a:srgbClr val="2E7D32"/>
-                </a:solidFill>
-                <a:latin typeface="Calibri"/>
-              </a:rPr>
-              <a:t>C3  </a:t>
-            </a:r>
-            <a:r>
-              <a:rPr sz="950" b="0">
-                <a:solidFill>
-                  <a:srgbClr val="1F3247"/>
-                </a:solidFill>
-                <a:latin typeface="Calibri"/>
-              </a:rPr>
-              <a:t>RCPS — rank parsers &amp; chunkers by what retrieval does, on a held-out Q–A probe. Retriever-averaged &amp; format-invariant. No training.</a:t>
-            </a:r>
-          </a:p>
-        </p:txBody>
-      </p:sp>
-      <p:sp>
-        <p:nvSpPr>
-          <p:cNvPr id="46" name="Rounded Rectangle 45"/>
-          <p:cNvSpPr/>
-          <p:nvPr/>
-        </p:nvSpPr>
-        <p:spPr>
-          <a:xfrm>
-            <a:off x="7589520" y="1993392"/>
-            <a:ext cx="2514600" cy="1792224"/>
-          </a:xfrm>
-          <a:prstGeom prst="roundRect">
-            <a:avLst>
-              <a:gd name="adj" fmla="val 5000"/>
-            </a:avLst>
-          </a:prstGeom>
-          <a:solidFill>
-            <a:srgbClr val="FFF3E0"/>
-          </a:solidFill>
-          <a:ln w="13970">
-            <a:solidFill>
-              <a:srgbClr val="E65100"/>
-            </a:solidFill>
-          </a:ln>
-          <a:effectLst/>
-        </p:spPr>
-        <p:style>
-          <a:lnRef idx="1">
-            <a:schemeClr val="accent1"/>
-          </a:lnRef>
-          <a:fillRef idx="3">
-            <a:schemeClr val="accent1"/>
-          </a:fillRef>
-          <a:effectRef idx="2">
-            <a:schemeClr val="accent1"/>
-          </a:effectRef>
-          <a:fontRef idx="minor">
-            <a:schemeClr val="lt1"/>
-          </a:fontRef>
-        </p:style>
-        <p:txBody>
-          <a:bodyPr rtlCol="0" anchor="ctr"/>
-          <a:lstStyle/>
-          <a:p>
-            <a:pPr algn="ctr"/>
-          </a:p>
-        </p:txBody>
-      </p:sp>
-      <p:sp>
-        <p:nvSpPr>
-          <p:cNvPr id="47" name="Rounded Rectangle 46"/>
-          <p:cNvSpPr/>
-          <p:nvPr/>
-        </p:nvSpPr>
-        <p:spPr>
-          <a:xfrm>
-            <a:off x="7589520" y="1993392"/>
-            <a:ext cx="2514600" cy="310896"/>
-          </a:xfrm>
-          <a:prstGeom prst="roundRect">
-            <a:avLst>
-              <a:gd name="adj" fmla="val 10000"/>
-            </a:avLst>
-          </a:prstGeom>
-          <a:solidFill>
-            <a:srgbClr val="E65100"/>
-          </a:solidFill>
-          <a:ln>
-            <a:noFill/>
-          </a:ln>
-          <a:effectLst/>
-        </p:spPr>
-        <p:style>
-          <a:lnRef idx="1">
-            <a:schemeClr val="accent1"/>
-          </a:lnRef>
-          <a:fillRef idx="3">
-            <a:schemeClr val="accent1"/>
-          </a:fillRef>
-          <a:effectRef idx="2">
-            <a:schemeClr val="accent1"/>
-          </a:effectRef>
-          <a:fontRef idx="minor">
-            <a:schemeClr val="lt1"/>
-          </a:fontRef>
-        </p:style>
-        <p:txBody>
-          <a:bodyPr rtlCol="0" anchor="ctr" wrap="square" lIns="27432" rIns="27432" tIns="27432" bIns="27432">
-            <a:noAutofit/>
-          </a:bodyPr>
-          <a:lstStyle/>
-          <a:p>
-            <a:pPr algn="ctr">
-              <a:spcBef>
-                <a:spcPts val="0"/>
-              </a:spcBef>
-              <a:spcAft>
-                <a:spcPts val="300"/>
-              </a:spcAft>
-            </a:pPr>
-            <a:r>
-              <a:rPr sz="1050" b="1">
-                <a:solidFill>
-                  <a:srgbClr val="FFFFFF"/>
-                </a:solidFill>
-                <a:latin typeface="Calibri"/>
-              </a:rPr>
-              <a:t>IMPROVE  (bounded)</a:t>
-            </a:r>
-          </a:p>
-        </p:txBody>
-      </p:sp>
-      <p:sp>
-        <p:nvSpPr>
-          <p:cNvPr id="48" name="TextBox 47"/>
-          <p:cNvSpPr txBox="1"/>
-          <p:nvPr/>
-        </p:nvSpPr>
-        <p:spPr>
-          <a:xfrm>
-            <a:off x="7662672" y="2350008"/>
-            <a:ext cx="2368296" cy="1371600"/>
-          </a:xfrm>
-          <a:prstGeom prst="rect">
-            <a:avLst/>
-          </a:prstGeom>
-          <a:noFill/>
-        </p:spPr>
-        <p:txBody>
-          <a:bodyPr wrap="square" anchor="t" lIns="36576" rIns="36576" tIns="36576" bIns="36576">
-            <a:noAutofit/>
-          </a:bodyPr>
-          <a:lstStyle/>
-          <a:p>
-            <a:pPr algn="l">
-              <a:spcBef>
-                <a:spcPts val="0"/>
-              </a:spcBef>
-              <a:spcAft>
-                <a:spcPts val="500"/>
-              </a:spcAft>
-            </a:pPr>
-            <a:r>
-              <a:rPr sz="950" b="1">
-                <a:solidFill>
-                  <a:srgbClr val="E65100"/>
-                </a:solidFill>
-                <a:latin typeface="Calibri"/>
-              </a:rPr>
-              <a:t>C4  </a:t>
-            </a:r>
-            <a:r>
-              <a:rPr sz="950" b="0">
-                <a:solidFill>
-                  <a:srgbClr val="1F3247"/>
-                </a:solidFill>
-                <a:latin typeface="Calibri"/>
-              </a:rPr>
-              <a:t>Best-of-K fidelity distillation: +1.22 pp Hit@5 (OHR-Bench). A matched control shows the retrieval reward is unnecessary.</a:t>
-            </a:r>
-          </a:p>
-        </p:txBody>
-      </p:sp>
     </p:spTree>
   </p:cSld>
   <p:clrMapOvr>

</xml_diff>

<commit_message>
paper: integrate Figure 1 overview into body; compress intro C1-C4; drop redundant protocol figure
Add the detailed 2x2 architecture as Figure 1 (full-width, paper's C1->C4 arc) and
lean on it: the four long intro bullets collapse to one compact paragraph pointing
to the figure (numbers live in the experiments). Drop the standalone RCPS-protocol
figure — its content is now Figure 1's C3 panel — and repoint the §3.1 reference.
Diagonal C2->C3 arc arrow replaced by a centred down arrow; figure exported to
vector PDF for \includegraphics. Body stays at 6pp (Limitations p7), 0 overfull.
</commit_message>
<xml_diff>
--- a/paper/figures/fig1_overview.pptx
+++ b/paper/figures/fig1_overview.pptx
@@ -5984,9 +5984,9 @@
           <p:nvPr/>
         </p:nvCxnSpPr>
         <p:spPr>
-          <a:xfrm flipH="1">
-            <a:off x="2240280" y="3236976"/>
-            <a:ext cx="4389120" cy="237744"/>
+          <a:xfrm>
+            <a:off x="4389120" y="3223260"/>
+            <a:ext cx="0" cy="265176"/>
           </a:xfrm>
           <a:prstGeom prst="line">
             <a:avLst/>

</xml_diff>